<commit_message>
updating with lab 4 powerpoint
</commit_message>
<xml_diff>
--- a/docs/labs/lab_4.pptx
+++ b/docs/labs/lab_4.pptx
@@ -5,7 +5,7 @@
     <p:sldMasterId id="2147483659" r:id="rId1"/>
   </p:sldMasterIdLst>
   <p:notesMasterIdLst>
-    <p:notesMasterId r:id="rId12"/>
+    <p:notesMasterId r:id="rId13"/>
   </p:notesMasterIdLst>
   <p:sldIdLst>
     <p:sldId id="258" r:id="rId2"/>
@@ -18,6 +18,7 @@
     <p:sldId id="262" r:id="rId9"/>
     <p:sldId id="263" r:id="rId10"/>
     <p:sldId id="264" r:id="rId11"/>
+    <p:sldId id="267" r:id="rId12"/>
   </p:sldIdLst>
   <p:sldSz cx="9144000" cy="5143500" type="screen16x9"/>
   <p:notesSz cx="6858000" cy="9144000"/>
@@ -760,184 +761,6 @@
 </inkml:ink>
 </file>
 
-<file path=ppt/ink/ink114.xml><?xml version="1.0" encoding="utf-8"?>
-<inkml:ink xmlns:inkml="http://www.w3.org/2003/InkML">
-  <inkml:definitions>
-    <inkml:context xml:id="ctx0">
-      <inkml:inkSource xml:id="inkSrc0">
-        <inkml:traceFormat>
-          <inkml:channel name="X" type="integer" min="-2.14748E9" max="2.14748E9" units="cm"/>
-          <inkml:channel name="Y" type="integer" min="-2.14748E9" max="2.14748E9" units="cm"/>
-          <inkml:channel name="F" type="integer" max="32767" units="dev"/>
-        </inkml:traceFormat>
-        <inkml:channelProperties>
-          <inkml:channelProperty channel="X" name="resolution" value="1000" units="1/cm"/>
-          <inkml:channelProperty channel="Y" name="resolution" value="1000" units="1/cm"/>
-          <inkml:channelProperty channel="F" name="resolution" value="0" units="1/dev"/>
-        </inkml:channelProperties>
-      </inkml:inkSource>
-      <inkml:timestamp xml:id="ts0" timeString="2026-10-21T09:29:14.962"/>
-    </inkml:context>
-    <inkml:brush xml:id="br0">
-      <inkml:brushProperty name="width" value="0.06" units="cm"/>
-      <inkml:brushProperty name="height" value="0.06" units="cm"/>
-    </inkml:brush>
-  </inkml:definitions>
-  <inkml:trace contextRef="#ctx0" brushRef="#br0">87 60 7724,'-4'-6'242,"-1"0"1,1 2 0,-2 2 0,0 2 0,1 6 0,3 4 0,2 8 313,2 6 0,2 5 0,3 8 1,0 7-207,2 5 0,-1 9 0,3 9 0,1 2-237,0 1 0,-1-4 0,-2-5 1,-2-4-35,0-5 0,-3-8 0,-1-5 1,0-6-236,-1-5 1,-1-5 0,-1-4 0,0-3-1067,0-3 948,0-3 1,0-7-1,-1-3 1,-1-6 75,0-5 1,-3-5-1,2-4 1,-2-4 97,1-1 1,-1-8 0,-1-6 0,-2-4 15,-1-5 0,2-3 1,-5-5-1,1-4-33,1-6 1,1-3 0,5-3 0,6 5 369,9 7 0,10 10 0,11 14 1,2 6 304,2 9 0,-6 10 0,0 8 0,-1 6 12,-1 6 0,2 7 0,-3 3 0,0 5-172,-3 2 0,-7 5 0,-4 3 0,-6 0-21,-4 0 1,-3-4 0,-2-2 0,-4-2-212,-5-2 0,-2-2 0,-8 0 0,-1-1-307,-3-2 1,0-1-1,-2-3 1,1-1-210,-1-1 0,3-4 0,0-3 0,1-3-481,1-1 0,-1-5 0,-1-4 1,0-3-733,-1-3 1,5-5 1562,0-2 0,0-4 0,3 0 0</inkml:trace>
-  <inkml:trace contextRef="#ctx0" brushRef="#br0" timeOffset="484">818 114 7687,'-6'-5'0,"-1"1"319,0 2 0,1 0 1,-2 2-1,0 0 408,0 0 1,-4 5-1,0 5 1,0 5-224,2 5 0,-2 6 1,3 6-1,1 5-176,3 5 1,4 0 0,5 0 0,6-5-158,4-4 1,3-3 0,5-7 0,1-5-10,1-6 1,-3-8 0,4-3 0,0-5-1,1-4 0,0-7 1,1-3-1,-1-1-339,-1-1 0,-3 0 0,-3-1 0,-5 0-320,-5 2 1,-4-1-1,-7-1 1,-2-2 264,-5 0 1,-6 0-1,-5-1 1,-2 0 117,-2 0 1,0-2 0,-2 3 0,2 0-64,2 3 0,4 4 0,3 4 0,3 4-779,3 1 0,3 4 230,2 6 1,1 0-1,4 6 726,1 1 0,1 1 0,4 2 0</inkml:trace>
-  <inkml:trace contextRef="#ctx0" brushRef="#br0" timeOffset="871">1377 41 7702,'-17'-3'238,"1"1"0,-2-1 1,0 0 709,-1 1 1,1 1 0,-1 1 0,3 1-124,-1 1 0,4 3 0,4 3 0,3 2-584,2 0 0,4 3 0,5 4 0,6-1-71,4 3 1,4 1-1,1 3 1,3 3 136,1 2 1,-3-2 0,-2-2 0,-3-2-66,-3 0 1,-2-2 0,-4 0 0,-3-2-411,-3-3 0,-6-3 0,-3-2 1,-3 0-307,-3-2 0,-4-1 0,0-1 0,-3-1-179,-1-3 1,-3-1 0,4-1-1,-1 0 89,2 0 0,2-3 1,0-2-1,3-1 13,3-1 1,0 1 0,4 0-1,3-1-1887,1 0 2438,3-3 0,1 0 0,0-3 0</inkml:trace>
-  <inkml:trace contextRef="#ctx0" brushRef="#br0" timeOffset="1184">1575 41 7643,'-22'0'0,"-1"-2"0,2-1 0,3 2 897,3 0 1,5 4 0,1 2 0,2 1-29,3 3 1,1 1-1,3 4 1,3 3-343,4 2 0,3 5 0,3 3 0,0 1-153,1 1 0,-1 1 0,-1-2 0,-1-2-234,-2-2 0,-4-2 0,-3-6 0,-3-2-190,-3-3 1,-1 1-1,-7-3 1,-2-3-285,0 0 0,-4-3 0,2 1 1,0-2-439,-1-1 0,4-1 0,2-1 0,0-1-243,0-2 0,-1-2 0,5-3 0,0 0-32,2-2 1,3 2 1046,0-1 0,1-2 0,1-1 0</inkml:trace>
-  <inkml:trace contextRef="#ctx0" brushRef="#br0" timeOffset="1518">1728 101 7647,'-6'3'331,"1"-2"0,1 2 1,-1 1 363,2 0 1,-3 0-1,2 4 1,-2 2 542,2 3 1,1 4 0,3 5 0,0 3-714,0 3 1,1 2-1,3 0 1,4-3-323,1-5 1,3-2 0,3-2-1,3-3-180,1-3 1,1-3 0,0-5 0,0-2-127,0-2 1,0 0-1,-1-3 1,-1-3-279,-3-5 0,-1-2 0,-4 0 0,-1 0-130,-1 0 0,-4-2 1,-2 1-1,-1-2-13,-1 1 0,-3-1 0,-3-2 0,-1-2 48,-2 1 1,-2-2 0,-1 0 0,0-2-171,-2 2 0,1 0 0,1 3 0,0 0-1341,1 2 1987,3 2 0,-2 1 0,3-1 0</inkml:trace>
-  <inkml:trace contextRef="#ctx0" brushRef="#br0" timeOffset="2166">2028 81 7649,'0'-7'1798,"0"0"1,0 3-383,0-1 0,0 5 1,0 0-909,0 6 0,0 4 0,0 4 0,0 3 86,3 2 0,-3 2 1,3 3-1,-1 2-396,0-1 0,3 1 1,-3 1-1,-1-3-233,0-2 1,-1-3-1,0-3 1,0 0-1463,0-3 0,0-3 77,0-4 0,-2-3 1,0-3 913,0-6 0,-1-2 0,1-2 0,0-2 319,2-1 1,0-1-1,2-1 1,1-3 236,1-1 0,-2-4 0,2-1 0,2 0 197,0 0 0,1 2 0,3 0 0,2 3 420,3 3 0,4 5 0,0 6 0,3 4 133,-1 2 1,2 6 0,-2 4 0,-1 4-325,-4 3 1,-5 3 0,0 3 0,-2 0-78,-3 2 1,-2-2 0,-4-4 0,0-1-313,0-1 1,-3-3-1,0-2 1,0-2-673,0-2 1,0-1 0,1-3-1161,-2 0 1,0-3 1026,-1-4 0,4-2 0,-1-3 0,1-2 227,1-2 0,0-2 1,0 0-1,0-3 292,0-2 0,2-4 1,0-3-1,1-1 86,0-2 1,0-2 0,4 1 0,0 3 285,0 3 0,2 4 0,2 6 1,1 4 399,-1 4 1,2 3 0,0 7 0,2 4 64,0 2 0,-3 3 0,0 2 0,-1 2 81,-1 4 0,-2-1 0,-1 4 0,-1-1-127,-2 0 0,-1-3 0,-3-2 1,0-2-319,0-1 1,0-1 0,0-4 0,0-2-910,0-2 0,0-2-1814,0-1 1,1-2-2600,1 0 5048,-1-4 0,5-5 0,-2-4 0</inkml:trace>
-  <inkml:trace contextRef="#ctx0" brushRef="#br0" timeOffset="2519">2791 54 7650,'-7'-10'85,"1"0"0,0 2 339,-1 1 1,0-1-1,0 5 1,-2-1 609,-2 2 1,-2 1-1,-1 1 1,-1 1-232,0 1 1,0 2 0,3 3 0,2 2-623,1 2 0,0 2 0,5-1 1,2 3-228,1 0 1,2 0 0,3 3 0,4 0-6,4-2 1,0 4 0,7-2 0,1 0 0,1 3 1,2-3 0,-4 1 0,-1-2 824,-3-1 0,-2 0 0,-2-3 0,-2-1-12,-4 0 1,-3 0 0,-5-3 0,-4-2-457,-3 1 1,-3-2-1,0 1 1,-2-1-400,-1-1 0,-1-2 1,0-3-1,1 0-887,0 0 0,0-1 1,3-1-1,0-3-891,-1-1 0,2-3 0,0-1 1870,4 1 0,-2-6 0,-1-2 0</inkml:trace>
-</inkml:ink>
-</file>
-
-<file path=ppt/ink/ink115.xml><?xml version="1.0" encoding="utf-8"?>
-<inkml:ink xmlns:inkml="http://www.w3.org/2003/InkML">
-  <inkml:definitions>
-    <inkml:context xml:id="ctx0">
-      <inkml:inkSource xml:id="inkSrc0">
-        <inkml:traceFormat>
-          <inkml:channel name="X" type="integer" min="-2.14748E9" max="2.14748E9" units="cm"/>
-          <inkml:channel name="Y" type="integer" min="-2.14748E9" max="2.14748E9" units="cm"/>
-          <inkml:channel name="F" type="integer" max="32767" units="dev"/>
-        </inkml:traceFormat>
-        <inkml:channelProperties>
-          <inkml:channelProperty channel="X" name="resolution" value="1000" units="1/cm"/>
-          <inkml:channelProperty channel="Y" name="resolution" value="1000" units="1/cm"/>
-          <inkml:channelProperty channel="F" name="resolution" value="0" units="1/dev"/>
-        </inkml:channelProperties>
-      </inkml:inkSource>
-      <inkml:timestamp xml:id="ts0" timeString="2026-10-21T09:29:37.894"/>
-    </inkml:context>
-    <inkml:brush xml:id="br0">
-      <inkml:brushProperty name="width" value="0.06" units="cm"/>
-      <inkml:brushProperty name="height" value="0.06" units="cm"/>
-    </inkml:brush>
-  </inkml:definitions>
-  <inkml:trace contextRef="#ctx0" brushRef="#br0">39 55 7920,'-5'-8'-56,"1"0"1,-2 0 0,2 2-1,-2 1 1643,0 0-763,3 0 0,-1 4-479,4 0 0,1 5 0,6 3 1,0 4-74,1 4 1,3 2-1,-1 3 1,2 3-19,2 2 0,-1 1 0,1 4 0,-1 1-28,-1 2 0,-1-1 0,-1 3 0,-2 1-70,-1 1 0,-2 1 0,-1-4 0,-2-5-160,-1-4 0,-1-7 0,-1-3 0,-1-3-174,-2 0 0,1-4 1,-1-2 7,-1-1 0,0-2 0,-1-1 1,0-2 43,3-2 1,-3-2 0,3-4 0,-1-2 73,-1-2 0,5-3 1,-3 0-1,0-3-7,2-3 0,-1 0 0,2-5 0,0-1-39,0-1 0,0 1 0,0-5 0,3-1 113,3-1 1,3 2 0,5 4 0,0 1 288,2 2 0,0 2 1,0 2-1,-1 6-5,0 4 0,1 2 0,-2 3 1,0 1 24,-2 1 1,0 0 0,0 3 0,0-1-237,-2-2 1,1 1 0,-2-2 0,1 2-335,-2 0 1,-1-1 0,-1 2 0,-1 0-799,-1-1 1,-1 2-379,-3-3 0,0 2-1190,0-2 2612,0 2 0,2-3 0,2 2 0</inkml:trace>
-  <inkml:trace contextRef="#ctx0" brushRef="#br0" timeOffset="667">762 133 7784,'2'-8'87,"-1"-3"1,2 3 0,-3-1 0,0 2 335,0-2 0,0 1 0,0 2 1,0 0 65,0 0 0,0 0 0,-1 1 0,-1 0-112,1 1 1,-4 1-1,1-2 1,-1 4-102,-1 0 0,-1 1 1,-1 0-1,-3 1-47,-2 0 0,-3 5 0,-4 6 0,-3 1 16,0 6 1,-1 5 0,0 6 0,1 4 86,0 3 0,1 6 0,4 2 0,6 1-54,2 1 0,6-4 0,3-2 1,3-6-348,4-6 1,4-5 0,5-9 0,0-3-265,2-3 1,2-5 0,2-2-1,1-2 63,1-2 0,-2-3 0,1-4 0,0-4-11,-3-2 0,0-1 0,-5-5 1,-2-1 269,-1-4 1,-4-1-1,0 0 1,-2 0 141,-3 0 0,-1 2 0,-1-1 1,0 2 173,0 2 1,-1 4 13,-1 4 1,2 7-1,-3 5 1,3 8 230,0 8 1,0 4 0,0 7 0,2 4 260,-1 3 1,2 2 0,-3 0-1,0 0-476,3-1 1,-3 1 0,5-5 0,0-3-776,3-5 0,-1-3 0,3-4 0,0-3-731,2-1 0,0-5 0,0-3 1,3-5-677,1-3 1,1-1 1846,1-5 0,0 1 0,0-4 0</inkml:trace>
-</inkml:ink>
-</file>
-
-<file path=ppt/ink/ink116.xml><?xml version="1.0" encoding="utf-8"?>
-<inkml:ink xmlns:inkml="http://www.w3.org/2003/InkML">
-  <inkml:definitions>
-    <inkml:context xml:id="ctx0">
-      <inkml:inkSource xml:id="inkSrc0">
-        <inkml:traceFormat>
-          <inkml:channel name="X" type="integer" min="-2.14748E9" max="2.14748E9" units="cm"/>
-          <inkml:channel name="Y" type="integer" min="-2.14748E9" max="2.14748E9" units="cm"/>
-          <inkml:channel name="F" type="integer" max="32767" units="dev"/>
-        </inkml:traceFormat>
-        <inkml:channelProperties>
-          <inkml:channelProperty channel="X" name="resolution" value="1000" units="1/cm"/>
-          <inkml:channelProperty channel="Y" name="resolution" value="1000" units="1/cm"/>
-          <inkml:channelProperty channel="F" name="resolution" value="0" units="1/dev"/>
-        </inkml:channelProperties>
-      </inkml:inkSource>
-      <inkml:timestamp xml:id="ts0" timeString="2026-10-21T09:29:40.993"/>
-    </inkml:context>
-    <inkml:brush xml:id="br0">
-      <inkml:brushProperty name="width" value="0.06" units="cm"/>
-      <inkml:brushProperty name="height" value="0.06" units="cm"/>
-    </inkml:brush>
-  </inkml:definitions>
-  <inkml:trace contextRef="#ctx0" brushRef="#br0">326 97 7824,'0'-6'-25,"0"0"1,0 0-1,-1 0-270,-1 0 0,1 0 0,-1 0 0,0 0 652,-1 0 0,1 0 0,0 0 179,-2 0 1,-1 0-159,-2 0 0,-1 2-143,-3 0 0,-1 2 0,-2 1 1,-3 0 122,-3 1 0,-4 5 0,1 1 0,-2 3-15,-1 4 1,4 4-1,2 4 1,2 6 55,2 1 1,1 6-1,5 1 1,2 3-98,3-1 0,5 2 0,2-1 0,4 0-258,4-1 0,2-7 0,2-5 0,0-5-177,2-2 0,-1-7 1,4 0-1,1-2-904,3-1 1,-1-2-1,1 0 1,2-1 1036,2-1 0,-1-3 0,1 1 0</inkml:trace>
-  <inkml:trace contextRef="#ctx0" brushRef="#br0" timeOffset="534">681 146 7829,'-9'-10'4,"0"2"0,1 2 201,0 2 1,0 1 0,-1 3 0,0 0 346,-3 0 0,2 4 0,1 3 0,-1 3-256,1 4 1,-1 5 0,-2 1 0,3 4 64,0 2 1,3 2 0,2 5-1,2 3-131,2 3 0,3 0 0,3-3 0,6-5-175,0-4 0,6-4 1,-3-8-1,3-3 54,0-6 1,0-3 0,2-5-1,2-3-354,1-2 0,-1-3 0,3-5 0,-3-3-25,-1-1 0,-2-6 1,-3 0-1,-3-1 136,-4 0 1,-4-3-1,-6 3 1,-2 1 391,-3 0 1,-6 2 0,-6 0 0,-6 1 114,-3 2 0,-3 0 1,1 3-1,1 0-168,4 3 1,3 4 0,6 3-1,1 2-286,4 3 1,4 2 0,3 2-978,3 2 1,3 1-1,3 1 1,2 1 1057,1 1 0,1-1 0,2 2 0</inkml:trace>
-  <inkml:trace contextRef="#ctx0" brushRef="#br0" timeOffset="983">1103 127 7812,'-3'-6'0,"-2"0"249,4 0 0,-4 0 1,2 1-1,0 1 0,-1 1 1,0 2 374,0-2 0,-2 1 0,-3 3 1,0 1-162,-2 2 1,-1 4 0,-2 3-1,-2 2-59,-1 3 0,-1 5 1,1 3-1,2 4 55,0 1 1,2 4 0,4 1 0,3 2-240,6 0 1,4-3 0,5-3-1,6-5-6,4-4 1,3-7-1,4-6 1,3-4-243,0-1 1,0-6 0,0-1 0,-4-4-280,-2-1 1,-1-6 0,-3 0-1,0-3-212,-2-3 0,-4 2 0,-5-3 0,-2 1 254,-2-1 0,-2 3 1,-7-1-1,-3-1 211,-2 1 1,-5 0 0,-1 1-1,-1 0-96,-1-2 0,0 4 0,2 4 0,2 2-58,1 3 1,4 2 0,1 3 0,2 3-515,2 3 0,1 3 1,3 2-1,1 2 722,1-1 0,4 5 0,3-1 0</inkml:trace>
-  <inkml:trace contextRef="#ctx0" brushRef="#br0" timeOffset="1516">1326 121 7804,'3'-12'477,"0"-1"0,1 1 285,1 3 1,-2 2 0,3 4 0,0 3 59,-3 3 0,3 6 0,-2 4 0,1 4-105,1 4 0,0 4 1,0-1-1,-1 3-105,-1 1 1,-2-2 0,1 2-1,0 1-220,-2 1 1,-1-3-1,0-1 1,0-1-159,0-1 1,0-3 0,-1-1-1,-2-4-413,0-4 0,-1 0 0,0-5-977,-1 1 0,4-5 488,-4 0 1,4-6 0,-1 0 0,1-3 194,1 0 0,0-3 1,1 0-1,1-3-32,-1-3 1,2 0-1,-1-4 1,1-3-150,1-2 0,2-4 0,-1 2 1,4-1 248,0 0 1,2 0 0,5 2 0,2 3 440,3 2 1,1 5-1,1 7 1,1 4-1,-3 5 0,-4 8 0,-1 5 1,-3 4 420,-3 2 0,-1 2 0,-2 4 0,-1 2 231,0-1 0,1 2 0,-2-4 0,2 1-107,1-1 0,5-4 0,1-3 0,3-4-396,1-4 0,3-1 0,1-6 1,3 0-79,-1-3 1,-1-3 0,-5-3 0,-1-3-146,-1-3 0,-1 0 1,-3 0-1,-3 0-386,0 0 0,-3 0 0,-2 0 0,0 0-163,-2 0 0,0 0 0,-2 3 0,0 0-532,0 0 0,-3 3 0,0-1 0,-3 3 1119,0 1 0,-3-4 0,0 1 0</inkml:trace>
-</inkml:ink>
-</file>
-
-<file path=ppt/ink/ink117.xml><?xml version="1.0" encoding="utf-8"?>
-<inkml:ink xmlns:inkml="http://www.w3.org/2003/InkML">
-  <inkml:definitions>
-    <inkml:context xml:id="ctx0">
-      <inkml:inkSource xml:id="inkSrc0">
-        <inkml:traceFormat>
-          <inkml:channel name="X" type="integer" min="-2.14748E9" max="2.14748E9" units="cm"/>
-          <inkml:channel name="Y" type="integer" min="-2.14748E9" max="2.14748E9" units="cm"/>
-          <inkml:channel name="F" type="integer" max="32767" units="dev"/>
-        </inkml:traceFormat>
-        <inkml:channelProperties>
-          <inkml:channelProperty channel="X" name="resolution" value="1000" units="1/cm"/>
-          <inkml:channelProperty channel="Y" name="resolution" value="1000" units="1/cm"/>
-          <inkml:channelProperty channel="F" name="resolution" value="0" units="1/dev"/>
-        </inkml:channelProperties>
-      </inkml:inkSource>
-      <inkml:timestamp xml:id="ts0" timeString="2026-10-21T09:31:36.835"/>
-    </inkml:context>
-    <inkml:brush xml:id="br0">
-      <inkml:brushProperty name="width" value="0.06" units="cm"/>
-      <inkml:brushProperty name="height" value="0.06" units="cm"/>
-    </inkml:brush>
-  </inkml:definitions>
-  <inkml:trace contextRef="#ctx0" brushRef="#br0">415 97 7703,'0'-13'104,"0"-2"0,-1 3 0,-3 0 0,-2 1 0,-5 1 0,-2 1 0,-4 3 0,-3 1 362,-2 3 1,-2 1 0,2 1-1,-1 1-27,1 1 0,3 3 0,2 4 0,4 2-128,2 2 0,3 3 0,2 1 0,2 1-201,1 0 1,1 0-1,4 0 1,1 1-35,5 1 0,6 1 0,2-1 0,5 2-9,4 0 0,1 1 1,6 2-1,1 3 80,-2 0 1,0 2 0,-11-3 0,-4 1 5,-5-1 1,-3-2 0,-7-3 0,-4-3-50,-5-3 1,-7-2 0,-4 0 0,-1-1-94,-4-2 0,0-1 1,-3-3-1,-1 0 59,-2-3 0,2-1 0,-1-3 0,3-1-411,3-1 1,4-2 0,0-4 0,-1 0-363,1-1 1,-1-1 0,8 1 0,0-3-220,3-1 1,2 0 0,3-1-1,5 1-1198,6 2 2120,5-2 0,6 2 0,3-3 0</inkml:trace>
-  <inkml:trace contextRef="#ctx0" brushRef="#br0" timeOffset="683">771 255 7682,'0'-7'222,"0"0"1,0 0-1,0 0 236,0 0 0,-3 0 0,0 1 0,0-1-71,0 0 1,-2 0 0,0 0 0,-1 0-35,0 0 0,-4 1 1,-2 0-1,-1 1-79,0 3 0,-4 1 1,-2 3-1,1 2-74,-1 5 0,0 9 1,3 6-1,2 5 10,1 8 1,6 7-1,3 6 1,2-1-106,3-3 1,5-2 0,6-7-1,3-4-12,3-7 0,4-8 0,1-10 0,-1-4-361,0-4 1,-2-3 0,0-7 0,-2-4-191,-5-4 1,0-4-1,-3-4 1,0 0 87,0-2 0,-3-1 0,-4-1 1,0 2 288,-1-1 1,-1 3 0,-2 1-1,-1 5 167,-3 3 0,-1 8 0,-1 6 0,1 5 508,-1 7 0,0 10 0,0 11 0,0 8 488,0 6 1,1 6 0,1 3 0,1 2-330,1 2 1,-2 1 0,0 4-1,-1-2-339,-1-6 1,3-3 0,2-12 0,1-1-415,1-6 1,5-4 0,3-9-1,2-5-548,-1-5 0,3-4 0,-1-6 0,0-3-393,1-3 0,-1-7 1,1-3-1,-1-1 403,2-3 1,-4-3 0,0 0 0,-2-1 273,-2 0 1,-2 2 0,-3-2 0,-1 0 127,-1 1 0,-5-3 0,-4 5 1,-3-1 60,-2 2 0,-1 0 1,-2 2-1,1 5 10,2 2 0,-1 6 0,2 4 0,0 1-556,2 1 1,5 1-1,6 1 621,1 3 0,7 1 0,2 1 0</inkml:trace>
-  <inkml:trace contextRef="#ctx0" brushRef="#br0" timeOffset="1166">1010 241 7068,'-2'-7'-273,"0"0"0,-3 2 0,2 2 0,0-1 667,0 0 1,0 3-1,2 0 498,-1 5 0,-3 5 1,2 10-1,0 7-366,-1 7 1,2 5 0,2 5 0,1 5-164,1 1 0,3-2 0,4-5 1,3-5-213,0-8 1,5-5 0,-1-9-1,-1-6 13,-1-5 0,0-9 0,0-5 0,-1-4 49,1-5 0,-3 0 0,-2-2 0,-2 0-33,-3-2 0,1 1 1,-2 0-1,-2 0-144,0 2 0,-3 2 1,-1-2-1,-1 0-398,-1-2 0,-4-3 1,0 2-1,1-1-459,0 0 0,0-1 1,0 3-1,2 3-1692,0 4 1,3 3 2512,1 3 0,4 2 0,2 4 0</inkml:trace>
-  <inkml:trace contextRef="#ctx0" brushRef="#br0" timeOffset="1467">1333 213 9705,'0'11'0,"1"4"764,1 4 0,-1 11 0,1 7 0,-1 4 73,2 3 1,-3 1-1,3-3 1,-3-4-417,0-2 0,0-9 0,1-9 0,1-4-975,0-2 0,2-2 0,-1-4-1086,1-1 1,-2-5 0,0-6 0,-1-1 69,-1-3 0,2-3 1570,0 0 0,0-4 0,-2-4 0</inkml:trace>
-  <inkml:trace contextRef="#ctx0" brushRef="#br0" timeOffset="1598">1305 152 7698,'-7'-8'0,"1"0"0,-1 1 0,0 6 0,3 1 108,4 4 0,4 2 1,5 2-1,1 0-108,0 1 0,2 3 0,2-1 0</inkml:trace>
-  <inkml:trace contextRef="#ctx0" brushRef="#br0" timeOffset="2051">1531 227 7683,'4'-3'435,"-1"1"23,-3-2 1,1 3 0,1 2 0,1 5 330,0 5 0,2 6 1,2 4-1,-1 6-251,1 3 0,0 5 0,0 1 0,0 1-190,0 1 1,-3-5-1,0-2 1,-1-4-146,-1-5 1,-2-3 0,0-4-299,0-3 0,0-4 1,0-4-153,-3-1 1,2-4 0,-3-4 0,0-3-33,1-1 1,1-4 0,0 0 0,1-3 306,1 1 1,0-2 0,0-2-1,0 0 95,0-1 1,0-4 0,0 1 0,0-2-189,0-3 1,0-3-1,1-3 1,1 0-294,3-1 1,1 4 0,3 2-1,0 1-271,3 3 1,-1 6-1,2 7 1,0 7-362,-1 4 0,1 6 1,-2 3-1,1 4 990,-1 2 0,0 4 0,-4 0 0</inkml:trace>
-  <inkml:trace contextRef="#ctx0" brushRef="#br0" timeOffset="2502">1737 248 7663,'0'-7'0,"0"0"-1035,0 0 1824,0 0 1,1 4-1,1 4 1,3 6-201,1 6 1,3 10-1,0 7 1,1 5-183,1 4 1,-2 1 0,0 2 0,-1-3 429,-2 0 0,0-5 1,-4-7-1,0-3-428,-2-3 0,0-4 0,0-3 0,0-4-849,0-3 78,0-3 0,0-4 1,0-5-1,-2-3-162,0-1 0,0-4 0,2 0 1,0-2 172,0 0 1,0-2-1,0 0 1,0 0 408,0-3 0,0 0 0,0-2 0,0-2 20,0-3 1,2 0 0,1-7 0,1 0-92,2 1 1,3 2 0,3 4 0,2 2-79,2 2 0,2 8 0,-2 3 0,0 5-298,-2 2 1,0 2 0,-1 3-1,1 0-1778,0 0 0,-3 0 2167,0 0 0,1 3 0,2 1 0</inkml:trace>
-</inkml:ink>
-</file>
-
-<file path=ppt/ink/ink118.xml><?xml version="1.0" encoding="utf-8"?>
-<inkml:ink xmlns:inkml="http://www.w3.org/2003/InkML">
-  <inkml:definitions>
-    <inkml:context xml:id="ctx0">
-      <inkml:inkSource xml:id="inkSrc0">
-        <inkml:traceFormat>
-          <inkml:channel name="X" type="integer" min="-2.14748E9" max="2.14748E9" units="cm"/>
-          <inkml:channel name="Y" type="integer" min="-2.14748E9" max="2.14748E9" units="cm"/>
-          <inkml:channel name="F" type="integer" max="32767" units="dev"/>
-        </inkml:traceFormat>
-        <inkml:channelProperties>
-          <inkml:channelProperty channel="X" name="resolution" value="1000" units="1/cm"/>
-          <inkml:channelProperty channel="Y" name="resolution" value="1000" units="1/cm"/>
-          <inkml:channelProperty channel="F" name="resolution" value="0" units="1/dev"/>
-        </inkml:channelProperties>
-      </inkml:inkSource>
-      <inkml:timestamp xml:id="ts0" timeString="2026-10-21T09:42:41.736"/>
-    </inkml:context>
-    <inkml:brush xml:id="br0">
-      <inkml:brushProperty name="width" value="0.05" units="cm"/>
-      <inkml:brushProperty name="height" value="0.05" units="cm"/>
-    </inkml:brush>
-  </inkml:definitions>
-  <inkml:trace contextRef="#ctx0" brushRef="#br0">62 218 24575,'16'0'0,"8"0"0,12 0 0,4 0 0,-3-1 0,-8-4 0,-6-2 0,-8-3 0,-5-1 0,-6-2 0,-3-1 0,0-4 0,-1-1 0,0 0 0,-1 1 0,-4 3 0,-3 2 0,-3 0 0,-3 4 0,-2 0 0,-2 2 0,-2 0 0,2 2 0,2 2 0,0 2 0,2 1 0,0 0 0,-1 0 0,0 0 0,1 0 0,2 1 0,1 3 0,2 3 0,-1 4 0,1 3 0,0 0 0,3 2 0,1 1 0,1-1 0,1 2 0,0-1 0,1 2 0,2-2 0,0 1 0,0 0 0,0 0 0,0 0 0,2-2 0,0 0 0,3-2 0,2 0 0,1 0 0,0-1 0,0-1 0,-2-1 0,1-1 0,0-1 0,0-2 0,0-1 0,1-1 0,-1 1 0,2-1 0,0 0 0,2-1 0,1 0 0,0-1 0,0-2 0,1-1 0,-1 0 0,0 0 0,0 0 0,1 0 0,1 0 0,2 0 0,1 0 0,-2 0 0,-1 0 0,-2 0 0,0 0 0,1 0 0,-1-1 0,0 0 0,-1-2 0,-1-1 0,-4 0 0,-3-2 0,-2-2 0,-1 4 0,0-1 0</inkml:trace>
-</inkml:ink>
-</file>
-
-<file path=ppt/ink/ink119.xml><?xml version="1.0" encoding="utf-8"?>
-<inkml:ink xmlns:inkml="http://www.w3.org/2003/InkML">
-  <inkml:definitions>
-    <inkml:context xml:id="ctx0">
-      <inkml:inkSource xml:id="inkSrc0">
-        <inkml:traceFormat>
-          <inkml:channel name="X" type="integer" min="-2.14748E9" max="2.14748E9" units="cm"/>
-          <inkml:channel name="Y" type="integer" min="-2.14748E9" max="2.14748E9" units="cm"/>
-          <inkml:channel name="F" type="integer" max="32767" units="dev"/>
-        </inkml:traceFormat>
-        <inkml:channelProperties>
-          <inkml:channelProperty channel="X" name="resolution" value="1000" units="1/cm"/>
-          <inkml:channelProperty channel="Y" name="resolution" value="1000" units="1/cm"/>
-          <inkml:channelProperty channel="F" name="resolution" value="0" units="1/dev"/>
-        </inkml:channelProperties>
-      </inkml:inkSource>
-      <inkml:timestamp xml:id="ts0" timeString="2026-10-21T09:42:43.086"/>
-    </inkml:context>
-    <inkml:brush xml:id="br0">
-      <inkml:brushProperty name="width" value="0.05" units="cm"/>
-      <inkml:brushProperty name="height" value="0.05" units="cm"/>
-    </inkml:brush>
-  </inkml:definitions>
-  <inkml:trace contextRef="#ctx0" brushRef="#br0">0 1 24575,'0'21'0,"0"24"0,0-7 0,0 5 0,0 8 0,0 3 0,0 5 0,0-1 0,0-2 0,0-3 0,0-10 0,0-1 0,0-3 0,0 0 0,0 26 0,0-2 0,0 3 0,2-3 0,2 0 0,2-6 0,1-10 0,-1-10 0,-1-10 0,-2-8 0,0-4 0,1-5 0,-1-2 0,-2-8 0,-4-7 0,-12-18 0,8 12 0,-6-7 0</inkml:trace>
-</inkml:ink>
-</file>
-
 <file path=ppt/ink/ink12.xml><?xml version="1.0" encoding="utf-8"?>
 <inkml:ink xmlns:inkml="http://www.w3.org/2003/InkML">
   <inkml:definitions>
@@ -962,258 +785,6 @@
     </inkml:brush>
   </inkml:definitions>
   <inkml:trace contextRef="#ctx0" brushRef="#br0">30 30 7754,'-6'-4'267,"0"0"1,0 0-22,0 1 1,3-1-710,1 2 463,2 2 0,2-6 0,1 3 0</inkml:trace>
-</inkml:ink>
-</file>
-
-<file path=ppt/ink/ink120.xml><?xml version="1.0" encoding="utf-8"?>
-<inkml:ink xmlns:inkml="http://www.w3.org/2003/InkML">
-  <inkml:definitions>
-    <inkml:context xml:id="ctx0">
-      <inkml:inkSource xml:id="inkSrc0">
-        <inkml:traceFormat>
-          <inkml:channel name="X" type="integer" min="-2.14748E9" max="2.14748E9" units="cm"/>
-          <inkml:channel name="Y" type="integer" min="-2.14748E9" max="2.14748E9" units="cm"/>
-          <inkml:channel name="F" type="integer" max="32767" units="dev"/>
-        </inkml:traceFormat>
-        <inkml:channelProperties>
-          <inkml:channelProperty channel="X" name="resolution" value="1000" units="1/cm"/>
-          <inkml:channelProperty channel="Y" name="resolution" value="1000" units="1/cm"/>
-          <inkml:channelProperty channel="F" name="resolution" value="0" units="1/dev"/>
-        </inkml:channelProperties>
-      </inkml:inkSource>
-      <inkml:timestamp xml:id="ts0" timeString="2026-10-21T09:29:53.542"/>
-    </inkml:context>
-    <inkml:brush xml:id="br0">
-      <inkml:brushProperty name="width" value="0.06" units="cm"/>
-      <inkml:brushProperty name="height" value="0.06" units="cm"/>
-    </inkml:brush>
-  </inkml:definitions>
-  <inkml:trace contextRef="#ctx0" brushRef="#br0">386 99 7706,'0'-7'-4,"0"-2"0,0 5 1,0-1 213,0-1 0,0 1 0,0 1 213,0-2 1,0-1 0,0-1-222,-3 1 1,-1 0-1,-4 1 1,1 2 5,-1 1 1,-3-3 0,-2 3-1,-2 2-43,-3 0 1,-3 1-1,-6 1 1,-2 3-91,-2 3 1,0 2 0,2 5 0,2 4 70,1 0 1,1 3-1,6 1 1,4 1 71,4 3 0,6 2 1,2 5-1,3 2 43,3 2 1,2 0 0,7-1 0,5-4-46,1 0 1,6-4 0,4-1-1,1-6-190,2-4 1,2-1-1,3-6 1,0-2-298,0-2 1,-6 0 0,-6-3-1,-3-2-421,-6 0 0,-1-1 0,-4 0-246,-1 0 0,0-3 0,-3-2 938,0-2 0,0-4 0,-2-1 0</inkml:trace>
-  <inkml:trace contextRef="#ctx0" brushRef="#br0" timeOffset="1303">539 99 8476,'-4'-7'123,"2"0"0,-2 1-138,1 1 1,0 4 0,4 1 0,2 6 731,2 5 0,4 6 0,2 7 0,0 4-357,3 4 0,-2 6 0,1 2 0,-1 4-222,0 3 0,2-1 1,-4 0-1,-2-4-143,-2-3 1,-2-6 0,-2-9 0,0-3-215,0-6 0,-1 0 0,-2-6 108,-2-3 1,3-2 0,-3-7 0,3-2 201,0-2 1,0-3 0,0-4-1,0-3-24,3-3 1,1-4 0,3-3-1,-1 1-24,-2 0 0,1-3 0,1 2 0,-1-4-327,1-2 0,1 1 0,0-2 1,1-1-26,-1 0 1,3 4 0,1 1 0,1 7 124,-2 4 1,1 7 0,-1 4-1,3 3-59,1 2 1,-1 1 0,0 2-1,-1 2-124,0 0 1,2 3 0,-4-1 0,-1-1-2,0 1 1,-2 1 0,1 0 0,-2 0 279,0 0 1,-3-3 0,-3 4-1,0 0 247,0 0 1,0 2 0,0 0 0,-1 2 627,-1 3 0,-3 5 1,-2 3-1,1 4 60,2 5 0,1 4 0,-1 4 0,0 1-257,3 1 0,3 0 1,4 1-1,5-5-292,4-5 0,3-5 0,6-5 0,0-7-187,1-4 1,1-4-1,0-8 1,2-3-227,2-5 0,0-6 0,-1-4 0,-1-1-525,-3-3 1,-2 0 0,-2-2-1,-5-1 213,-2 0 0,-7 0 0,-4 2 1,-4-1 260,-4-1 0,-8-3 0,-10-3 0,-5 1 309,-3 1 1,-4 4 0,-3 2-1,0 4 302,0 3 0,7 9 0,4 4 0,6 4-232,6 1 1,1 6 0,4 2 0,3 2-785,4 1 0,2 0 0,1-2 0,0 2-120,0-2 1,6-2 0,2-1 0,1-1 37,2 1 0,-2-3 1,3 0-1,-1-2 390,1-1 0,-1 0 0,2 0 0,1-1 353,2-2 0,1 0 1,2-6-1,1 2 330,3-1 1,5-1 0,0-2 0,1 2 220,2 1 0,-4 3 0,0 3 1,0 1-22,-3 1 0,-1 1 1,-3 1-1,-3 4-375,0 0 0,-3 6 0,-1 3 1,-4 2 77,-3 2 1,-3 5 0,-3 4-1,-1 2 78,-1 3 0,-2-1 0,-1-1 0,0-2 125,2-4 1,-2-2 0,3-2-1,3-5-269,3-2 0,4-4 1,2-5-1,4-2-275,2-3 1,1 0 0,0-3-1,-1-3-344,-1-3 0,0-3 0,0-3 0,0 0-276,-3 0 0,-1-2 1,-5 1-1,-1-3 207,0-1 1,-1 4 0,-1-1 0,0 3 288,-1 4 1,1 6 0,-2 4 385,1 4 0,0 9 0,2 3 1,1 3 298,-1 2 0,1 0 0,3 0 1,1-2-539,2 0 0,3-2 1,0-3-1,4-4-389,2-5 1,0-4 0,2-4 0,-1-4 8,-1-4 1,-4-4-1,-1-7 1,-4-2 338,-2-2 1,-5-2-1,-1-2 1,-5-1 438,-2-2 1,-2-1 0,-7-2-1,0 5 143,1 1 1,-1 6 0,3 3 0,0 4-698,2 4 1,-2 2-1,0 4-965,1 2 1,3 3 0,4 4-1635,1 3 2750,1 2 0,3 1 0,2-1 0</inkml:trace>
-</inkml:ink>
-</file>
-
-<file path=ppt/ink/ink121.xml><?xml version="1.0" encoding="utf-8"?>
-<inkml:ink xmlns:inkml="http://www.w3.org/2003/InkML">
-  <inkml:definitions>
-    <inkml:context xml:id="ctx0">
-      <inkml:inkSource xml:id="inkSrc0">
-        <inkml:traceFormat>
-          <inkml:channel name="X" type="integer" min="-2.14748E9" max="2.14748E9" units="cm"/>
-          <inkml:channel name="Y" type="integer" min="-2.14748E9" max="2.14748E9" units="cm"/>
-          <inkml:channel name="F" type="integer" max="32767" units="dev"/>
-        </inkml:traceFormat>
-        <inkml:channelProperties>
-          <inkml:channelProperty channel="X" name="resolution" value="1000" units="1/cm"/>
-          <inkml:channelProperty channel="Y" name="resolution" value="1000" units="1/cm"/>
-          <inkml:channelProperty channel="F" name="resolution" value="0" units="1/dev"/>
-        </inkml:channelProperties>
-      </inkml:inkSource>
-      <inkml:timestamp xml:id="ts0" timeString="2026-10-21T09:30:05.559"/>
-    </inkml:context>
-    <inkml:brush xml:id="br0">
-      <inkml:brushProperty name="width" value="0.06" units="cm"/>
-      <inkml:brushProperty name="height" value="0.06" units="cm"/>
-    </inkml:brush>
-  </inkml:definitions>
-  <inkml:trace contextRef="#ctx0" brushRef="#br0">0 275 7967,'0'-12'1077,"0"3"-676,0 0 0,0 7 0,2 1 0,2 5-88,5 4 0,2 6 0,3 8 0,0 4-149,3 5 1,0 2 0,3 8 0,0 2-49,1 5 1,-1 0 0,2 0 0,-4 0-15,-4-2 1,-5-1-1,-2-6 1,-1-1-4,-3-3 0,-2-7 0,-1-8 0,0-1-105,0-3 1,-6-3-134,-2-4 1,-3-5-1,2-8 1,1-5-30,2-2 1,0-4 0,3-3 0,-1-3 69,1-4 1,0-6 0,0 1-1,-1-1 20,1-1 1,1-2 0,2-5 0,0 0 115,0 0 1,2 0 0,2-1 0,4 1-17,-1 0 0,6-1 0,-2 3 0,6 3-293,-1 8 1,4 1-1,0 8 1,3 2 107,-2 5 0,-3 4 1,2 6-1,0 1-1063,0 4 1,-3-2 1225,0 6 0,-2-1 0,-2 6 0</inkml:trace>
-  <inkml:trace contextRef="#ctx0" brushRef="#br0" timeOffset="416">655 354 7842,'-13'-13'684,"0"4"1,0 2-346,0 1 1,0 2 0,0 5 0,-1 3-38,2 5 0,-2 6 1,1 5-1,0 8-112,0 4 1,0 7 0,1 7 0,3 0-4,5 4 0,3 1 0,2-1 1,3-1-18,5-6 1,9-4 0,3-4 0,4-5-31,1-7 0,7-10 0,0-9 0,3-4-214,3-4 0,-6-5 0,5-10 0,-5-6-132,-4-4 1,-3-7 0,-5 1 0,-8-3 27,-8-2 0,-3 6 0,-4-1 0,-3-1 71,-8-3 1,-3 6 0,-9 3 0,-3 2-66,1 2 0,-3 4 0,1 3 0,-1 3-165,1 4 1,1 8 0,2-1 0,0 5-309,-1 5 1,7 7-1,1 7 1,2-1 644,-1 1 0,1 10 0,4-1 0</inkml:trace>
-  <inkml:trace contextRef="#ctx0" brushRef="#br0" timeOffset="883">917 0 7662,'-7'2'1792,"2"4"-1624,4 7 1,1 9 0,0 11 0,1 10 481,4 6 0,1 6 1,4 12-1,-3 2-581,-1 0 0,3 1 0,-4-6 0,1-4-268,0-8 0,-1-11 0,-5-12 0,0-4-291,0-3 0,0-10 265,0 0 1,0-9 0,0-3-1,1-7 110,3-4 0,-2-9 0,2-2 0,-1-4 81,2-4 0,-4 1 0,5-6 0,-1-1 112,4-3 1,-1 0 0,0 0 0,3 1 217,0 4 1,4 3 0,2 11 0,6 5 307,7 5 1,-1 8 0,5 4 0,2 9-142,-3 9 1,3 13 0,-5 4 0,-3 6-106,-5-1 1,-6-2 0,-8 0-1,-5-1-183,-2 1 1,-9-3 0,-8-1 0,-8-6-219,-7-3 0,-7 0 0,-1-3 0,-3-2-385,4-5 0,-3-6 1,5-4-1,-1 0-33,1 1 0,3-5 0,6 0 0,1-5-262,3-2 0,3-6 0,6 1 1,2-3-561,2-1 0,-1-1 1283,5-4 0,7-2 0,5-7 0</inkml:trace>
-  <inkml:trace contextRef="#ctx0" brushRef="#br0" timeOffset="1099">1337 407 7662,'12'-2'524,"2"-2"0,-1 2 0,-1-2 0,2 4 10,-1 4 0,0 5 1,0 8-1,0 7-82,0 5 0,-1 4 0,-2 8 1,-3 1-305,-1 2 0,-1 4 0,-5-4 1,0-2-513,0-2 1,0-7 0,0-7-1,0-6-1526,0-1 1890,0-10 0,-6 2 0,-2-11 0</inkml:trace>
-  <inkml:trace contextRef="#ctx0" brushRef="#br0" timeOffset="1232">1337 315 7662,'-8'-7'607,"2"1"0,6 6 1</inkml:trace>
-  <inkml:trace contextRef="#ctx0" brushRef="#br0" timeOffset="1733">1637 393 8392,'8'2'980,"-4"2"1,-1 5-498,2 2 1,-4 8 0,3 4 0,-1 8 21,2 9 1,-4 5-1,4 7 1,-4 1-260,-1-1 1,0-6 0,0-2 0,0-3-219,0-2 0,2-7 0,1-6-301,0-7 0,3-10-39,-1-4 0,-2-10 0,5-5 1,1-6 46,-1-6 0,3-4 0,-2-3 0,1-2-6,-1 2 1,3-4-1,-6-3 1,3-1 11,0-2 1,0-5 0,4-1 0,1-2 175,4-2 0,-2 5 0,6 4 0,1 10 428,2 7 0,0 10 1,-2 10-1,-3 7-108,-1 10 0,-3 10 0,-6 11 0,-1 5 268,2 3 0,-6 2 0,-1 5 0,-1-4 66,2-1 0,-2-1 0,4-5 1,0-1-280,1-3 0,-1-7 0,3-8 1,-1-1-325,1-3 1,3-7-1,3-5 1,3-2-523,2-2 0,0-2 0,6-2 0,-2-5 554,1-3 0,7-6 0,0-3 0</inkml:trace>
-</inkml:ink>
-</file>
-
-<file path=ppt/ink/ink122.xml><?xml version="1.0" encoding="utf-8"?>
-<inkml:ink xmlns:inkml="http://www.w3.org/2003/InkML">
-  <inkml:definitions>
-    <inkml:context xml:id="ctx0">
-      <inkml:inkSource xml:id="inkSrc0">
-        <inkml:traceFormat>
-          <inkml:channel name="X" type="integer" min="-2.14748E9" max="2.14748E9" units="cm"/>
-          <inkml:channel name="Y" type="integer" min="-2.14748E9" max="2.14748E9" units="cm"/>
-          <inkml:channel name="F" type="integer" max="32767" units="dev"/>
-        </inkml:traceFormat>
-        <inkml:channelProperties>
-          <inkml:channelProperty channel="X" name="resolution" value="1000" units="1/cm"/>
-          <inkml:channelProperty channel="Y" name="resolution" value="1000" units="1/cm"/>
-          <inkml:channelProperty channel="F" name="resolution" value="0" units="1/dev"/>
-        </inkml:channelProperties>
-      </inkml:inkSource>
-      <inkml:timestamp xml:id="ts0" timeString="2026-10-21T09:30:20.724"/>
-    </inkml:context>
-    <inkml:brush xml:id="br0">
-      <inkml:brushProperty name="width" value="0.06" units="cm"/>
-      <inkml:brushProperty name="height" value="0.06" units="cm"/>
-    </inkml:brush>
-  </inkml:definitions>
-  <inkml:trace contextRef="#ctx0" brushRef="#br0">7 554 7709,'-4'-4'448,"4"0"0,-2 2 0,5-1 212,8 2 1,7 0 0,12 0-1,3 0-472,5-2 0,2-3 0,2 3 0,0-1-848,1-2 1,1 1 0,1 1 659,-5-2 0,1-2 0,-5 1 0</inkml:trace>
-  <inkml:trace contextRef="#ctx0" brushRef="#br0" timeOffset="533">360 32 7688,'-3'-5'-79,"-3"3"1,3 1-1,-2 2 199,2 1 1,0 6 0,4 6 0,1 5 693,0 6 1,4 8 0,0 11-1,0 8-365,2 8 1,-4 2 0,-1 5 0,-3-1-276,0 0 1,-2-1 0,-2-7-1,1-7-365,0-10 1,0-7-1,3-7 1,0-3-576,0-3 1,1-4 0,1 0 765,1-3 0,6-3 0,0-4 0</inkml:trace>
-  <inkml:trace contextRef="#ctx0" brushRef="#br0" timeOffset="1153">621 1 7688,'-4'3'504,"2"3"1,1 4 132,1 3 1,0 9 0,1 7 0,1 11-211,3 7 1,2 9-1,0 4 1,-2 2-122,-2 3 0,0-5 0,0-5 0,-2-2-106,0-5 1,-1-5 0,0-5 0,-1-7-72,-1-5 1,1-5 0,-2-3-1,3-3-71,0-2 0,0 1-287,0-4 0,0-3 10,3-5 0,1-7 1,3-3-1,-1-4-109,-1-4 1,0-1 0,3-3 0,-1-2-239,2 1 0,-5-4 1,2-3-1,2-3 201,1-4 1,3 2 0,-2-2 0,3 0 311,1 0 0,4 7 0,0 2 0,-1 8 39,-1 8 1,0 3-1,-1 9 1,0 6 423,-2 7 1,-5 9-1,-4 5 1,-1 5 250,0 4 1,-3 0 0,0 3 0,1-2 62,1 0 1,-1-3 0,3-2 0,0-2-300,0-5 0,1-3 1,0-4-1,2-2-424,2-2 1,0-4 0,3-5 0,0-4-1202,0-1 0,1-4 0,1 0 1200,-1-3 0,2-5 0,-3-2 0</inkml:trace>
-</inkml:ink>
-</file>
-
-<file path=ppt/ink/ink123.xml><?xml version="1.0" encoding="utf-8"?>
-<inkml:ink xmlns:inkml="http://www.w3.org/2003/InkML">
-  <inkml:definitions>
-    <inkml:context xml:id="ctx0">
-      <inkml:inkSource xml:id="inkSrc0">
-        <inkml:traceFormat>
-          <inkml:channel name="X" type="integer" min="-2.14748E9" max="2.14748E9" units="cm"/>
-          <inkml:channel name="Y" type="integer" min="-2.14748E9" max="2.14748E9" units="cm"/>
-          <inkml:channel name="F" type="integer" max="32767" units="dev"/>
-        </inkml:traceFormat>
-        <inkml:channelProperties>
-          <inkml:channelProperty channel="X" name="resolution" value="1000" units="1/cm"/>
-          <inkml:channelProperty channel="Y" name="resolution" value="1000" units="1/cm"/>
-          <inkml:channelProperty channel="F" name="resolution" value="0" units="1/dev"/>
-        </inkml:channelProperties>
-      </inkml:inkSource>
-      <inkml:timestamp xml:id="ts0" timeString="2026-10-21T09:30:24.707"/>
-    </inkml:context>
-    <inkml:brush xml:id="br0">
-      <inkml:brushProperty name="width" value="0.06" units="cm"/>
-      <inkml:brushProperty name="height" value="0.06" units="cm"/>
-    </inkml:brush>
-  </inkml:definitions>
-  <inkml:trace contextRef="#ctx0" brushRef="#br0">16 254 7742,'-3'-5'406,"0"0"1,-1-1 6,1-1 0,0 3 0,4 4 0,2 3-141,2 4 1,3 2 0,1 8-1,2 1-47,1 6 1,0 3 0,1 5-1,-2 2-41,0 2 1,-3 2 0,3 2 0,-4-2-23,-1-1 1,-3-7-1,-3 0 1,0-4-129,0-4 1,0-3-1,0-6 1,-1-3-395,-1-4 333,-3 0 0,-2-9 1,2-3-1,3-4 1,1-5 1,1 0 0,0-2 0,0-1 28,0-2 1,0-2 0,0 1-1,0 1-37,0-2 0,0 1 0,1-3 0,0-1-78,2-1 1,2 0 0,-1 4 0,0-2-244,2 1 0,2 0 0,1 1 0,2 3-199,1 3 1,-2 4 0,4 4 0,1-1 16,2 1 1,4 0 0,-2 4 0,0 1 536,-1-1 0,3-2 0,-1 3 0</inkml:trace>
-  <inkml:trace contextRef="#ctx0" brushRef="#br0" timeOffset="348">400 246 8055,'-5'5'0,"-1"0"256,-3-2 0,0 4 0,5 0 0,-2 4 224,-1 4 0,0 3 0,2 7 0,2 4 21,2 4 1,1 1-1,1 5 1,2-1-232,2-3 1,5-4 0,3-7-1,2-2-152,0-4 1,1-3 0,-2-3 0,-1-4-15,0-5 1,-2-2-1,1-2 1,-1-1-2,-2-3 1,-1-3 0,0-3-1,-1-4-45,-2-1 1,2-5 0,-3 2 0,0-1-70,-1-1 1,-2 1 0,-1 0-1,0-1-87,0-2 0,0 2 1,0-1-1,-1 2-266,-2-2 0,-1-3 1,-4 0-1,1 4 45,-1 2 1,3 2 0,1 2 0,1 0-1064,0 3 0,3 0 551,0 5 0,3 2 1,3 3 830,0 1 0,5 1 0,1 0 0</inkml:trace>
-  <inkml:trace contextRef="#ctx0" brushRef="#br0" timeOffset="667">876 162 8000,'-12'0'0,"-1"0"549,-2 0 0,-1 1 0,5 1 0,-1 3 98,2 2 1,2 7 0,4 2 0,1 4-219,4 4 0,2 2 0,6 5 0,0 3-102,2 2 0,1 2 0,-4-1 0,-2-1-176,-1-3 1,-3-5 0,-2-3 0,-1-4-171,-2-3 0,-4-4 0,-3-2 0,-2-1-264,-2-2 0,-1-4 1,0-2-1,-1-2-400,-2-1 1,1 0-1,-1-1 1,3-2-472,3-2 1,1-2 0,6-4 1153,3-2 0,1-5 0,1-1 0</inkml:trace>
-  <inkml:trace contextRef="#ctx0" brushRef="#br0" timeOffset="1117">984 0 8167,'-3'9'1734,"1"2"1,0 5-1004,1 7 1,1 7 0,0 6-1,1 4-428,2 4 1,0 4 0,3 0 0,-2 0-164,0-1 0,-2-4 1,-2-3-1,0-4-167,0-2 0,0-9 0,-1-6 0,0-3 96,-2-3 0,1-7-377,2 2 0,0-7 1,2-1-1,2-6-268,0-3 1,1-8-1,3 1 1,-1-3 174,1-2 0,-1-5 1,2-2-1,-2-2 228,1-1 1,-1-2 0,1-1 0,0 0 202,-1-1 1,4 3-1,-1 5 1,2 4 386,3 4 1,-3 7 0,2 5 0,0 4-85,0 5 1,0 5-1,1 7 1,0 4 248,-2 5 0,0 1 0,-4 5 1,-1 1 22,-2 3 0,-4 3 0,0 0 0,-1-2-145,-1-3 1,-3-2 0,-2-4-1,0-2-688,0-1 0,3-6 0,-1-1-1848,0-3 263,2-4 1,-1-7-1,3-4 1813,1-6 0,4-3 0,-1-3 0</inkml:trace>
-  <inkml:trace contextRef="#ctx0" brushRef="#br0" timeOffset="1550">1468 385 7069,'-8'15'0,"2"1"123,0-1 0,0-3 1,3 0-1,3 0 966,5-3 1,0 0-1,6-3 1,1 0-656,0-4 0,2-1 0,0-2 1,1-1-385,1-4 0,2-1 1,-1-4-1,0-4-392,-2-2 0,0-5 1,-3 2-1,0-2-16,-2-1 0,-5 0 0,-2 0 0,-3 1 207,0 1 0,-1-1 1,-4 3-1,-3-2 511,-3 3 0,-1 3 1,-2 3-1,2 5 254,-2 3 1,-1 4 0,1 4 0,0 3-72,2 5 0,-1 6 0,-2 3 0,2 4 8,3 4 1,1 4 0,2 3 0,0 5-92,2 2 0,-1-1 0,4-2 1,-1-4-248,3-5 1,3-5 0,3-6 0,3-5 98,1-3 0,4-8 1,-2-1-1,4-3-1592,2-3 1,1-1 0,2-7 0,-1-1-1656,2 0 0,1-3 2935,3-1 0,-2 1 0,2-3 0</inkml:trace>
-  <inkml:trace contextRef="#ctx0" brushRef="#br0" timeOffset="1834">2013 162 7628,'-28'0'636,"-3"0"0,5 1 0,-1 1 0,7 3-75,4 2 0,10 4 0,0 2 0,6 1-169,6 2 0,0 0 1,9 2-1,3 4-58,0 2 0,2 3 0,0 4 1,-2 0 212,-1 0 1,-5-1 0,-3 0 0,-3-2 39,-4-2 1,-4-5-1,-4-3 1,-3-3-216,-5 1 1,-2-4 0,-3-3 0,0-3-432,0-3 0,-2-2 1,3-1-1,2-1-726,-1-2 0,3-4 1,0-2-1,2-2-2378,1 0 0,1 0 3163,2-2 0,4-1 0,1 2 0</inkml:trace>
-</inkml:ink>
-</file>
-
-<file path=ppt/ink/ink124.xml><?xml version="1.0" encoding="utf-8"?>
-<inkml:ink xmlns:inkml="http://www.w3.org/2003/InkML">
-  <inkml:definitions>
-    <inkml:context xml:id="ctx0">
-      <inkml:inkSource xml:id="inkSrc0">
-        <inkml:traceFormat>
-          <inkml:channel name="X" type="integer" min="-2.14748E9" max="2.14748E9" units="cm"/>
-          <inkml:channel name="Y" type="integer" min="-2.14748E9" max="2.14748E9" units="cm"/>
-          <inkml:channel name="F" type="integer" max="32767" units="dev"/>
-        </inkml:traceFormat>
-        <inkml:channelProperties>
-          <inkml:channelProperty channel="X" name="resolution" value="1000" units="1/cm"/>
-          <inkml:channelProperty channel="Y" name="resolution" value="1000" units="1/cm"/>
-          <inkml:channelProperty channel="F" name="resolution" value="0" units="1/dev"/>
-        </inkml:channelProperties>
-      </inkml:inkSource>
-      <inkml:timestamp xml:id="ts0" timeString="2026-10-21T09:30:39.672"/>
-    </inkml:context>
-    <inkml:brush xml:id="br0">
-      <inkml:brushProperty name="width" value="0.06" units="cm"/>
-      <inkml:brushProperty name="height" value="0.06" units="cm"/>
-    </inkml:brush>
-  </inkml:definitions>
-  <inkml:trace contextRef="#ctx0" brushRef="#br0">40 151 7704,'-8'-1'78,"2"-2"248,1-2 1,2-4 257,-6 5 1,6-6 265,-1 1-737,2 3 1,2 2 0,0 8 0,0 6-4,0 6 0,0 2 1,0 7-1,0 5 128,0 7 1,5 0-1,1 13 1,0 2 92,0 4 0,3 1 0,0-6 0,3 0-51,1-3 1,0-3-1,0-12 1,0-7-150,1-7 0,3-10 1,0-5-1,1-4-176,1-4 0,-5-9 0,5-10 0,-1-1-55,-1-2 0,0-5 0,-3-1 0,-3 0-41,-2 0 0,1-4 0,-4 1 0,0-2-20,0 3 0,-2-4 0,-4 3 0,0-2 45,0 2 0,-4 4 0,-1 6 0,1 5 15,-2 6 1,4 8 0,-1 12-1,0 9 182,-2 10 1,4 12 0,-4 13 0,4 4 84,1 2 1,6 1 0,3-4 0,2-2-92,2-3 0,6-3 0,3-9 1,3-6-27,1-8 1,2-7 0,0-7 0,3-3 26,-2-4 0,-3-7 0,-2-3 1,-4-7-1,-1-7 0,-3-2 0,-6-4 0,-3-2 4,-1 2 1,-1-4 0,-5 2 0,0-1-67,0-1 1,0 2-1,-2 0 1,-2-3-166,-5 1 0,-2-5 0,-3 5 0,1-1-3,0 4 0,5 8 0,0 5 0,1 3-562,0 6 1,4 3-78,-2 10 1,4 3 0,1 9 0,1 0-1081,4-1 1873,2-1 0,6 3 0,0 3 0</inkml:trace>
-  <inkml:trace contextRef="#ctx0" brushRef="#br0" timeOffset="434">917 269 7686,'-12'0'27,"-2"0"0,1 0 1,0 1 797,0 3 0,0 5 1,0 10-1,-1 7-277,2 8 0,0 5 0,3 6 0,5 6-375,2 4 1,4-4-1,4-7 1,7-4-87,7-6 1,6-3-1,3-11 1,4-6-135,0-9 1,2-10 0,4-4 0,1-7-45,-1-7 1,-6-2-1,-3-4 1,-3-4 85,-6 0 0,-1-2 1,-9-3-1,-2 2 58,-4 1 1,-5 2 0,-5-4 0,-5 4-12,-6 1 0,-4-4 0,-7 6 0,1 3-146,0 3 0,-5 2 0,2 8 0,3 3-164,2 4 1,7-2-1,-3 5 1,1 2-278,3 5 1,6 5 0,2 5 0,2 0-767,3 0 0,3 5 1311,0-1 0,5 6 0,2-2 0</inkml:trace>
-  <inkml:trace contextRef="#ctx0" brushRef="#br0" timeOffset="803">1337 269 7675,'-12'1'199,"2"2"1,1 3 411,-2 1 1,2 2-1,-2 5 1,3 5 344,-3 7 0,5 2 1,3 7-1,1 1-744,2 3 0,2 3 0,1-2 0,6-3-223,3-4 1,7-4 0,3-6 0,3-4 4,1-4 0,0-5 0,0-10 0,1-2-27,-2-1 1,4-6 0,-2-9 0,-7-3-172,-4-4 0,-3-1 0,-1-1 1,-4 1 10,-3 0 1,-5 0 0,-5-1 0,-3 1 26,-4 0 1,-2 0 0,-3 1-1,-1 2 16,-3 1 1,1 8-1,-3-1 1,3 5-40,0-1 0,-2 5 1,5 3-1,1 1-872,1 2 0,4 5 1061,2 4 0,9 3 0,8 1 0</inkml:trace>
-  <inkml:trace contextRef="#ctx0" brushRef="#br0" timeOffset="1217">1860 243 7675,'-13'-9'0,"0"1"151,0 3 1,0-4-1,0 3 1,0 0 518,0 1 0,-5 0 0,1 5 0,-1 2-182,-1 2 1,5 9-1,-4 10 1,4 6-174,1 7 1,4 3 0,2 4 0,1 4-102,3-1 1,7 4 0,5-6-1,4-4-180,5-4 1,2-9-1,6-11 1,1-6-310,-1-6 1,-1-2-1,-2-5 1,-1-5-167,1-4 1,-3-10 0,0-1 0,-1-7-13,-2-5 0,-3-1 0,-2-2 1,-2 0 110,-1-2 1,-6-7 0,1 2 0,-2-2 435,-2-2 0,-2 2 0,-2 1 0,-5 2 498,-3 6 0,-6 11 0,1 12 443,1 9 0,3 10 1,3 18-1,3 9-627,1 6 1,1 9 0,5 7 0,0 4 335,0 3 0,2-2 0,1-7 0,3-3-565,1-4 1,1-5 0,6-5 0,-1-8-1071,0-7 1,0-6 0,2-4 0,1-5-926,1-2 0,0-4 1,-3-2 1815,-2-5 0,2-8 0,-1-4 0</inkml:trace>
-  <inkml:trace contextRef="#ctx0" brushRef="#br0" timeOffset="1983">2201 243 7783,'0'-14'1130,"-4"6"-508,-1-1 1,1 7-168,4 2 0,0 18 0,1 12 0,4 9-51,3 4 0,3 10 1,-1 9-1,-2 6-207,3 6 1,-6-35-1,0-2 1,0 1 0,-1 0-1,0 33 68,-2-4 1,-1-4 0,2-14 0,1-5-213,-1-9-443,-2-12 0,-1-11 0,0-12-198,0-8 1,0-9 0,0-5 0,0-4 235,0-5 0,0-3 0,0-10 0,2-4 257,2-3 0,-2-1 1,4-2-1,-2-2 127,0 0 0,7-7 0,-2 2 1,3-2 379,6 2 1,-2 4 0,4 11 0,1 7 146,-1 7 1,2 15 0,4 10-1,-1 10-79,-4 10 1,4 12 0,-5 10 0,-3 3 20,-4 1 1,-9 5 0,1-1 0,-5-1-232,-5 0 1,-2-5 0,-6-2 0,-1-5-382,2-2 0,-6-6 0,-1-2 0,0 0-712,0-5 1,-2-1 0,2-4 0,-1-3-474,2-1-1,-1-2 1,3-4 0,-2-2 1296,2-1 0,2-11 0,1-6 0</inkml:trace>
-  <inkml:trace contextRef="#ctx0" brushRef="#br0" timeOffset="2384">2777 439 7632,'-9'8'789,"1"1"1,5 0 0,0 3-340,6-3 1,5-3 0,9-6 0,2 0-203,1 0 0,2 0 0,2-2 0,0-2-308,-3-5 1,-3-4 0,3-4 0,-4-1-379,-5-3 1,-1 0 0,-6-6-1,-2 1 419,-2 0 0,-2 0 1,-5 1-1,-6 3 279,-4 5 0,-7 3 0,1 6 1,-3 4 262,-1 2 0,0 13 0,-1 7 0,1 7-14,0 5 1,6 4-1,2 5 1,4 2-243,1 3 0,1-5 1,3 2-1,5-7-271,2-1 0,8-3 1,5-5-1,3-5-124,3-7 1,8-1 0,0-7-1,6-2-792,2-2 0,-4-1 1,3-1-1,-1-4-2582,0-4 3502,-1-2 0,2-9 0,2 0 0</inkml:trace>
-  <inkml:trace contextRef="#ctx0" brushRef="#br0" timeOffset="2651">3380 203 7644,'-15'-4'80,"-2"0"0,1-5 1,-5 4-1,1 2 649,0 2 0,2 1 0,-2 1 0,-1 4-124,1 4 0,4 8 0,-2 6 0,4 6-282,1 7 1,6 1-1,2 2 1,4 1-160,1-1 0,0 1 0,1-3 0,4-2-72,3-5 1,4-8 0,2-4-1,4-5-198,4-4 0,3 1 0,1-6 0,0-2-101,0-5 0,6-4 1,2-8-1,0-1-774,2-1 0,-7-6 0,0 5 981,-6-3 0,7-6 0,-2-6 0</inkml:trace>
-  <inkml:trace contextRef="#ctx0" brushRef="#br0" timeOffset="3017">3590 72 7644,'0'-20'654,"0"-3"-37,0 5 1,-5 8-1,1 10 1,1 10 136,1 10 0,2 8 0,0 13 1,0 3-258,0 4 0,0 7 0,2 1 1,1 0-7,1-2 0,1-2 1,-5-1-1,0-3-341,0-4 1,0-11-1,0-7 1,0-6-1258,0-6 0,1-8 400,3-6 1,-3-6 0,4-8-1,-2-4 290,1-4 0,-1-3 0,4-1 1,1-2 241,-1-2 1,-4 1 0,3-5 0,-2 1 72,0-1 0,7 5 1,-3-2-1,4 5 320,1 4 0,2 4 0,1 6 1,2 3 403,3 5 0,1 10 1,3 8-1,-2 9 196,-1 7 1,0 6 0,2-1 0,-3 3-210,-8 1 0,0-4 0,-6-2 0,2 0-227,0-4 0,-6-6 1,1-3-4458,-2-1 2395,-2-1 0,0-13 1,-2-3-1,-4-8 1680,-7-5 0,-6 0 0,-7-8 0</inkml:trace>
-  <inkml:trace contextRef="#ctx0" brushRef="#br0" timeOffset="3167">3720 399 7644,'0'-12'1041,"0"3"0,0 0 1,2 0-510,2 2 0,-1-3 0,6 4 0,2 0 434,5 0 0,1-4 1,6 3-1,3-2-1224,3 1 1,7 3 0,0-2 0,3 1-990,4 3 1,-6-3 0,-1 2 1246,-7 1 0,6-5 0,-7 2 0</inkml:trace>
-  <inkml:trace contextRef="#ctx0" brushRef="#br0" timeOffset="3851">4257 360 7661,'-5'8'3860,"-4"-4"-3199,3 3 1,1-1 0,11 3 0,6-5-590,4-3 0,6-1 1,-3 0-1,0-1-162,0-3 0,0 1 0,-4-6 1,3 0 113,-2 2 1,-5-6 0,-5 2 0,2-6-447,-1 1 1,-4 2-1,0-1 1,-5-1 504,-2-1 0,-6 1 0,0 7 0,-6 3 381,-6 0 0,2 5 1,-2-2-1,0 7-50,2 10 0,-4 5 1,7 7-1,-1 2-81,0 2 0,4 3 0,0 6 0,5 1 10,3-1 0,2 1 0,4-3 1,0-1-258,0-6 1,7-4-1,5-4 1,4-4-336,-1-4 1,5-7-1,-1-2 1,1-4-524,3-1 0,-1-6 0,1-3 0,2-2 206,-2-2 0,-1-6 1,1-1-1,0-2 259,0-1 1,-4 2-1,-2-6 1,-2 2 345,-2-1 1,1-1 0,2 3-1,0 2 513,-4 4 0,1 8 1,-4 3-1,2 1 236,3 3 0,-2 7 1,0 7-1,-2 3-214,-1 3 0,-1 11 1,0-2-1,-2 2-40,0 0 0,-5-2 0,4 0 0,-4 0-343,-1 1 0,0-3 0,0-2 1,0-5-1050,0-2 0,0-6 50,0 0 0,0-8 0,0-1 1,0-9 284,0-7 0,0 0 0,0-4 0,1-1 378,4 1 0,-4-2 0,4-4 0,-4 0 213,-1 0 0,5-1 0,1 1 0,0 1 236,5 4 1,0-3-1,3 7 1,-2 1 141,2 1 1,0 2 0,3 2 0,0 2-116,-1 4 1,2 0 0,0 0 0,0 1-627,0-2 0,-1 4 0,3-3 0,-1 1-1532,-3-1 1,2-1 0,0 3-2011,-2-1 3837,-1-6 0,-2 2 0,0-4 0</inkml:trace>
-</inkml:ink>
-</file>
-
-<file path=ppt/ink/ink125.xml><?xml version="1.0" encoding="utf-8"?>
-<inkml:ink xmlns:inkml="http://www.w3.org/2003/InkML">
-  <inkml:definitions>
-    <inkml:context xml:id="ctx0">
-      <inkml:inkSource xml:id="inkSrc0">
-        <inkml:traceFormat>
-          <inkml:channel name="X" type="integer" min="-2.14748E9" max="2.14748E9" units="cm"/>
-          <inkml:channel name="Y" type="integer" min="-2.14748E9" max="2.14748E9" units="cm"/>
-          <inkml:channel name="F" type="integer" max="32767" units="dev"/>
-        </inkml:traceFormat>
-        <inkml:channelProperties>
-          <inkml:channelProperty channel="X" name="resolution" value="1000" units="1/cm"/>
-          <inkml:channelProperty channel="Y" name="resolution" value="1000" units="1/cm"/>
-          <inkml:channelProperty channel="F" name="resolution" value="0" units="1/dev"/>
-        </inkml:channelProperties>
-      </inkml:inkSource>
-      <inkml:timestamp xml:id="ts0" timeString="2026-10-21T09:31:01.788"/>
-    </inkml:context>
-    <inkml:brush xml:id="br0">
-      <inkml:brushProperty name="width" value="0.06" units="cm"/>
-      <inkml:brushProperty name="height" value="0.06" units="cm"/>
-    </inkml:brush>
-  </inkml:definitions>
-  <inkml:trace contextRef="#ctx0" brushRef="#br0">39 44 7863,'-2'-11'0,"1"2"238,-1 2 1,0 1 0,0 1 177,-1 1 1,1 3 0,1 6 0,0 7-33,1 6 1,1 11 0,0 6-1,3 3-133,1 4 1,2 5 0,0 6 0,0 5-77,-1 1 1,-1-3 0,-1-6-1,-2-4-139,-2-6 0,0-3 1,0-9-1,0-6-219,-2-6 1,1-6-1,-1-3-85,2-1 1,0-4 53,0-4 1,2-4 0,2-7 0,1-2 56,3-3 0,-2-2 0,1-5 0,-1-1 223,0-3 0,1 0 0,1 3 0,1 1 85,0 1 0,4 1 0,3 5 0,1 6 324,3 5 1,3 7-1,0 6 1,0 5 43,-2 5 1,-3 5 0,-6 3 0,-3 1-82,-3-1 1,-4 2 0,-4-2 0,-2-3-154,-3 0 1,-2-4-1,-4 0 1,-3-2-149,-2-1 0,-1-3 1,0-3-1,-1 0-183,-1-1 0,-1 1 0,2-2 0,2 0-593,1-2 1,1-2 0,0-1 0,3 0-671,-1-1 1,2-3-1,0-2 1,2-4-80,1-2 1,1-2 1387,5-2 0,-2-3 0,2-2 0</inkml:trace>
-  <inkml:trace contextRef="#ctx0" brushRef="#br0" timeOffset="299">381 148 8251,'0'-2'1050,"0"2"0,0 4-489,0 5 0,0 3 0,0 7 1,0 4-167,0 6 1,0 6-1,0 8 1,0 0 15,0 1 0,0-2 1,0-2-1,0-4-185,0-3 1,0-6 0,0-5 0,0-5-386,0-3 0,0-4 0,0 0 0,0-3-1001,2-3 0,-1-1 170,3-3 0,-2-3 1,1-1-1,0-1 990,0-3 0,0 0 0,3-3 0</inkml:trace>
-  <inkml:trace contextRef="#ctx0" brushRef="#br0" timeOffset="900">519 418 8469,'-4'2'0,"0"1"656,0 2 0,-1-1 0,1 6 0,1 1-51,0 1 1,0 3 0,1 4 0,1 4 47,1 1 0,2 2 1,2 1-1,3-1-286,2-3 1,-1-5-1,1-3 1,2-5-382,-1-2 0,1-5 0,0-1 0,0-1-67,-2-1 0,0-3 0,-2-3 0,-2-1-132,0-1 0,-2-1 1,1-3-1,-1 1 34,0 1 0,-1-2 0,-2 0 0,0 0 18,0 0 0,-1-2 0,0 2 0,-2-1-276,0-2 1,2 0-1,-1 0 1,-1 0-110,2 0 1,-1 2 0,2-2-1,0 1 79,0 2 0,0 0 0,0 4 0,3 2-227,0 2 1,2 1-1,1 4 417,-1 1 1,0 1 0,1 4-1,-3 1 310,1 1 1,0 0 0,2 2 0,0 0 376,1 0 0,2-1 1,2 1-1,-1-3 264,2 0 0,1-1 1,2-1-1,1-2-272,0 0 0,0-2 0,-1-2 1,-1-2-411,0-2 0,-4-1 1,-2-2-1,-3-1-116,-1 0 0,0 0 0,-2 0 0,-1 0 227,-3 1 1,-2 1 0,-2 1 0,-2-1 508,-1 1 0,0 2 0,-2 1 1,0 4 29,0 1 0,0 5 1,0 1-1,0 1-64,0 4 1,3 0-1,0 5 1,2 3-135,1 3 1,2 4 0,1 1-1,2 0-359,2-3 1,3 0 0,5-6 0,2-3-523,3-3 1,1-6-1,0-3 1,1-4-523,-1-1 0,-2-6 0,0-1 0,-1-2-386,2-2 0,1 0 0,2-1 1345,1 0 0,1 0 0,0 0 0</inkml:trace>
-  <inkml:trace contextRef="#ctx0" brushRef="#br0" timeOffset="1699">1300 77 7663,'-1'-8'0,"-2"1"0,2 1-109,-1 1 0,0 5 0,-1 3 484,1 4 0,0 9 0,2 4 0,2 7-57,2 3 1,-1 6 0,0 3 0,1 5-22,-1 3 1,2 3 0,-4 2 0,1-2-156,-2-2 1,1-6 0,0-7 0,1-4-85,-1-5 0,0-8 1,-1-2-1,0-4-201,0-4 0,0-2 60,0-3 1,0-2-1,0-2 1,2-4-22,-1-3 0,4-3 0,-1-2 1,0-2-19,2-3 0,-1-2 0,1-2 1,1-3 41,1-3 0,1 3 0,0-2 0,3 2 146,0 2 1,3 0 0,1 4 0,1 2 113,-1 4 1,1 6-1,-1 4 1,0 4 80,-1 3 0,-2 4 0,-2 2 0,-2 5 179,-2 0 1,-3 5 0,-1-1 0,0 2-2,-2-2 1,0 1 0,-2 4 0,-1-1-234,-1 0 1,-2 0 0,1-2 0,1-3-216,-2-3 1,3-2 0,0-2-2453,1-2 1315,1-1 0,1-6 1,1-2-1,1-3-1420,0-1 2566,1-2 0,-1-2 0,3-1 0</inkml:trace>
-  <inkml:trace contextRef="#ctx0" brushRef="#br0" timeOffset="2949">1785 484 7640,'-5'8'690,"1"-1"0,-1 1 0,2-2 0,-1 2-786,1-1 0,3-1 0,0-1 1026,3 1 0,4-3 0,1-2 0,1 0-723,0-1 1,2-1 0,1 0-1,1-4-318,-1-1 0,-1-1 0,-1-2 0,-2-1-202,0 0 1,-3-2-1,-3 0 1,-2-1 255,-2 1 0,-1-2 0,-4 2 0,-2-1 465,-2 2 0,2 0 1,-4 3-1,1 2 225,-1 4 0,1 2 1,-1 4-1,1 6-155,0 3 0,0 6 0,0 3 0,1 3-74,2 2 0,3 3 1,0 0-1,4 0-396,1 0 1,2-6 0,1-5 0,4-2-377,2-5 0,4-3 1,0-3-1,3-4-573,-2-1 0,4-2 0,-4-1 0,2-1-68,0-3 1,-1-2 0,1 0 0,0-1 169,0-1 0,-1 0 1,0-2-1,0 0 399,-2 0 0,-3-3 0,-2-1 1,0-3 439,-2 0 0,-2-2 0,-1 0 0,-1-1 92,1 2 1,-2 1 0,3 4 0,0 3 437,0 4 0,0 5 1,1 6-1,0 3 676,-1 4 0,1 4 1,-1 3-1,1 1-434,0 2 1,-1 3-1,1 0 1,-2 0-200,-2 0 0,0 0 0,0-3 1,0-2-236,0-1 1,0-3 0,0-3 0,0-3-147,0-2-524,0-3 1,0-1-1,0-4 1,1-1-230,1-3 1,-1-1-1,2-1 1,0-1 4,0 0 0,-1-2 0,2 0 0,-1-2 123,0-2 0,2-1 1,-3-2-1,1-1 139,2-1 1,0 0-1,2-2 1,3 1 220,2 0 1,1 3 0,3 3 0,1 1 193,0 5 0,0 5 0,-2 2 0,-3 3 166,0 3 0,-4-1 0,-3 7 0,-2 2 37,0 2 1,-3 2 0,2 1-1,-1 0 8,-1 1 0,1 0 1,0 1-1,2 1-190,0-1 0,3-1 1,-3 0-1,4-3-19,0-2 0,1-4 0,-1-2 0,1-3-282,0-2 1,1-1-1,3-2 1,-1-1-450,-1-4 1,2-2-1,0-2 1,0-2 59,-1-1 1,-1-1-1,-3-3 1,-2 1 395,-2-1 1,-3 0-1,-3 0 1,-3-2 327,-2 1 1,-2 1-1,-2 3 1,0 2 622,-1 2 0,2 0 0,2 3 377,1 3 1,2 1-1145,5 3 0,3 0 1,6 2-1,2 1-115,2 0 1,3 2 0,1 0 0,0 1-182,0 0 0,-1 5 0,1-1 1,-1 3 434,-3 1 1,-2 1-1,-3 3 1,-1-1 653,-2 2 0,-2 1 1,-3-1-1,0 2-366,-3-3 1,1-3-1,-1-3 1,2 0-937,1-1-102,0-3 1,4-3-1,0-5-265,2-3 0,-1-2 1,-1 0-1,0-1 503,0-2 1,0 2 0,1-3 0,-1-1 166,0-1 1,1-1-1,0 0 1,1-3 28,0 2 1,1-3-1,-1 2 1,1 0 108,2 1 1,-1 4-1,1 2 1,1 3 216,-1 1 0,0 6 0,3 3 0,-2 3 295,1 3 0,0 2 1,1 2-1,0 1 161,0-3 1,3 0 0,0-5 0,2 0-222,1-4 1,-1-3-1,0 0 1,-1-2-403,0-2 0,-2-2 1,1-3-1,0-2 28,0-2 1,-2 0 0,1 0 0,-2 0-96,-1 0 1,-3 0 0,-2 0 0,1 0-545,-3 0 1,0 0 0,-3 2-1,0 0-558,0 1 0,-3 1 0,0 1 0,-3 1 1155,1 0 0,-2-1 0,-2 1 0</inkml:trace>
-</inkml:ink>
-</file>
-
-<file path=ppt/ink/ink126.xml><?xml version="1.0" encoding="utf-8"?>
-<inkml:ink xmlns:inkml="http://www.w3.org/2003/InkML">
-  <inkml:definitions>
-    <inkml:context xml:id="ctx0">
-      <inkml:inkSource xml:id="inkSrc0">
-        <inkml:traceFormat>
-          <inkml:channel name="X" type="integer" min="-2.14748E9" max="2.14748E9" units="cm"/>
-          <inkml:channel name="Y" type="integer" min="-2.14748E9" max="2.14748E9" units="cm"/>
-          <inkml:channel name="F" type="integer" max="32767" units="dev"/>
-        </inkml:traceFormat>
-        <inkml:channelProperties>
-          <inkml:channelProperty channel="X" name="resolution" value="1000" units="1/cm"/>
-          <inkml:channelProperty channel="Y" name="resolution" value="1000" units="1/cm"/>
-          <inkml:channelProperty channel="F" name="resolution" value="0" units="1/dev"/>
-        </inkml:channelProperties>
-      </inkml:inkSource>
-      <inkml:timestamp xml:id="ts0" timeString="2026-10-21T09:30:59.138"/>
-    </inkml:context>
-    <inkml:brush xml:id="br0">
-      <inkml:brushProperty name="width" value="0.06" units="cm"/>
-      <inkml:brushProperty name="height" value="0.06" units="cm"/>
-    </inkml:brush>
-  </inkml:definitions>
-  <inkml:trace contextRef="#ctx0" brushRef="#br0">469 201 7686,'0'-7'156,"0"0"0,2 0 0,0 1 0,-1-1 0,-1-1 0,0 1 1,0-1-1,0 1 577,0 0 1,-1 1 0,-1 1 0,-1-1-415,-2-2 1,0 2 0,0-1-1,-1 1-59,-2 1 0,0 1 1,-4 1-1,-1 0-98,-2 2 0,-1 1 0,0 2 1,-1 4-16,-1 3 0,1 4 0,0 4 0,3 4-66,2 5 0,0 5 1,6 4-1,1 1-15,3 1 1,2-4 0,2 3 0,3-3-158,4 0 1,4-5-1,4-5 1,1-8-142,1-5 1,0-4 0,0-2-1,-2-3 82,-3 0 1,0-5 0,-3-2 0,-1-3 41,-1-2 1,-3-2-1,0-4 1,-3 1-9,-1-2 1,-1 0 0,-1-2-1,0 0 77,0 0 1,0 2-1,-1-3 1,-1 0 73,-4 0 0,0 0 0,-1 0 1,-1 4 231,1 4 1,2 3 0,2 7-1,0 4 131,2 6 0,2 9 0,4 9 0,1 8 4,1 5 0,3 7 1,-2 5-1,1 3 14,-1 1 0,-2 4 0,-2 1 1,0-2 10,-2-6 0,-5-8 1,-1-8-1,-4-3-152,0-4 0,-2-4 0,0 0 0,-1-4-273,-1-1 0,-3-1 1,-3-2-1,-3-2-283,-1-1 1,-1-3 0,2-4 0,-1-1-562,2-1 1,2-3 0,3-1-1,2-2-269,2-3 1,-3-5-1,-1-1 1,-1-3 179,0-2 0,-3-4 1,0-4-1,1-6-333,-1-3 0,2 1 1264,5-1 0,0 1 0,1-1 0</inkml:trace>
-  <inkml:trace contextRef="#ctx0" brushRef="#br0" timeOffset="519">507 152 7688,'4'-5'27,"-2"-1"1,-2 0 198,0 1 1,1 2 0,1 2 0,2 5 485,3 5 0,1 7 0,3 6 1,1 5-181,0 3 0,0 1 0,0 5 0,-1 1-193,-2 1 1,-4 3 0,0-2-1,-2-3-196,-2-6 1,0-6 0,-1-6-1,-1-3-1,0-2 1,-1-4-1,-2-1 1,0-2 1,-1-3-1,0-2-228,-1 0 1,2-4 0,1-2 0,0-2-18,0-2 0,-2-2 0,3-2 0,-1-1-91,1-1 1,-3-4-1,1-1 1,1-2 22,-1-2 0,-1-1 1,3-1-1,0 0 65,-1-2 0,1 1 0,3-1 0,3 4 67,1 3 1,4 5-1,1 5 1,2 2-185,1 3 1,0 2-1,0 4 1,1 0-366,0 3 0,1 0 0,-2 2 0,-1 0-286,0 1 0,-3-1 0,0 1 873,1 0 0,-2-1 0,0 1 0</inkml:trace>
-  <inkml:trace contextRef="#ctx0" brushRef="#br0" timeOffset="917">827 333 7688,'0'6'606,"0"0"1,1-1-1,1-2 1,2 0-205,2-1 1,1-1 0,2 0 0,1 0-211,0-1 0,3-1 0,1 1 0,-2-3-199,-1 0 1,-1-1-1,0-2 1,-1-1-148,-1 0 1,-1-3-1,-1 1 1,-1-2-6,-2 1 0,0-1 0,-3-1 1,-1 1 273,-1-2 1,-1 0 0,-3-3-1,-1 2 175,-2 1 0,-1 0 0,0 3 0,1 1 127,-1 4 0,-1 2 1,1 3-1,-1 4 112,-1 4 0,2 6 0,-2 3 0,1 3-60,-1 4 1,0-1 0,3 1 0,1 1 3,1 2 1,-1 1 0,3-1 0,2-1-400,1 0 1,7-4 0,1-1 0,2-3-137,4-3 0,-1-3 0,4-4 0,0-2-911,2-2 0,-1 0 0,-2-2 0,-1-1-1573,-1 0 1,-2-1 2545,-1 0 0,4-2 0,-1-1 0</inkml:trace>
-  <inkml:trace contextRef="#ctx0" brushRef="#br0" timeOffset="1383">1257 279 7640,'0'-6'139,"2"0"0,-1 1 0,0 0 0,0-1 357,-1 1 0,-2-1 0,0 0 0,-1 1-69,-1-1 1,-2 1-1,0 0 1,0-1-105,-2 3 0,-2-1 1,1 2-1,-1 1 86,-1 0 1,0 3 0,0 4 0,0 1-34,0 4 1,-2 7-1,1 0 1,-2 5-102,1 2 1,1 5 0,0 0 0,3 1-283,1-2 0,5-2 0,4-3 0,3-4-274,5-4 1,4-7-1,1-6 1,1-3-233,0-1 1,-2-3 0,2-3-1,-2-3 186,-2-2 1,-1-2 0,-2-4 0,1 1 470,-1-2 1,-2 2 0,-1 2 0,-1 3 444,-1 2 1,1 4 286,-2 9 0,0 3 1,-2 12-1,-1 0-279,0 2 1,-1 2 0,-1-1 0,1-1-1004,0-2 1,2-2-1,0-1 1,3-3-1059,3-2 1,0-4-1,3-4 1,0-2-390,2-2 0,0-2 1,0-3 1852,0-2 0,0-4 0,0-1 0</inkml:trace>
-  <inkml:trace contextRef="#ctx0" brushRef="#br0" timeOffset="1633">1422 3 7640,'3'-2'325,"1"2"0,-2 0 0,0 3 615,0 4 0,-1 4 1,1 5-1,0 3 9,0 5 0,0 8 0,0 3 0,-1 4-219,1 1 0,-2 3 0,0-3 0,0-4-323,0-2 0,0-6 0,0-1 1,0-3-485,0-6 0,0-3 0,0-5 0,0-3-2906,0 0 605,0-2 0,0-3 1,-2-2 2377,-2-3 0,-1-1 0,0-2 0</inkml:trace>
-  <inkml:trace contextRef="#ctx0" brushRef="#br0" timeOffset="1783">1278 356 7640,'-2'5'1024,"1"0"1,0 1 511,0 0 1,4-1 0,3-1-1,5-1-880,3 0 0,2-2 0,2-1 1,1-1-1107,1 0 1,0-2 0,2-3 0,1-1-4498,-1 0 4947,2-3 0,-8 1 0,4-2 0</inkml:trace>
-</inkml:ink>
-</file>
-
-<file path=ppt/ink/ink127.xml><?xml version="1.0" encoding="utf-8"?>
-<inkml:ink xmlns:inkml="http://www.w3.org/2003/InkML">
-  <inkml:definitions>
-    <inkml:context xml:id="ctx0">
-      <inkml:inkSource xml:id="inkSrc0">
-        <inkml:traceFormat>
-          <inkml:channel name="X" type="integer" min="-2.14748E9" max="2.14748E9" units="cm"/>
-          <inkml:channel name="Y" type="integer" min="-2.14748E9" max="2.14748E9" units="cm"/>
-          <inkml:channel name="F" type="integer" max="32767" units="dev"/>
-        </inkml:traceFormat>
-        <inkml:channelProperties>
-          <inkml:channelProperty channel="X" name="resolution" value="1000" units="1/cm"/>
-          <inkml:channelProperty channel="Y" name="resolution" value="1000" units="1/cm"/>
-          <inkml:channelProperty channel="F" name="resolution" value="0" units="1/dev"/>
-        </inkml:channelProperties>
-      </inkml:inkSource>
-      <inkml:timestamp xml:id="ts0" timeString="2026-10-21T09:31:18.770"/>
-    </inkml:context>
-    <inkml:brush xml:id="br0">
-      <inkml:brushProperty name="width" value="0.06" units="cm"/>
-      <inkml:brushProperty name="height" value="0.06" units="cm"/>
-    </inkml:brush>
-  </inkml:definitions>
-  <inkml:trace contextRef="#ctx0" brushRef="#br0">376 549 7672,'0'-13'73,"0"0"1,0 0 0,0 0 253,0 0 1,0 0 0,0 0-1,0 0 143,0 0 1,0 1 0,-1-2 0,-2 1-286,-1 1 1,-7-1 0,3-1-1,-3 3-98,-3 3 1,0-3-1,-3 7 1,-5 0-107,-2-2 1,-6 6-1,-1 0 1,1 9 62,-1 7 0,3 11 0,0 12 1,4 8 187,7 8 0,4 0 1,5 5-1,4 0 50,2-1 1,10-3 0,4-9 0,9-5-71,3-6 1,9-10 0,4-10 0,7-7-241,1-9 0,1-12 0,4-11 0,-5-5-321,0-7 0,-8-4 0,-7-4 0,-4-3-208,-4 0 1,-3-4 0,-8 3 0,-3 0 142,-3 0 0,-4-1 0,-2-5 0,-4-1 270,-3-3 0,-5-3 0,-2 6 0,-3 3 234,3 6 0,0 8 1,2 8 567,0 12 1,6 17 0,1 19 0,2 14 240,-1 11 0,1 8 0,4 6 0,0 6-511,0 8 1,1-34 0,-1 1 0,2-1 0,-1-1 0,4 35-80,-2-7 0,2-7 0,1-11 0,2-4-277,1-2 0,-1-14 1,0-7-1100,3-9 1,-5-5-1,3-6-202,1 0 1,-4-6 0,-1-2 0,0-4 1268,-1-1 0,6 1 0,-2-1 0</inkml:trace>
-  <inkml:trace contextRef="#ctx0" brushRef="#br0" timeOffset="417">713 329 8235,'-13'0'533,"0"0"1,4 0 0,0 1 0,1 5 122,1 7 0,-5 11 1,5 11-1,0 4-62,3 4 1,-2 7 0,3 6 0,4-3-259,7-3 1,6-6-1,6-8 1,7-5-253,5-4 1,3-16 0,3-3 0,0-5-67,-4-3 1,-1-10 0,-5-4 0,-3-5-140,-4-4 1,-6 3 0,-3-1-1,-3-4-55,-5-3 1,-2 1 0,-2 0 0,0 3-57,0-3 0,0 0 0,-2-3 1,-2 3-257,-5 1 1,2-4 0,-2-1 0,1 1-219,0-1 0,-2 8 0,6-1 0,1 3-1309,1 6 2015,-3 6 0,10 3 0,-5 6 0</inkml:trace>
-  <inkml:trace contextRef="#ctx0" brushRef="#br0" timeOffset="783">1308 303 7712,'-13'6'119,"-1"-5"0,-2 4 1,-3-2 331,-1 0 0,3-1 1,-4 4-1,3 0 74,2 2 0,0 3 0,2 4 0,0 3-186,2 3 1,3 5 0,1 4-1,4 4 10,2 4 1,2 2 0,0 0-1,2 1-90,2-4 0,3-7 1,6 0-1,0-2-376,0-3 0,0-6 0,0-6 0,1-6-643,4-1 0,2-4 1,5 0-1,2-4-1530,-2-7 2290,1-2 0,6-8 0,1-1 0</inkml:trace>
-  <inkml:trace contextRef="#ctx0" brushRef="#br0" timeOffset="1150">1515 135 7712,'-13'-9'1033,"0"0"0,0 8-50,1 1 1,4 12-1,4 10 1,2 8-302,2 9 0,5 8 0,1 10 0,-1 7-195,1 3 1,3 1-1,-5-8 1,-1-4-312,-2-3 1,-1-9-1,0-6 1,0-9-778,0-6 1,0-11-33,0 0 1,0-9-1,0-3 1,0-7 32,0-4 0,0-7 0,0 0 0,2-3 371,2-2 1,-2-1 0,3-2-1,-1 0 114,1 0 0,5 1 1,-3-2-1,1 2 196,1-1 0,-2 5 0,4 4 0,-3 4 480,2 5 0,2 2 1,2 8-1,2 4 543,1 6 1,2 11-1,-4 9 1,3 1-162,-2 3 0,-2 0 0,-1 0 1,0-3-983,0-1 0,0-2 1,0-6-1,0-3-1625,-1-3 1,-3-5-942,0-5 1,-8-3 2604,-1-10 0,-11-7 0,-9-9 0</inkml:trace>
-  <inkml:trace contextRef="#ctx0" brushRef="#br0" timeOffset="1316">1541 561 8427,'-7'-12'2522,"1"-1"1,8 2-1568,2 2 0,3-3 0,7 5 0,3-1-816,5-1 1,3 0-1,2-4 1,3 0-178,4 0 1,4 2 0,1 1 0,0 1 37,-1-1 0,1-1 0,0-2 0</inkml:trace>
-  <inkml:trace contextRef="#ctx0" brushRef="#br0" timeOffset="1733">2227 329 7714,'-12'-2'1748,"2"-1"-1088,1-1 0,1 0 1,-5 4-1,0 0-66,0 0 1,0 0-1,1 0 1,-2 2-222,1 1 1,1 9 0,0 7 0,3 1-175,5 3 0,2 3 1,4 3-1,2 2 233,5 2 1,8 2-1,5 2 1,1-1 329,-1-1 1,2-7-1,-4 3 1,2-4-435,-1-1 1,-5-2 0,0-2-763,-6-5 0,-6-4 0,-8-4-432,-5-5 0,-8-4 0,-5-4 1,-4-5-24,-4-2 0,-1-2 0,-5 1 0,0 2 85,-5 1 1,7 1-1,-5-5 1,5 0-842,5 0 1645,5 0 0,10 0 0,1 0 0</inkml:trace>
 </inkml:ink>
 </file>
 
@@ -4625,6 +4196,800 @@
 </p:notesMaster>
 </file>
 
+<file path=ppt/notesSlides/notesSlide1.xml><?xml version="1.0" encoding="utf-8"?>
+<p:notes xmlns:a="http://schemas.openxmlformats.org/drawingml/2006/main" xmlns:r="http://schemas.openxmlformats.org/officeDocument/2006/relationships" xmlns:p="http://schemas.openxmlformats.org/presentationml/2006/main">
+  <p:cSld>
+    <p:spTree>
+      <p:nvGrpSpPr>
+        <p:cNvPr id="1" name=""/>
+        <p:cNvGrpSpPr/>
+        <p:nvPr/>
+      </p:nvGrpSpPr>
+      <p:grpSpPr>
+        <a:xfrm>
+          <a:off x="0" y="0"/>
+          <a:ext cx="0" cy="0"/>
+          <a:chOff x="0" y="0"/>
+          <a:chExt cx="0" cy="0"/>
+        </a:xfrm>
+      </p:grpSpPr>
+      <p:sp>
+        <p:nvSpPr>
+          <p:cNvPr id="2" name="Marcador de imagen de diapositiva 1"/>
+          <p:cNvSpPr>
+            <a:spLocks noGrp="1" noRot="1" noChangeAspect="1"/>
+          </p:cNvSpPr>
+          <p:nvPr>
+            <p:ph type="sldImg"/>
+          </p:nvPr>
+        </p:nvSpPr>
+        <p:spPr>
+          <a:xfrm>
+            <a:off x="381000" y="685800"/>
+            <a:ext cx="6096000" cy="3429000"/>
+          </a:xfrm>
+        </p:spPr>
+      </p:sp>
+      <p:sp>
+        <p:nvSpPr>
+          <p:cNvPr id="3" name="Marcador de notas 2"/>
+          <p:cNvSpPr>
+            <a:spLocks noGrp="1"/>
+          </p:cNvSpPr>
+          <p:nvPr>
+            <p:ph type="body" idx="1"/>
+          </p:nvPr>
+        </p:nvSpPr>
+        <p:spPr/>
+        <p:txBody>
+          <a:bodyPr/>
+          <a:lstStyle/>
+          <a:p>
+            <a:r>
+              <a:rPr lang="es-US" b="1" dirty="0"/>
+              <a:t>https://</a:t>
+            </a:r>
+            <a:r>
+              <a:rPr lang="es-US" b="1" dirty="0" err="1"/>
+              <a:t>commons.wikimedia.org</a:t>
+            </a:r>
+            <a:r>
+              <a:rPr lang="es-US" b="1" dirty="0"/>
+              <a:t>/wiki/File:Opossum_2.jpg</a:t>
+            </a:r>
+          </a:p>
+        </p:txBody>
+      </p:sp>
+    </p:spTree>
+    <p:extLst>
+      <p:ext uri="{BB962C8B-B14F-4D97-AF65-F5344CB8AC3E}">
+        <p14:creationId xmlns:p14="http://schemas.microsoft.com/office/powerpoint/2010/main" val="826979226"/>
+      </p:ext>
+    </p:extLst>
+  </p:cSld>
+  <p:clrMapOvr>
+    <a:masterClrMapping/>
+  </p:clrMapOvr>
+</p:notes>
+</file>
+
+<file path=ppt/notesSlides/notesSlide10.xml><?xml version="1.0" encoding="utf-8"?>
+<p:notes xmlns:a="http://schemas.openxmlformats.org/drawingml/2006/main" xmlns:r="http://schemas.openxmlformats.org/officeDocument/2006/relationships" xmlns:p="http://schemas.openxmlformats.org/presentationml/2006/main">
+  <p:cSld>
+    <p:spTree>
+      <p:nvGrpSpPr>
+        <p:cNvPr id="1" name=""/>
+        <p:cNvGrpSpPr/>
+        <p:nvPr/>
+      </p:nvGrpSpPr>
+      <p:grpSpPr>
+        <a:xfrm>
+          <a:off x="0" y="0"/>
+          <a:ext cx="0" cy="0"/>
+          <a:chOff x="0" y="0"/>
+          <a:chExt cx="0" cy="0"/>
+        </a:xfrm>
+      </p:grpSpPr>
+      <p:sp>
+        <p:nvSpPr>
+          <p:cNvPr id="2" name="Marcador de imagen de diapositiva 1"/>
+          <p:cNvSpPr>
+            <a:spLocks noGrp="1" noRot="1" noChangeAspect="1"/>
+          </p:cNvSpPr>
+          <p:nvPr>
+            <p:ph type="sldImg"/>
+          </p:nvPr>
+        </p:nvSpPr>
+        <p:spPr>
+          <a:xfrm>
+            <a:off x="381000" y="685800"/>
+            <a:ext cx="6096000" cy="3429000"/>
+          </a:xfrm>
+        </p:spPr>
+      </p:sp>
+      <p:sp>
+        <p:nvSpPr>
+          <p:cNvPr id="3" name="Marcador de notas 2"/>
+          <p:cNvSpPr>
+            <a:spLocks noGrp="1"/>
+          </p:cNvSpPr>
+          <p:nvPr>
+            <p:ph type="body" idx="1"/>
+          </p:nvPr>
+        </p:nvSpPr>
+        <p:spPr/>
+        <p:txBody>
+          <a:bodyPr/>
+          <a:lstStyle/>
+          <a:p>
+            <a:r>
+              <a:rPr lang="es-US" dirty="0"/>
+              <a:t>https://</a:t>
+            </a:r>
+            <a:r>
+              <a:rPr lang="es-US" dirty="0" err="1"/>
+              <a:t>commons.wikimedia.org</a:t>
+            </a:r>
+            <a:r>
+              <a:rPr lang="es-US" dirty="0"/>
+              <a:t>/wiki/</a:t>
+            </a:r>
+            <a:r>
+              <a:rPr lang="es-US" dirty="0" err="1"/>
+              <a:t>File:Glass_slide.jpg</a:t>
+            </a:r>
+            <a:endParaRPr lang="es-US" dirty="0"/>
+          </a:p>
+        </p:txBody>
+      </p:sp>
+    </p:spTree>
+    <p:extLst>
+      <p:ext uri="{BB962C8B-B14F-4D97-AF65-F5344CB8AC3E}">
+        <p14:creationId xmlns:p14="http://schemas.microsoft.com/office/powerpoint/2010/main" val="2668045776"/>
+      </p:ext>
+    </p:extLst>
+  </p:cSld>
+  <p:clrMapOvr>
+    <a:masterClrMapping/>
+  </p:clrMapOvr>
+</p:notes>
+</file>
+
+<file path=ppt/notesSlides/notesSlide2.xml><?xml version="1.0" encoding="utf-8"?>
+<p:notes xmlns:a="http://schemas.openxmlformats.org/drawingml/2006/main" xmlns:r="http://schemas.openxmlformats.org/officeDocument/2006/relationships" xmlns:p="http://schemas.openxmlformats.org/presentationml/2006/main">
+  <p:cSld>
+    <p:spTree>
+      <p:nvGrpSpPr>
+        <p:cNvPr id="1" name=""/>
+        <p:cNvGrpSpPr/>
+        <p:nvPr/>
+      </p:nvGrpSpPr>
+      <p:grpSpPr>
+        <a:xfrm>
+          <a:off x="0" y="0"/>
+          <a:ext cx="0" cy="0"/>
+          <a:chOff x="0" y="0"/>
+          <a:chExt cx="0" cy="0"/>
+        </a:xfrm>
+      </p:grpSpPr>
+      <p:sp>
+        <p:nvSpPr>
+          <p:cNvPr id="2" name="Marcador de imagen de diapositiva 1"/>
+          <p:cNvSpPr>
+            <a:spLocks noGrp="1" noRot="1" noChangeAspect="1"/>
+          </p:cNvSpPr>
+          <p:nvPr>
+            <p:ph type="sldImg"/>
+          </p:nvPr>
+        </p:nvSpPr>
+        <p:spPr>
+          <a:xfrm>
+            <a:off x="381000" y="685800"/>
+            <a:ext cx="6096000" cy="3429000"/>
+          </a:xfrm>
+        </p:spPr>
+      </p:sp>
+      <p:sp>
+        <p:nvSpPr>
+          <p:cNvPr id="3" name="Marcador de notas 2"/>
+          <p:cNvSpPr>
+            <a:spLocks noGrp="1"/>
+          </p:cNvSpPr>
+          <p:nvPr>
+            <p:ph type="body" idx="1"/>
+          </p:nvPr>
+        </p:nvSpPr>
+        <p:spPr/>
+        <p:txBody>
+          <a:bodyPr/>
+          <a:lstStyle/>
+          <a:p>
+            <a:r>
+              <a:rPr lang="es-US" dirty="0"/>
+              <a:t>https://</a:t>
+            </a:r>
+            <a:r>
+              <a:rPr lang="es-US" dirty="0" err="1"/>
+              <a:t>commons.wikimedia.org</a:t>
+            </a:r>
+            <a:r>
+              <a:rPr lang="es-US" dirty="0"/>
+              <a:t>/wiki/</a:t>
+            </a:r>
+            <a:r>
+              <a:rPr lang="es-US" dirty="0" err="1"/>
+              <a:t>File:Raccoon_in_Central_Park</a:t>
+            </a:r>
+            <a:r>
+              <a:rPr lang="es-US" dirty="0"/>
+              <a:t>_(35264).</a:t>
+            </a:r>
+            <a:r>
+              <a:rPr lang="es-US" dirty="0" err="1"/>
+              <a:t>jpg</a:t>
+            </a:r>
+            <a:endParaRPr lang="es-US" dirty="0"/>
+          </a:p>
+        </p:txBody>
+      </p:sp>
+    </p:spTree>
+    <p:extLst>
+      <p:ext uri="{BB962C8B-B14F-4D97-AF65-F5344CB8AC3E}">
+        <p14:creationId xmlns:p14="http://schemas.microsoft.com/office/powerpoint/2010/main" val="3069895850"/>
+      </p:ext>
+    </p:extLst>
+  </p:cSld>
+  <p:clrMapOvr>
+    <a:masterClrMapping/>
+  </p:clrMapOvr>
+</p:notes>
+</file>
+
+<file path=ppt/notesSlides/notesSlide3.xml><?xml version="1.0" encoding="utf-8"?>
+<p:notes xmlns:a="http://schemas.openxmlformats.org/drawingml/2006/main" xmlns:r="http://schemas.openxmlformats.org/officeDocument/2006/relationships" xmlns:p="http://schemas.openxmlformats.org/presentationml/2006/main">
+  <p:cSld>
+    <p:spTree>
+      <p:nvGrpSpPr>
+        <p:cNvPr id="1" name=""/>
+        <p:cNvGrpSpPr/>
+        <p:nvPr/>
+      </p:nvGrpSpPr>
+      <p:grpSpPr>
+        <a:xfrm>
+          <a:off x="0" y="0"/>
+          <a:ext cx="0" cy="0"/>
+          <a:chOff x="0" y="0"/>
+          <a:chExt cx="0" cy="0"/>
+        </a:xfrm>
+      </p:grpSpPr>
+      <p:sp>
+        <p:nvSpPr>
+          <p:cNvPr id="2" name="Marcador de imagen de diapositiva 1"/>
+          <p:cNvSpPr>
+            <a:spLocks noGrp="1" noRot="1" noChangeAspect="1"/>
+          </p:cNvSpPr>
+          <p:nvPr>
+            <p:ph type="sldImg"/>
+          </p:nvPr>
+        </p:nvSpPr>
+        <p:spPr/>
+      </p:sp>
+      <p:sp>
+        <p:nvSpPr>
+          <p:cNvPr id="3" name="Marcador de notas 2"/>
+          <p:cNvSpPr>
+            <a:spLocks noGrp="1"/>
+          </p:cNvSpPr>
+          <p:nvPr>
+            <p:ph type="body" idx="1"/>
+          </p:nvPr>
+        </p:nvSpPr>
+        <p:spPr/>
+        <p:txBody>
+          <a:bodyPr/>
+          <a:lstStyle/>
+          <a:p>
+            <a:r>
+              <a:rPr lang="es-US" dirty="0"/>
+              <a:t>https://</a:t>
+            </a:r>
+            <a:r>
+              <a:rPr lang="es-US" dirty="0" err="1"/>
+              <a:t>commons.wikimedia.org</a:t>
+            </a:r>
+            <a:r>
+              <a:rPr lang="es-US" dirty="0"/>
+              <a:t>/wiki/File:Eastern_Grey_Squirrel_in_St_James%27s_Park,_London_-_Nov_2006_edit.jpg</a:t>
+            </a:r>
+          </a:p>
+        </p:txBody>
+      </p:sp>
+    </p:spTree>
+    <p:extLst>
+      <p:ext uri="{BB962C8B-B14F-4D97-AF65-F5344CB8AC3E}">
+        <p14:creationId xmlns:p14="http://schemas.microsoft.com/office/powerpoint/2010/main" val="2957091112"/>
+      </p:ext>
+    </p:extLst>
+  </p:cSld>
+  <p:clrMapOvr>
+    <a:masterClrMapping/>
+  </p:clrMapOvr>
+</p:notes>
+</file>
+
+<file path=ppt/notesSlides/notesSlide4.xml><?xml version="1.0" encoding="utf-8"?>
+<p:notes xmlns:a="http://schemas.openxmlformats.org/drawingml/2006/main" xmlns:r="http://schemas.openxmlformats.org/officeDocument/2006/relationships" xmlns:p="http://schemas.openxmlformats.org/presentationml/2006/main">
+  <p:cSld>
+    <p:spTree>
+      <p:nvGrpSpPr>
+        <p:cNvPr id="1" name=""/>
+        <p:cNvGrpSpPr/>
+        <p:nvPr/>
+      </p:nvGrpSpPr>
+      <p:grpSpPr>
+        <a:xfrm>
+          <a:off x="0" y="0"/>
+          <a:ext cx="0" cy="0"/>
+          <a:chOff x="0" y="0"/>
+          <a:chExt cx="0" cy="0"/>
+        </a:xfrm>
+      </p:grpSpPr>
+      <p:sp>
+        <p:nvSpPr>
+          <p:cNvPr id="2" name="Marcador de imagen de diapositiva 1"/>
+          <p:cNvSpPr>
+            <a:spLocks noGrp="1" noRot="1" noChangeAspect="1"/>
+          </p:cNvSpPr>
+          <p:nvPr>
+            <p:ph type="sldImg"/>
+          </p:nvPr>
+        </p:nvSpPr>
+        <p:spPr/>
+      </p:sp>
+      <p:sp>
+        <p:nvSpPr>
+          <p:cNvPr id="3" name="Marcador de notas 2"/>
+          <p:cNvSpPr>
+            <a:spLocks noGrp="1"/>
+          </p:cNvSpPr>
+          <p:nvPr>
+            <p:ph type="body" idx="1"/>
+          </p:nvPr>
+        </p:nvSpPr>
+        <p:spPr/>
+        <p:txBody>
+          <a:bodyPr/>
+          <a:lstStyle/>
+          <a:p>
+            <a:r>
+              <a:rPr lang="es-US" dirty="0"/>
+              <a:t>https://</a:t>
+            </a:r>
+            <a:r>
+              <a:rPr lang="es-US" dirty="0" err="1"/>
+              <a:t>commons.wikimedia.org</a:t>
+            </a:r>
+            <a:r>
+              <a:rPr lang="es-US" dirty="0"/>
+              <a:t>/wiki/File:2014-04-29_01_Northwestern_crow_(</a:t>
+            </a:r>
+            <a:r>
+              <a:rPr lang="es-US" dirty="0" err="1"/>
+              <a:t>Corvus_brachyrhynchos_caurinus</a:t>
+            </a:r>
+            <a:r>
+              <a:rPr lang="es-US" dirty="0"/>
+              <a:t>).</a:t>
+            </a:r>
+            <a:r>
+              <a:rPr lang="es-US" dirty="0" err="1"/>
+              <a:t>jpg#Licensing</a:t>
+            </a:r>
+            <a:endParaRPr lang="es-US" dirty="0"/>
+          </a:p>
+        </p:txBody>
+      </p:sp>
+    </p:spTree>
+    <p:extLst>
+      <p:ext uri="{BB962C8B-B14F-4D97-AF65-F5344CB8AC3E}">
+        <p14:creationId xmlns:p14="http://schemas.microsoft.com/office/powerpoint/2010/main" val="3970236416"/>
+      </p:ext>
+    </p:extLst>
+  </p:cSld>
+  <p:clrMapOvr>
+    <a:masterClrMapping/>
+  </p:clrMapOvr>
+</p:notes>
+</file>
+
+<file path=ppt/notesSlides/notesSlide5.xml><?xml version="1.0" encoding="utf-8"?>
+<p:notes xmlns:a="http://schemas.openxmlformats.org/drawingml/2006/main" xmlns:r="http://schemas.openxmlformats.org/officeDocument/2006/relationships" xmlns:p="http://schemas.openxmlformats.org/presentationml/2006/main">
+  <p:cSld>
+    <p:spTree>
+      <p:nvGrpSpPr>
+        <p:cNvPr id="1" name=""/>
+        <p:cNvGrpSpPr/>
+        <p:nvPr/>
+      </p:nvGrpSpPr>
+      <p:grpSpPr>
+        <a:xfrm>
+          <a:off x="0" y="0"/>
+          <a:ext cx="0" cy="0"/>
+          <a:chOff x="0" y="0"/>
+          <a:chExt cx="0" cy="0"/>
+        </a:xfrm>
+      </p:grpSpPr>
+      <p:sp>
+        <p:nvSpPr>
+          <p:cNvPr id="2" name="Marcador de imagen de diapositiva 1"/>
+          <p:cNvSpPr>
+            <a:spLocks noGrp="1" noRot="1" noChangeAspect="1"/>
+          </p:cNvSpPr>
+          <p:nvPr>
+            <p:ph type="sldImg"/>
+          </p:nvPr>
+        </p:nvSpPr>
+        <p:spPr/>
+      </p:sp>
+      <p:sp>
+        <p:nvSpPr>
+          <p:cNvPr id="3" name="Marcador de notas 2"/>
+          <p:cNvSpPr>
+            <a:spLocks noGrp="1"/>
+          </p:cNvSpPr>
+          <p:nvPr>
+            <p:ph type="body" idx="1"/>
+          </p:nvPr>
+        </p:nvSpPr>
+        <p:spPr/>
+        <p:txBody>
+          <a:bodyPr/>
+          <a:lstStyle/>
+          <a:p>
+            <a:r>
+              <a:rPr lang="es-US" dirty="0"/>
+              <a:t>https://</a:t>
+            </a:r>
+            <a:r>
+              <a:rPr lang="es-US" dirty="0" err="1"/>
+              <a:t>commons.wikimedia.org</a:t>
+            </a:r>
+            <a:r>
+              <a:rPr lang="es-US" dirty="0"/>
+              <a:t>/wiki/File:Turdus-migratorius-002.jpg#filelinks</a:t>
+            </a:r>
+          </a:p>
+        </p:txBody>
+      </p:sp>
+    </p:spTree>
+    <p:extLst>
+      <p:ext uri="{BB962C8B-B14F-4D97-AF65-F5344CB8AC3E}">
+        <p14:creationId xmlns:p14="http://schemas.microsoft.com/office/powerpoint/2010/main" val="1388670676"/>
+      </p:ext>
+    </p:extLst>
+  </p:cSld>
+  <p:clrMapOvr>
+    <a:masterClrMapping/>
+  </p:clrMapOvr>
+</p:notes>
+</file>
+
+<file path=ppt/notesSlides/notesSlide6.xml><?xml version="1.0" encoding="utf-8"?>
+<p:notes xmlns:a="http://schemas.openxmlformats.org/drawingml/2006/main" xmlns:r="http://schemas.openxmlformats.org/officeDocument/2006/relationships" xmlns:p="http://schemas.openxmlformats.org/presentationml/2006/main">
+  <p:cSld>
+    <p:spTree>
+      <p:nvGrpSpPr>
+        <p:cNvPr id="1" name=""/>
+        <p:cNvGrpSpPr/>
+        <p:nvPr/>
+      </p:nvGrpSpPr>
+      <p:grpSpPr>
+        <a:xfrm>
+          <a:off x="0" y="0"/>
+          <a:ext cx="0" cy="0"/>
+          <a:chOff x="0" y="0"/>
+          <a:chExt cx="0" cy="0"/>
+        </a:xfrm>
+      </p:grpSpPr>
+      <p:sp>
+        <p:nvSpPr>
+          <p:cNvPr id="2" name="Marcador de imagen de diapositiva 1"/>
+          <p:cNvSpPr>
+            <a:spLocks noGrp="1" noRot="1" noChangeAspect="1"/>
+          </p:cNvSpPr>
+          <p:nvPr>
+            <p:ph type="sldImg"/>
+          </p:nvPr>
+        </p:nvSpPr>
+        <p:spPr/>
+      </p:sp>
+      <p:sp>
+        <p:nvSpPr>
+          <p:cNvPr id="3" name="Marcador de notas 2"/>
+          <p:cNvSpPr>
+            <a:spLocks noGrp="1"/>
+          </p:cNvSpPr>
+          <p:nvPr>
+            <p:ph type="body" idx="1"/>
+          </p:nvPr>
+        </p:nvSpPr>
+        <p:spPr/>
+        <p:txBody>
+          <a:bodyPr/>
+          <a:lstStyle/>
+          <a:p>
+            <a:r>
+              <a:rPr lang="es-US" dirty="0"/>
+              <a:t>https://</a:t>
+            </a:r>
+            <a:r>
+              <a:rPr lang="es-US" dirty="0" err="1"/>
+              <a:t>commons.wikimedia.org</a:t>
+            </a:r>
+            <a:r>
+              <a:rPr lang="es-US" dirty="0"/>
+              <a:t>/wiki/</a:t>
+            </a:r>
+            <a:r>
+              <a:rPr lang="es-US" dirty="0" err="1"/>
+              <a:t>File:Turdus_viscivorus_Brych_y_coed.jpg</a:t>
+            </a:r>
+            <a:endParaRPr lang="es-US" dirty="0"/>
+          </a:p>
+        </p:txBody>
+      </p:sp>
+    </p:spTree>
+    <p:extLst>
+      <p:ext uri="{BB962C8B-B14F-4D97-AF65-F5344CB8AC3E}">
+        <p14:creationId xmlns:p14="http://schemas.microsoft.com/office/powerpoint/2010/main" val="1301013057"/>
+      </p:ext>
+    </p:extLst>
+  </p:cSld>
+  <p:clrMapOvr>
+    <a:masterClrMapping/>
+  </p:clrMapOvr>
+</p:notes>
+</file>
+
+<file path=ppt/notesSlides/notesSlide7.xml><?xml version="1.0" encoding="utf-8"?>
+<p:notes xmlns:a="http://schemas.openxmlformats.org/drawingml/2006/main" xmlns:r="http://schemas.openxmlformats.org/officeDocument/2006/relationships" xmlns:p="http://schemas.openxmlformats.org/presentationml/2006/main">
+  <p:cSld>
+    <p:spTree>
+      <p:nvGrpSpPr>
+        <p:cNvPr id="1" name=""/>
+        <p:cNvGrpSpPr/>
+        <p:nvPr/>
+      </p:nvGrpSpPr>
+      <p:grpSpPr>
+        <a:xfrm>
+          <a:off x="0" y="0"/>
+          <a:ext cx="0" cy="0"/>
+          <a:chOff x="0" y="0"/>
+          <a:chExt cx="0" cy="0"/>
+        </a:xfrm>
+      </p:grpSpPr>
+      <p:sp>
+        <p:nvSpPr>
+          <p:cNvPr id="2" name="Marcador de imagen de diapositiva 1"/>
+          <p:cNvSpPr>
+            <a:spLocks noGrp="1" noRot="1" noChangeAspect="1"/>
+          </p:cNvSpPr>
+          <p:nvPr>
+            <p:ph type="sldImg"/>
+          </p:nvPr>
+        </p:nvSpPr>
+        <p:spPr>
+          <a:xfrm>
+            <a:off x="381000" y="685800"/>
+            <a:ext cx="6096000" cy="3429000"/>
+          </a:xfrm>
+        </p:spPr>
+      </p:sp>
+      <p:sp>
+        <p:nvSpPr>
+          <p:cNvPr id="3" name="Marcador de notas 2"/>
+          <p:cNvSpPr>
+            <a:spLocks noGrp="1"/>
+          </p:cNvSpPr>
+          <p:nvPr>
+            <p:ph type="body" idx="1"/>
+          </p:nvPr>
+        </p:nvSpPr>
+        <p:spPr/>
+        <p:txBody>
+          <a:bodyPr/>
+          <a:lstStyle/>
+          <a:p>
+            <a:r>
+              <a:rPr lang="es-US" b="1" dirty="0"/>
+              <a:t>https://</a:t>
+            </a:r>
+            <a:r>
+              <a:rPr lang="es-US" b="1" dirty="0" err="1"/>
+              <a:t>commons.wikimedia.org</a:t>
+            </a:r>
+            <a:r>
+              <a:rPr lang="es-US" b="1" dirty="0"/>
+              <a:t>/wiki/File:Acorn_woodpecker_holding_a_nut_in_its_beak-0225.jpg#Licensing</a:t>
+            </a:r>
+          </a:p>
+        </p:txBody>
+      </p:sp>
+    </p:spTree>
+    <p:extLst>
+      <p:ext uri="{BB962C8B-B14F-4D97-AF65-F5344CB8AC3E}">
+        <p14:creationId xmlns:p14="http://schemas.microsoft.com/office/powerpoint/2010/main" val="2777042685"/>
+      </p:ext>
+    </p:extLst>
+  </p:cSld>
+  <p:clrMapOvr>
+    <a:masterClrMapping/>
+  </p:clrMapOvr>
+</p:notes>
+</file>
+
+<file path=ppt/notesSlides/notesSlide8.xml><?xml version="1.0" encoding="utf-8"?>
+<p:notes xmlns:a="http://schemas.openxmlformats.org/drawingml/2006/main" xmlns:r="http://schemas.openxmlformats.org/officeDocument/2006/relationships" xmlns:p="http://schemas.openxmlformats.org/presentationml/2006/main">
+  <p:cSld>
+    <p:spTree>
+      <p:nvGrpSpPr>
+        <p:cNvPr id="1" name=""/>
+        <p:cNvGrpSpPr/>
+        <p:nvPr/>
+      </p:nvGrpSpPr>
+      <p:grpSpPr>
+        <a:xfrm>
+          <a:off x="0" y="0"/>
+          <a:ext cx="0" cy="0"/>
+          <a:chOff x="0" y="0"/>
+          <a:chExt cx="0" cy="0"/>
+        </a:xfrm>
+      </p:grpSpPr>
+      <p:sp>
+        <p:nvSpPr>
+          <p:cNvPr id="2" name="Marcador de imagen de diapositiva 1"/>
+          <p:cNvSpPr>
+            <a:spLocks noGrp="1" noRot="1" noChangeAspect="1"/>
+          </p:cNvSpPr>
+          <p:nvPr>
+            <p:ph type="sldImg"/>
+          </p:nvPr>
+        </p:nvSpPr>
+        <p:spPr>
+          <a:xfrm>
+            <a:off x="381000" y="685800"/>
+            <a:ext cx="6096000" cy="3429000"/>
+          </a:xfrm>
+        </p:spPr>
+      </p:sp>
+      <p:sp>
+        <p:nvSpPr>
+          <p:cNvPr id="3" name="Marcador de notas 2"/>
+          <p:cNvSpPr>
+            <a:spLocks noGrp="1"/>
+          </p:cNvSpPr>
+          <p:nvPr>
+            <p:ph type="body" idx="1"/>
+          </p:nvPr>
+        </p:nvSpPr>
+        <p:spPr/>
+        <p:txBody>
+          <a:bodyPr/>
+          <a:lstStyle/>
+          <a:p>
+            <a:r>
+              <a:rPr lang="es-US" dirty="0"/>
+              <a:t>https://</a:t>
+            </a:r>
+            <a:r>
+              <a:rPr lang="es-US" dirty="0" err="1"/>
+              <a:t>commons.wikimedia.org</a:t>
+            </a:r>
+            <a:r>
+              <a:rPr lang="es-US" dirty="0"/>
+              <a:t>/wiki/</a:t>
+            </a:r>
+            <a:r>
+              <a:rPr lang="es-US" dirty="0" err="1"/>
+              <a:t>File:Great_blue_heron_in_GWC</a:t>
+            </a:r>
+            <a:r>
+              <a:rPr lang="es-US" dirty="0"/>
+              <a:t>_(16570).</a:t>
+            </a:r>
+            <a:r>
+              <a:rPr lang="es-US" dirty="0" err="1"/>
+              <a:t>jpg</a:t>
+            </a:r>
+            <a:endParaRPr lang="es-US" dirty="0"/>
+          </a:p>
+        </p:txBody>
+      </p:sp>
+    </p:spTree>
+    <p:extLst>
+      <p:ext uri="{BB962C8B-B14F-4D97-AF65-F5344CB8AC3E}">
+        <p14:creationId xmlns:p14="http://schemas.microsoft.com/office/powerpoint/2010/main" val="3743771136"/>
+      </p:ext>
+    </p:extLst>
+  </p:cSld>
+  <p:clrMapOvr>
+    <a:masterClrMapping/>
+  </p:clrMapOvr>
+</p:notes>
+</file>
+
+<file path=ppt/notesSlides/notesSlide9.xml><?xml version="1.0" encoding="utf-8"?>
+<p:notes xmlns:a="http://schemas.openxmlformats.org/drawingml/2006/main" xmlns:r="http://schemas.openxmlformats.org/officeDocument/2006/relationships" xmlns:p="http://schemas.openxmlformats.org/presentationml/2006/main">
+  <p:cSld>
+    <p:spTree>
+      <p:nvGrpSpPr>
+        <p:cNvPr id="1" name=""/>
+        <p:cNvGrpSpPr/>
+        <p:nvPr/>
+      </p:nvGrpSpPr>
+      <p:grpSpPr>
+        <a:xfrm>
+          <a:off x="0" y="0"/>
+          <a:ext cx="0" cy="0"/>
+          <a:chOff x="0" y="0"/>
+          <a:chExt cx="0" cy="0"/>
+        </a:xfrm>
+      </p:grpSpPr>
+      <p:sp>
+        <p:nvSpPr>
+          <p:cNvPr id="2" name="Marcador de imagen de diapositiva 1"/>
+          <p:cNvSpPr>
+            <a:spLocks noGrp="1" noRot="1" noChangeAspect="1"/>
+          </p:cNvSpPr>
+          <p:nvPr>
+            <p:ph type="sldImg"/>
+          </p:nvPr>
+        </p:nvSpPr>
+        <p:spPr/>
+      </p:sp>
+      <p:sp>
+        <p:nvSpPr>
+          <p:cNvPr id="3" name="Marcador de notas 2"/>
+          <p:cNvSpPr>
+            <a:spLocks noGrp="1"/>
+          </p:cNvSpPr>
+          <p:nvPr>
+            <p:ph type="body" idx="1"/>
+          </p:nvPr>
+        </p:nvSpPr>
+        <p:spPr/>
+        <p:txBody>
+          <a:bodyPr/>
+          <a:lstStyle/>
+          <a:p>
+            <a:r>
+              <a:rPr lang="es-US" dirty="0"/>
+              <a:t>https://</a:t>
+            </a:r>
+            <a:r>
+              <a:rPr lang="es-US" dirty="0" err="1"/>
+              <a:t>commons.wikimedia.org</a:t>
+            </a:r>
+            <a:r>
+              <a:rPr lang="es-US" dirty="0"/>
+              <a:t>/wiki/File:2022-11-20,_Ducks,_Lake_Morton_of_King_County,_Washington,_24.jpg</a:t>
+            </a:r>
+          </a:p>
+        </p:txBody>
+      </p:sp>
+    </p:spTree>
+    <p:extLst>
+      <p:ext uri="{BB962C8B-B14F-4D97-AF65-F5344CB8AC3E}">
+        <p14:creationId xmlns:p14="http://schemas.microsoft.com/office/powerpoint/2010/main" val="2299497756"/>
+      </p:ext>
+    </p:extLst>
+  </p:cSld>
+  <p:clrMapOvr>
+    <a:masterClrMapping/>
+  </p:clrMapOvr>
+</p:notes>
+</file>
+
 <file path=ppt/slideLayouts/slideLayout1.xml><?xml version="1.0" encoding="utf-8"?>
 <p:sldLayout xmlns:a="http://schemas.openxmlformats.org/drawingml/2006/main" xmlns:r="http://schemas.openxmlformats.org/officeDocument/2006/relationships" xmlns:p="http://schemas.openxmlformats.org/presentationml/2006/main" matchingName="Title slide" type="title">
   <p:cSld name="TITLE">
@@ -5245,7 +5610,7 @@
           <a:p>
             <a:fld id="{5451A1B7-44B2-D64C-B9FB-3CE0E8D85382}" type="datetimeFigureOut">
               <a:rPr lang="es-PR" smtClean="0"/>
-              <a:t>10/21/26</a:t>
+              <a:t>10/23/26</a:t>
             </a:fld>
             <a:endParaRPr lang="es-PR"/>
           </a:p>
@@ -9395,8 +9760,8 @@
           </p:pic>
         </mc:Fallback>
       </mc:AlternateContent>
-      <mc:AlternateContent xmlns:mc="http://schemas.openxmlformats.org/markup-compatibility/2006">
-        <mc:Choice xmlns:p14="http://schemas.microsoft.com/office/powerpoint/2010/main" Requires="p14">
+      <mc:AlternateContent xmlns:mc="http://schemas.openxmlformats.org/markup-compatibility/2006" xmlns:p14="http://schemas.microsoft.com/office/powerpoint/2010/main">
+        <mc:Choice Requires="p14">
           <p:contentPart p14:bwMode="auto" r:id="rId6">
             <p14:nvContentPartPr>
               <p14:cNvPr id="37" name="Entrada de lápiz 36">
@@ -9415,7 +9780,7 @@
             </p14:xfrm>
           </p:contentPart>
         </mc:Choice>
-        <mc:Fallback>
+        <mc:Fallback xmlns="">
           <p:pic>
             <p:nvPicPr>
               <p:cNvPr id="37" name="Entrada de lápiz 36">
@@ -15184,33 +15549,6 @@
       </p:grpSpPr>
       <p:sp>
         <p:nvSpPr>
-          <p:cNvPr id="2" name="Título 1">
-            <a:extLst>
-              <a:ext uri="{FF2B5EF4-FFF2-40B4-BE49-F238E27FC236}">
-                <a16:creationId xmlns:a16="http://schemas.microsoft.com/office/drawing/2014/main" id="{109B493E-3B76-A30D-FEE7-8537AAA82538}"/>
-              </a:ext>
-            </a:extLst>
-          </p:cNvPr>
-          <p:cNvSpPr>
-            <a:spLocks noGrp="1"/>
-          </p:cNvSpPr>
-          <p:nvPr>
-            <p:ph type="title"/>
-          </p:nvPr>
-        </p:nvSpPr>
-        <p:spPr/>
-        <p:txBody>
-          <a:bodyPr>
-            <a:normAutofit fontScale="90000"/>
-          </a:bodyPr>
-          <a:lstStyle/>
-          <a:p>
-            <a:endParaRPr lang="es-PR"/>
-          </a:p>
-        </p:txBody>
-      </p:sp>
-      <p:sp>
-        <p:nvSpPr>
           <p:cNvPr id="3" name="Marcador de contenido 2">
             <a:extLst>
               <a:ext uri="{FF2B5EF4-FFF2-40B4-BE49-F238E27FC236}">
@@ -15230,65 +15568,448 @@
           <a:bodyPr/>
           <a:lstStyle/>
           <a:p>
-            <a:endParaRPr lang="es-PR"/>
+            <a:pPr marL="114300" indent="0">
+              <a:buNone/>
+            </a:pPr>
+            <a:r>
+              <a:rPr lang="es-PR" dirty="0">
+                <a:solidFill>
+                  <a:schemeClr val="tx1"/>
+                </a:solidFill>
+              </a:rPr>
+              <a:t>Ducks</a:t>
+            </a:r>
+          </a:p>
+          <a:p>
+            <a:pPr marL="114300" indent="0">
+              <a:buNone/>
+            </a:pPr>
+            <a:r>
+              <a:rPr lang="es-US" dirty="0" err="1">
+                <a:solidFill>
+                  <a:schemeClr val="tx1"/>
+                </a:solidFill>
+              </a:rPr>
+              <a:t>Anatidae</a:t>
+            </a:r>
+            <a:r>
+              <a:rPr lang="es-US" dirty="0">
+                <a:solidFill>
+                  <a:schemeClr val="tx1"/>
+                </a:solidFill>
+              </a:rPr>
+              <a:t> fam.</a:t>
+            </a:r>
+          </a:p>
+          <a:p>
+            <a:pPr marL="114300" indent="0">
+              <a:buNone/>
+            </a:pPr>
+            <a:r>
+              <a:rPr lang="es-US" dirty="0">
+                <a:solidFill>
+                  <a:schemeClr val="tx1"/>
+                </a:solidFill>
+              </a:rPr>
+              <a:t>Wild</a:t>
+            </a:r>
+          </a:p>
+          <a:p>
+            <a:pPr marL="114300" indent="0">
+              <a:buNone/>
+            </a:pPr>
+            <a:r>
+              <a:rPr lang="es-US" dirty="0">
+                <a:solidFill>
+                  <a:schemeClr val="tx1"/>
+                </a:solidFill>
+              </a:rPr>
+              <a:t>WA</a:t>
+            </a:r>
+          </a:p>
+          <a:p>
+            <a:pPr marL="114300" indent="0">
+              <a:buNone/>
+            </a:pPr>
+            <a:r>
+              <a:rPr lang="es-PR" dirty="0"/>
+              <a:t> </a:t>
+            </a:r>
           </a:p>
         </p:txBody>
       </p:sp>
-      <mc:AlternateContent xmlns:mc="http://schemas.openxmlformats.org/markup-compatibility/2006" xmlns:p14="http://schemas.microsoft.com/office/powerpoint/2010/main">
-        <mc:Choice Requires="p14">
-          <p:contentPart p14:bwMode="auto" r:id="rId2">
-            <p14:nvContentPartPr>
-              <p14:cNvPr id="10" name="Entrada de lápiz 9">
-                <a:extLst>
-                  <a:ext uri="{FF2B5EF4-FFF2-40B4-BE49-F238E27FC236}">
-                    <a16:creationId xmlns:a16="http://schemas.microsoft.com/office/drawing/2014/main" id="{A91D69D8-966B-DF05-0A81-EF6A8588A5F3}"/>
-                  </a:ext>
-                </a:extLst>
-              </p14:cNvPr>
-              <p14:cNvContentPartPr/>
-              <p14:nvPr/>
-            </p14:nvContentPartPr>
-            <p14:xfrm>
-              <a:off x="942781" y="948822"/>
-              <a:ext cx="824580" cy="348570"/>
-            </p14:xfrm>
-          </p:contentPart>
-        </mc:Choice>
-        <mc:Fallback xmlns="">
-          <p:pic>
-            <p:nvPicPr>
-              <p:cNvPr id="10" name="Entrada de lápiz 9">
-                <a:extLst>
-                  <a:ext uri="{FF2B5EF4-FFF2-40B4-BE49-F238E27FC236}">
-                    <a16:creationId xmlns:a16="http://schemas.microsoft.com/office/drawing/2014/main" id="{A91D69D8-966B-DF05-0A81-EF6A8588A5F3}"/>
-                  </a:ext>
-                </a:extLst>
-              </p:cNvPr>
-              <p:cNvPicPr/>
-              <p:nvPr/>
-            </p:nvPicPr>
-            <p:blipFill>
-              <a:blip r:embed="rId3"/>
-              <a:stretch>
-                <a:fillRect/>
-              </a:stretch>
-            </p:blipFill>
-            <p:spPr>
-              <a:xfrm>
-                <a:off x="931979" y="938030"/>
-                <a:ext cx="845825" cy="369794"/>
-              </a:xfrm>
-              <a:prstGeom prst="rect">
-                <a:avLst/>
-              </a:prstGeom>
-            </p:spPr>
-          </p:pic>
-        </mc:Fallback>
-      </mc:AlternateContent>
+      <p:pic>
+        <p:nvPicPr>
+          <p:cNvPr id="4" name="Imagen 3" descr="File:2022-11-20, Ducks, Lake Morton of King County, Washington, 24.jpg">
+            <a:extLst>
+              <a:ext uri="{FF2B5EF4-FFF2-40B4-BE49-F238E27FC236}">
+                <a16:creationId xmlns:a16="http://schemas.microsoft.com/office/drawing/2014/main" id="{D3CE4D7B-D56A-54D0-125F-0EA8C15F70B9}"/>
+              </a:ext>
+            </a:extLst>
+          </p:cNvPr>
+          <p:cNvPicPr>
+            <a:picLocks noChangeAspect="1"/>
+          </p:cNvPicPr>
+          <p:nvPr/>
+        </p:nvPicPr>
+        <p:blipFill>
+          <a:blip r:embed="rId3"/>
+          <a:stretch>
+            <a:fillRect/>
+          </a:stretch>
+        </p:blipFill>
+        <p:spPr>
+          <a:xfrm>
+            <a:off x="2340032" y="642158"/>
+            <a:ext cx="5145579" cy="3859184"/>
+          </a:xfrm>
+          <a:prstGeom prst="rect">
+            <a:avLst/>
+          </a:prstGeom>
+        </p:spPr>
+      </p:pic>
     </p:spTree>
     <p:extLst>
       <p:ext uri="{BB962C8B-B14F-4D97-AF65-F5344CB8AC3E}">
         <p14:creationId xmlns:p14="http://schemas.microsoft.com/office/powerpoint/2010/main" val="3534877653"/>
+      </p:ext>
+    </p:extLst>
+  </p:cSld>
+  <p:clrMapOvr>
+    <a:masterClrMapping/>
+  </p:clrMapOvr>
+</p:sld>
+</file>
+
+<file path=ppt/slides/slide11.xml><?xml version="1.0" encoding="utf-8"?>
+<p:sld xmlns:a="http://schemas.openxmlformats.org/drawingml/2006/main" xmlns:r="http://schemas.openxmlformats.org/officeDocument/2006/relationships" xmlns:p="http://schemas.openxmlformats.org/presentationml/2006/main">
+  <p:cSld>
+    <p:spTree>
+      <p:nvGrpSpPr>
+        <p:cNvPr id="1" name=""/>
+        <p:cNvGrpSpPr/>
+        <p:nvPr/>
+      </p:nvGrpSpPr>
+      <p:grpSpPr>
+        <a:xfrm>
+          <a:off x="0" y="0"/>
+          <a:ext cx="0" cy="0"/>
+          <a:chOff x="0" y="0"/>
+          <a:chExt cx="0" cy="0"/>
+        </a:xfrm>
+      </p:grpSpPr>
+      <p:sp>
+        <p:nvSpPr>
+          <p:cNvPr id="2" name="Título 1">
+            <a:extLst>
+              <a:ext uri="{FF2B5EF4-FFF2-40B4-BE49-F238E27FC236}">
+                <a16:creationId xmlns:a16="http://schemas.microsoft.com/office/drawing/2014/main" id="{9FF7EB43-6C0B-9B4C-9C3B-3689165427F5}"/>
+              </a:ext>
+            </a:extLst>
+          </p:cNvPr>
+          <p:cNvSpPr>
+            <a:spLocks noGrp="1"/>
+          </p:cNvSpPr>
+          <p:nvPr>
+            <p:ph type="title"/>
+          </p:nvPr>
+        </p:nvSpPr>
+        <p:spPr/>
+        <p:txBody>
+          <a:bodyPr>
+            <a:normAutofit fontScale="90000"/>
+          </a:bodyPr>
+          <a:lstStyle/>
+          <a:p>
+            <a:r>
+              <a:rPr lang="es-US" dirty="0" err="1"/>
+              <a:t>Slides</a:t>
+            </a:r>
+            <a:r>
+              <a:rPr lang="es-US" dirty="0"/>
+              <a:t> </a:t>
+            </a:r>
+            <a:r>
+              <a:rPr lang="es-US" dirty="0" err="1"/>
+              <a:t>with</a:t>
+            </a:r>
+            <a:r>
+              <a:rPr lang="es-US" dirty="0"/>
+              <a:t> </a:t>
+            </a:r>
+            <a:r>
+              <a:rPr lang="es-US" dirty="0" err="1"/>
+              <a:t>worms</a:t>
+            </a:r>
+            <a:r>
+              <a:rPr lang="es-US" dirty="0"/>
+              <a:t>!</a:t>
+            </a:r>
+          </a:p>
+        </p:txBody>
+      </p:sp>
+      <p:sp>
+        <p:nvSpPr>
+          <p:cNvPr id="3" name="Marcador de contenido 2">
+            <a:extLst>
+              <a:ext uri="{FF2B5EF4-FFF2-40B4-BE49-F238E27FC236}">
+                <a16:creationId xmlns:a16="http://schemas.microsoft.com/office/drawing/2014/main" id="{CB7C8ADE-A305-EB92-AC3D-B61A1F716614}"/>
+              </a:ext>
+            </a:extLst>
+          </p:cNvPr>
+          <p:cNvSpPr>
+            <a:spLocks noGrp="1"/>
+          </p:cNvSpPr>
+          <p:nvPr>
+            <p:ph idx="1"/>
+          </p:nvPr>
+        </p:nvSpPr>
+        <p:spPr/>
+        <p:txBody>
+          <a:bodyPr/>
+          <a:lstStyle/>
+          <a:p>
+            <a:r>
+              <a:rPr lang="es-US" i="1" dirty="0" err="1">
+                <a:solidFill>
+                  <a:schemeClr val="tx1"/>
+                </a:solidFill>
+              </a:rPr>
+              <a:t>Taenia</a:t>
+            </a:r>
+            <a:r>
+              <a:rPr lang="es-US" i="1" dirty="0">
+                <a:solidFill>
+                  <a:schemeClr val="tx1"/>
+                </a:solidFill>
+              </a:rPr>
+              <a:t> </a:t>
+            </a:r>
+            <a:r>
+              <a:rPr lang="es-US" i="1" dirty="0" err="1">
+                <a:solidFill>
+                  <a:schemeClr val="tx1"/>
+                </a:solidFill>
+              </a:rPr>
+              <a:t>pisiformis</a:t>
+            </a:r>
+            <a:r>
+              <a:rPr lang="es-US" dirty="0">
+                <a:solidFill>
+                  <a:schemeClr val="tx1"/>
+                </a:solidFill>
+              </a:rPr>
+              <a:t> </a:t>
+            </a:r>
+            <a:r>
+              <a:rPr lang="es-US" dirty="0" err="1">
+                <a:solidFill>
+                  <a:schemeClr val="tx1"/>
+                </a:solidFill>
+              </a:rPr>
+              <a:t>or</a:t>
+            </a:r>
+            <a:r>
+              <a:rPr lang="es-US" dirty="0">
+                <a:solidFill>
+                  <a:schemeClr val="tx1"/>
+                </a:solidFill>
+              </a:rPr>
+              <a:t> </a:t>
+            </a:r>
+            <a:r>
+              <a:rPr lang="es-US" i="1" dirty="0" err="1">
+                <a:solidFill>
+                  <a:schemeClr val="tx1"/>
+                </a:solidFill>
+              </a:rPr>
+              <a:t>Taenia</a:t>
+            </a:r>
+            <a:r>
+              <a:rPr lang="es-US" i="1" dirty="0">
+                <a:solidFill>
+                  <a:schemeClr val="tx1"/>
+                </a:solidFill>
+              </a:rPr>
+              <a:t> </a:t>
+            </a:r>
+            <a:r>
+              <a:rPr lang="es-US" i="1" dirty="0" err="1">
+                <a:solidFill>
+                  <a:schemeClr val="tx1"/>
+                </a:solidFill>
+              </a:rPr>
+              <a:t>saginata</a:t>
+            </a:r>
+            <a:endParaRPr lang="es-US" dirty="0">
+              <a:solidFill>
+                <a:schemeClr val="tx1"/>
+              </a:solidFill>
+            </a:endParaRPr>
+          </a:p>
+          <a:p>
+            <a:r>
+              <a:rPr lang="es-US" i="1" dirty="0" err="1">
+                <a:solidFill>
+                  <a:schemeClr val="tx1"/>
+                </a:solidFill>
+              </a:rPr>
+              <a:t>Echinococcus</a:t>
+            </a:r>
+            <a:r>
+              <a:rPr lang="es-US" i="1" dirty="0">
+                <a:solidFill>
+                  <a:schemeClr val="tx1"/>
+                </a:solidFill>
+              </a:rPr>
+              <a:t> </a:t>
+            </a:r>
+            <a:r>
+              <a:rPr lang="es-US" i="1" dirty="0" err="1">
+                <a:solidFill>
+                  <a:schemeClr val="tx1"/>
+                </a:solidFill>
+              </a:rPr>
+              <a:t>granulosus</a:t>
+            </a:r>
+            <a:r>
+              <a:rPr lang="es-US" dirty="0">
+                <a:solidFill>
+                  <a:schemeClr val="tx1"/>
+                </a:solidFill>
+              </a:rPr>
+              <a:t> </a:t>
+            </a:r>
+            <a:r>
+              <a:rPr lang="es-US" dirty="0" err="1">
+                <a:solidFill>
+                  <a:schemeClr val="tx1"/>
+                </a:solidFill>
+              </a:rPr>
+              <a:t>adult</a:t>
+            </a:r>
+            <a:endParaRPr lang="es-US" dirty="0">
+              <a:solidFill>
+                <a:schemeClr val="tx1"/>
+              </a:solidFill>
+            </a:endParaRPr>
+          </a:p>
+          <a:p>
+            <a:r>
+              <a:rPr lang="es-US" i="1" dirty="0" err="1">
+                <a:solidFill>
+                  <a:schemeClr val="tx1"/>
+                </a:solidFill>
+              </a:rPr>
+              <a:t>Echinococcus</a:t>
+            </a:r>
+            <a:r>
+              <a:rPr lang="es-US" i="1" dirty="0">
+                <a:solidFill>
+                  <a:schemeClr val="tx1"/>
+                </a:solidFill>
+              </a:rPr>
+              <a:t> </a:t>
+            </a:r>
+            <a:r>
+              <a:rPr lang="es-US" i="1" dirty="0" err="1">
+                <a:solidFill>
+                  <a:schemeClr val="tx1"/>
+                </a:solidFill>
+              </a:rPr>
+              <a:t>granulosus</a:t>
+            </a:r>
+            <a:r>
+              <a:rPr lang="es-US" dirty="0">
+                <a:solidFill>
+                  <a:schemeClr val="tx1"/>
+                </a:solidFill>
+              </a:rPr>
+              <a:t> </a:t>
+            </a:r>
+            <a:r>
+              <a:rPr lang="es-US" dirty="0" err="1">
+                <a:solidFill>
+                  <a:schemeClr val="tx1"/>
+                </a:solidFill>
+              </a:rPr>
+              <a:t>hydatid</a:t>
+            </a:r>
+            <a:r>
+              <a:rPr lang="es-US" dirty="0">
+                <a:solidFill>
+                  <a:schemeClr val="tx1"/>
+                </a:solidFill>
+              </a:rPr>
+              <a:t> </a:t>
+            </a:r>
+            <a:r>
+              <a:rPr lang="es-US" dirty="0" err="1">
+                <a:solidFill>
+                  <a:schemeClr val="tx1"/>
+                </a:solidFill>
+              </a:rPr>
+              <a:t>cyst</a:t>
+            </a:r>
+            <a:endParaRPr lang="es-US" dirty="0">
+              <a:solidFill>
+                <a:schemeClr val="tx1"/>
+              </a:solidFill>
+            </a:endParaRPr>
+          </a:p>
+          <a:p>
+            <a:pPr marL="114300" indent="0">
+              <a:buNone/>
+            </a:pPr>
+            <a:br>
+              <a:rPr lang="es-US" dirty="0">
+                <a:solidFill>
+                  <a:schemeClr val="tx1"/>
+                </a:solidFill>
+              </a:rPr>
+            </a:br>
+            <a:endParaRPr lang="es-US" dirty="0">
+              <a:solidFill>
+                <a:schemeClr val="tx1"/>
+              </a:solidFill>
+            </a:endParaRPr>
+          </a:p>
+        </p:txBody>
+      </p:sp>
+      <p:pic>
+        <p:nvPicPr>
+          <p:cNvPr id="4" name="Imagen 3" descr="File:Glass slide.jpg">
+            <a:extLst>
+              <a:ext uri="{FF2B5EF4-FFF2-40B4-BE49-F238E27FC236}">
+                <a16:creationId xmlns:a16="http://schemas.microsoft.com/office/drawing/2014/main" id="{6662F3BB-C276-682D-C498-06FC2EC3621F}"/>
+              </a:ext>
+            </a:extLst>
+          </p:cNvPr>
+          <p:cNvPicPr>
+            <a:picLocks noChangeAspect="1"/>
+          </p:cNvPicPr>
+          <p:nvPr/>
+        </p:nvPicPr>
+        <p:blipFill>
+          <a:blip r:embed="rId3"/>
+          <a:stretch>
+            <a:fillRect/>
+          </a:stretch>
+        </p:blipFill>
+        <p:spPr>
+          <a:xfrm>
+            <a:off x="5253875" y="469375"/>
+            <a:ext cx="3175000" cy="4229100"/>
+          </a:xfrm>
+          <a:prstGeom prst="rect">
+            <a:avLst/>
+          </a:prstGeom>
+        </p:spPr>
+      </p:pic>
+    </p:spTree>
+    <p:extLst>
+      <p:ext uri="{BB962C8B-B14F-4D97-AF65-F5344CB8AC3E}">
+        <p14:creationId xmlns:p14="http://schemas.microsoft.com/office/powerpoint/2010/main" val="390088760"/>
       </p:ext>
     </p:extLst>
   </p:cSld>
@@ -15347,57 +16068,6 @@
           </a:p>
         </p:txBody>
       </p:sp>
-      <mc:AlternateContent xmlns:mc="http://schemas.openxmlformats.org/markup-compatibility/2006" xmlns:p14="http://schemas.microsoft.com/office/powerpoint/2010/main">
-        <mc:Choice Requires="p14">
-          <p:contentPart p14:bwMode="auto" r:id="rId2">
-            <p14:nvContentPartPr>
-              <p14:cNvPr id="11" name="Entrada de lápiz 10">
-                <a:extLst>
-                  <a:ext uri="{FF2B5EF4-FFF2-40B4-BE49-F238E27FC236}">
-                    <a16:creationId xmlns:a16="http://schemas.microsoft.com/office/drawing/2014/main" id="{28C717A0-E3D3-A0B0-8B1D-B47014BF5599}"/>
-                  </a:ext>
-                </a:extLst>
-              </p14:cNvPr>
-              <p14:cNvContentPartPr/>
-              <p14:nvPr/>
-            </p14:nvContentPartPr>
-            <p14:xfrm>
-              <a:off x="769863" y="269603"/>
-              <a:ext cx="1016550" cy="355320"/>
-            </p14:xfrm>
-          </p:contentPart>
-        </mc:Choice>
-        <mc:Fallback xmlns="">
-          <p:pic>
-            <p:nvPicPr>
-              <p:cNvPr id="11" name="Entrada de lápiz 10">
-                <a:extLst>
-                  <a:ext uri="{FF2B5EF4-FFF2-40B4-BE49-F238E27FC236}">
-                    <a16:creationId xmlns:a16="http://schemas.microsoft.com/office/drawing/2014/main" id="{28C717A0-E3D3-A0B0-8B1D-B47014BF5599}"/>
-                  </a:ext>
-                </a:extLst>
-              </p:cNvPr>
-              <p:cNvPicPr/>
-              <p:nvPr/>
-            </p:nvPicPr>
-            <p:blipFill>
-              <a:blip r:embed="rId3"/>
-              <a:stretch>
-                <a:fillRect/>
-              </a:stretch>
-            </p:blipFill>
-            <p:spPr>
-              <a:xfrm>
-                <a:off x="759064" y="258803"/>
-                <a:ext cx="1037788" cy="376560"/>
-              </a:xfrm>
-              <a:prstGeom prst="rect">
-                <a:avLst/>
-              </a:prstGeom>
-            </p:spPr>
-          </p:pic>
-        </mc:Fallback>
-      </mc:AlternateContent>
       <p:sp>
         <p:nvSpPr>
           <p:cNvPr id="5" name="Marcador de contenido 4">
@@ -15419,10 +16089,137 @@
           <a:bodyPr/>
           <a:lstStyle/>
           <a:p>
-            <a:endParaRPr lang="es-US"/>
+            <a:pPr marL="114300" indent="0">
+              <a:buNone/>
+            </a:pPr>
+            <a:r>
+              <a:rPr lang="es-US" dirty="0">
+                <a:solidFill>
+                  <a:schemeClr val="tx1"/>
+                </a:solidFill>
+              </a:rPr>
+              <a:t>Oposum </a:t>
+            </a:r>
+          </a:p>
+          <a:p>
+            <a:pPr marL="114300" indent="0">
+              <a:buNone/>
+            </a:pPr>
+            <a:r>
+              <a:rPr lang="es-US" i="1" dirty="0" err="1">
+                <a:solidFill>
+                  <a:schemeClr val="tx1"/>
+                </a:solidFill>
+              </a:rPr>
+              <a:t>Didelphis</a:t>
+            </a:r>
+            <a:r>
+              <a:rPr lang="es-US" i="1" dirty="0">
+                <a:solidFill>
+                  <a:schemeClr val="tx1"/>
+                </a:solidFill>
+              </a:rPr>
+              <a:t> </a:t>
+            </a:r>
+            <a:r>
+              <a:rPr lang="es-US" i="1" dirty="0" err="1">
+                <a:solidFill>
+                  <a:schemeClr val="tx1"/>
+                </a:solidFill>
+              </a:rPr>
+              <a:t>virginianus</a:t>
+            </a:r>
+            <a:endParaRPr lang="es-US" i="1" dirty="0">
+              <a:solidFill>
+                <a:schemeClr val="tx1"/>
+              </a:solidFill>
+            </a:endParaRPr>
+          </a:p>
+          <a:p>
+            <a:pPr marL="114300" indent="0">
+              <a:buNone/>
+            </a:pPr>
+            <a:r>
+              <a:rPr lang="es-US" dirty="0">
+                <a:solidFill>
+                  <a:schemeClr val="tx1"/>
+                </a:solidFill>
+              </a:rPr>
+              <a:t>Wild </a:t>
+            </a:r>
+          </a:p>
+          <a:p>
+            <a:pPr marL="114300" indent="0">
+              <a:buNone/>
+            </a:pPr>
+            <a:r>
+              <a:rPr lang="es-US" dirty="0">
+                <a:solidFill>
+                  <a:schemeClr val="tx1"/>
+                </a:solidFill>
+              </a:rPr>
+              <a:t>WA</a:t>
+            </a:r>
+          </a:p>
+          <a:p>
+            <a:pPr marL="114300" indent="0">
+              <a:buNone/>
+            </a:pPr>
+            <a:endParaRPr lang="es-US" i="1" dirty="0">
+              <a:solidFill>
+                <a:schemeClr val="tx1"/>
+              </a:solidFill>
+            </a:endParaRPr>
+          </a:p>
+          <a:p>
+            <a:pPr marL="114300" indent="0">
+              <a:buNone/>
+            </a:pPr>
+            <a:endParaRPr lang="es-US" b="1" dirty="0">
+              <a:solidFill>
+                <a:schemeClr val="tx1"/>
+              </a:solidFill>
+            </a:endParaRPr>
+          </a:p>
+          <a:p>
+            <a:endParaRPr lang="es-US" dirty="0">
+              <a:solidFill>
+                <a:schemeClr val="bg1"/>
+              </a:solidFill>
+            </a:endParaRPr>
           </a:p>
         </p:txBody>
       </p:sp>
+      <p:pic>
+        <p:nvPicPr>
+          <p:cNvPr id="7" name="Imagen 6" descr="File:Opossum 2.jpg">
+            <a:extLst>
+              <a:ext uri="{FF2B5EF4-FFF2-40B4-BE49-F238E27FC236}">
+                <a16:creationId xmlns:a16="http://schemas.microsoft.com/office/drawing/2014/main" id="{1134D8A5-0E46-9DF2-D8D9-BFED3D7318A7}"/>
+              </a:ext>
+            </a:extLst>
+          </p:cNvPr>
+          <p:cNvPicPr>
+            <a:picLocks noChangeAspect="1"/>
+          </p:cNvPicPr>
+          <p:nvPr/>
+        </p:nvPicPr>
+        <p:blipFill>
+          <a:blip r:embed="rId3"/>
+          <a:stretch>
+            <a:fillRect/>
+          </a:stretch>
+        </p:blipFill>
+        <p:spPr>
+          <a:xfrm>
+            <a:off x="3374044" y="373569"/>
+            <a:ext cx="5141306" cy="4195306"/>
+          </a:xfrm>
+          <a:prstGeom prst="rect">
+            <a:avLst/>
+          </a:prstGeom>
+        </p:spPr>
+      </p:pic>
     </p:spTree>
     <p:extLst>
       <p:ext uri="{BB962C8B-B14F-4D97-AF65-F5344CB8AC3E}">
@@ -15455,33 +16252,6 @@
       </p:grpSpPr>
       <p:sp>
         <p:nvSpPr>
-          <p:cNvPr id="2" name="Título 1">
-            <a:extLst>
-              <a:ext uri="{FF2B5EF4-FFF2-40B4-BE49-F238E27FC236}">
-                <a16:creationId xmlns:a16="http://schemas.microsoft.com/office/drawing/2014/main" id="{1667C6D1-E0F6-7763-1C7C-78A239B9D094}"/>
-              </a:ext>
-            </a:extLst>
-          </p:cNvPr>
-          <p:cNvSpPr>
-            <a:spLocks noGrp="1"/>
-          </p:cNvSpPr>
-          <p:nvPr>
-            <p:ph type="title"/>
-          </p:nvPr>
-        </p:nvSpPr>
-        <p:spPr/>
-        <p:txBody>
-          <a:bodyPr>
-            <a:normAutofit fontScale="90000"/>
-          </a:bodyPr>
-          <a:lstStyle/>
-          <a:p>
-            <a:endParaRPr lang="es-PR"/>
-          </a:p>
-        </p:txBody>
-      </p:sp>
-      <p:sp>
-        <p:nvSpPr>
           <p:cNvPr id="3" name="Marcador de contenido 2">
             <a:extLst>
               <a:ext uri="{FF2B5EF4-FFF2-40B4-BE49-F238E27FC236}">
@@ -15501,112 +16271,112 @@
           <a:bodyPr/>
           <a:lstStyle/>
           <a:p>
-            <a:endParaRPr lang="es-PR"/>
+            <a:pPr marL="114300" indent="0">
+              <a:buNone/>
+            </a:pPr>
+            <a:r>
+              <a:rPr lang="es-US" dirty="0" err="1">
+                <a:solidFill>
+                  <a:schemeClr val="tx1"/>
+                </a:solidFill>
+              </a:rPr>
+              <a:t>Raccoon</a:t>
+            </a:r>
+            <a:endParaRPr lang="es-US" dirty="0">
+              <a:solidFill>
+                <a:schemeClr val="tx1"/>
+              </a:solidFill>
+            </a:endParaRPr>
+          </a:p>
+          <a:p>
+            <a:pPr marL="114300" indent="0">
+              <a:buNone/>
+            </a:pPr>
+            <a:r>
+              <a:rPr lang="es-US" i="1" dirty="0">
+                <a:solidFill>
+                  <a:schemeClr val="tx1"/>
+                </a:solidFill>
+              </a:rPr>
+              <a:t>Procyon </a:t>
+            </a:r>
+            <a:r>
+              <a:rPr lang="es-US" i="1" dirty="0" err="1">
+                <a:solidFill>
+                  <a:schemeClr val="tx1"/>
+                </a:solidFill>
+              </a:rPr>
+              <a:t>lotor</a:t>
+            </a:r>
+            <a:endParaRPr lang="es-US" i="1" dirty="0">
+              <a:solidFill>
+                <a:schemeClr val="tx1"/>
+              </a:solidFill>
+            </a:endParaRPr>
+          </a:p>
+          <a:p>
+            <a:pPr marL="114300" indent="0">
+              <a:buNone/>
+            </a:pPr>
+            <a:r>
+              <a:rPr lang="es-US" dirty="0">
+                <a:solidFill>
+                  <a:schemeClr val="tx1"/>
+                </a:solidFill>
+              </a:rPr>
+              <a:t>Wild </a:t>
+            </a:r>
+          </a:p>
+          <a:p>
+            <a:pPr marL="114300" indent="0">
+              <a:buNone/>
+            </a:pPr>
+            <a:r>
+              <a:rPr lang="es-US" dirty="0">
+                <a:solidFill>
+                  <a:schemeClr val="tx1"/>
+                </a:solidFill>
+              </a:rPr>
+              <a:t>WA</a:t>
+            </a:r>
+            <a:endParaRPr lang="es-PR" dirty="0">
+              <a:solidFill>
+                <a:schemeClr val="tx1"/>
+              </a:solidFill>
+            </a:endParaRPr>
           </a:p>
         </p:txBody>
       </p:sp>
-      <mc:AlternateContent xmlns:mc="http://schemas.openxmlformats.org/markup-compatibility/2006" xmlns:p14="http://schemas.microsoft.com/office/powerpoint/2010/main">
-        <mc:Choice Requires="p14">
-          <p:contentPart p14:bwMode="auto" r:id="rId2">
-            <p14:nvContentPartPr>
-              <p14:cNvPr id="6" name="Entrada de lápiz 5">
-                <a:extLst>
-                  <a:ext uri="{FF2B5EF4-FFF2-40B4-BE49-F238E27FC236}">
-                    <a16:creationId xmlns:a16="http://schemas.microsoft.com/office/drawing/2014/main" id="{D79C5CF9-00FB-E90F-6E81-655999C5B897}"/>
-                  </a:ext>
-                </a:extLst>
-              </p14:cNvPr>
-              <p14:cNvContentPartPr/>
-              <p14:nvPr/>
-            </p14:nvContentPartPr>
-            <p14:xfrm>
-              <a:off x="1123378" y="1043550"/>
-              <a:ext cx="345600" cy="234090"/>
-            </p14:xfrm>
-          </p:contentPart>
-        </mc:Choice>
-        <mc:Fallback xmlns="">
-          <p:pic>
-            <p:nvPicPr>
-              <p:cNvPr id="6" name="Entrada de lápiz 5">
-                <a:extLst>
-                  <a:ext uri="{FF2B5EF4-FFF2-40B4-BE49-F238E27FC236}">
-                    <a16:creationId xmlns:a16="http://schemas.microsoft.com/office/drawing/2014/main" id="{D79C5CF9-00FB-E90F-6E81-655999C5B897}"/>
-                  </a:ext>
-                </a:extLst>
-              </p:cNvPr>
-              <p:cNvPicPr/>
-              <p:nvPr/>
-            </p:nvPicPr>
-            <p:blipFill>
-              <a:blip r:embed="rId3"/>
-              <a:stretch>
-                <a:fillRect/>
-              </a:stretch>
-            </p:blipFill>
-            <p:spPr>
-              <a:xfrm>
-                <a:off x="1112578" y="1032762"/>
-                <a:ext cx="366840" cy="255306"/>
-              </a:xfrm>
-              <a:prstGeom prst="rect">
-                <a:avLst/>
-              </a:prstGeom>
-            </p:spPr>
-          </p:pic>
-        </mc:Fallback>
-      </mc:AlternateContent>
-      <mc:AlternateContent xmlns:mc="http://schemas.openxmlformats.org/markup-compatibility/2006" xmlns:p14="http://schemas.microsoft.com/office/powerpoint/2010/main">
-        <mc:Choice Requires="p14">
-          <p:contentPart p14:bwMode="auto" r:id="rId4">
-            <p14:nvContentPartPr>
-              <p14:cNvPr id="11" name="Entrada de lápiz 10">
-                <a:extLst>
-                  <a:ext uri="{FF2B5EF4-FFF2-40B4-BE49-F238E27FC236}">
-                    <a16:creationId xmlns:a16="http://schemas.microsoft.com/office/drawing/2014/main" id="{65084879-CCFE-0EE6-1384-4FA031326D3E}"/>
-                  </a:ext>
-                </a:extLst>
-              </p14:cNvPr>
-              <p14:cNvContentPartPr/>
-              <p14:nvPr/>
-            </p14:nvContentPartPr>
-            <p14:xfrm>
-              <a:off x="1560238" y="1047870"/>
-              <a:ext cx="713880" cy="208710"/>
-            </p14:xfrm>
-          </p:contentPart>
-        </mc:Choice>
-        <mc:Fallback xmlns="">
-          <p:pic>
-            <p:nvPicPr>
-              <p:cNvPr id="11" name="Entrada de lápiz 10">
-                <a:extLst>
-                  <a:ext uri="{FF2B5EF4-FFF2-40B4-BE49-F238E27FC236}">
-                    <a16:creationId xmlns:a16="http://schemas.microsoft.com/office/drawing/2014/main" id="{65084879-CCFE-0EE6-1384-4FA031326D3E}"/>
-                  </a:ext>
-                </a:extLst>
-              </p:cNvPr>
-              <p:cNvPicPr/>
-              <p:nvPr/>
-            </p:nvPicPr>
-            <p:blipFill>
-              <a:blip r:embed="rId5"/>
-              <a:stretch>
-                <a:fillRect/>
-              </a:stretch>
-            </p:blipFill>
-            <p:spPr>
-              <a:xfrm>
-                <a:off x="1549438" y="1037056"/>
-                <a:ext cx="735120" cy="229978"/>
-              </a:xfrm>
-              <a:prstGeom prst="rect">
-                <a:avLst/>
-              </a:prstGeom>
-            </p:spPr>
-          </p:pic>
-        </mc:Fallback>
-      </mc:AlternateContent>
+      <p:pic>
+        <p:nvPicPr>
+          <p:cNvPr id="7" name="Imagen 6" descr="File:Raccoon in Central Park (35264).jpg">
+            <a:extLst>
+              <a:ext uri="{FF2B5EF4-FFF2-40B4-BE49-F238E27FC236}">
+                <a16:creationId xmlns:a16="http://schemas.microsoft.com/office/drawing/2014/main" id="{24768763-BA1A-BBE3-4370-D5F5B6820F31}"/>
+              </a:ext>
+            </a:extLst>
+          </p:cNvPr>
+          <p:cNvPicPr>
+            <a:picLocks noChangeAspect="1"/>
+          </p:cNvPicPr>
+          <p:nvPr/>
+        </p:nvPicPr>
+        <p:blipFill>
+          <a:blip r:embed="rId3"/>
+          <a:stretch>
+            <a:fillRect/>
+          </a:stretch>
+        </p:blipFill>
+        <p:spPr>
+          <a:xfrm>
+            <a:off x="3397162" y="435377"/>
+            <a:ext cx="5276805" cy="4133497"/>
+          </a:xfrm>
+          <a:prstGeom prst="rect">
+            <a:avLst/>
+          </a:prstGeom>
+        </p:spPr>
+      </p:pic>
     </p:spTree>
     <p:extLst>
       <p:ext uri="{BB962C8B-B14F-4D97-AF65-F5344CB8AC3E}">
@@ -15685,184 +16455,123 @@
           <a:bodyPr/>
           <a:lstStyle/>
           <a:p>
-            <a:endParaRPr lang="es-PR"/>
+            <a:pPr marL="114300" indent="0">
+              <a:buNone/>
+            </a:pPr>
+            <a:r>
+              <a:rPr lang="es-PR" dirty="0">
+                <a:solidFill>
+                  <a:schemeClr val="tx1"/>
+                </a:solidFill>
+              </a:rPr>
+              <a:t>Gray squirell</a:t>
+            </a:r>
+          </a:p>
+          <a:p>
+            <a:pPr marL="114300" indent="0">
+              <a:buNone/>
+            </a:pPr>
+            <a:r>
+              <a:rPr lang="es-US" i="1" dirty="0">
+                <a:solidFill>
+                  <a:schemeClr val="tx1"/>
+                </a:solidFill>
+              </a:rPr>
+              <a:t>Sciurus </a:t>
+            </a:r>
+            <a:r>
+              <a:rPr lang="es-US" i="1" dirty="0" err="1">
+                <a:solidFill>
+                  <a:schemeClr val="tx1"/>
+                </a:solidFill>
+              </a:rPr>
+              <a:t>carolinensis</a:t>
+            </a:r>
+            <a:endParaRPr lang="es-US" i="1" dirty="0">
+              <a:solidFill>
+                <a:schemeClr val="tx1"/>
+              </a:solidFill>
+            </a:endParaRPr>
+          </a:p>
+          <a:p>
+            <a:pPr marL="114300" indent="0">
+              <a:buNone/>
+            </a:pPr>
+            <a:r>
+              <a:rPr lang="es-US" dirty="0">
+                <a:solidFill>
+                  <a:schemeClr val="tx1"/>
+                </a:solidFill>
+              </a:rPr>
+              <a:t>Wild </a:t>
+            </a:r>
+          </a:p>
+          <a:p>
+            <a:pPr marL="114300" indent="0">
+              <a:buNone/>
+            </a:pPr>
+            <a:r>
+              <a:rPr lang="en-US" dirty="0">
+                <a:solidFill>
+                  <a:schemeClr val="tx1"/>
+                </a:solidFill>
+              </a:rPr>
+              <a:t>?</a:t>
+            </a:r>
+            <a:endParaRPr lang="es-PR" dirty="0">
+              <a:solidFill>
+                <a:schemeClr val="tx1"/>
+              </a:solidFill>
+            </a:endParaRPr>
+          </a:p>
+          <a:p>
+            <a:pPr marL="114300" indent="0">
+              <a:buNone/>
+            </a:pPr>
+            <a:endParaRPr lang="es-PR" dirty="0">
+              <a:solidFill>
+                <a:schemeClr val="tx1"/>
+              </a:solidFill>
+            </a:endParaRPr>
+          </a:p>
+          <a:p>
+            <a:pPr marL="114300" indent="0">
+              <a:buNone/>
+            </a:pPr>
+            <a:endParaRPr lang="es-PR" dirty="0"/>
           </a:p>
         </p:txBody>
       </p:sp>
-      <mc:AlternateContent xmlns:mc="http://schemas.openxmlformats.org/markup-compatibility/2006" xmlns:p14="http://schemas.microsoft.com/office/powerpoint/2010/main">
-        <mc:Choice Requires="p14">
-          <p:contentPart p14:bwMode="auto" r:id="rId2">
-            <p14:nvContentPartPr>
-              <p14:cNvPr id="11" name="Entrada de lápiz 10">
-                <a:extLst>
-                  <a:ext uri="{FF2B5EF4-FFF2-40B4-BE49-F238E27FC236}">
-                    <a16:creationId xmlns:a16="http://schemas.microsoft.com/office/drawing/2014/main" id="{4800A652-AAE0-23EE-310A-7E926F1D8E9B}"/>
-                  </a:ext>
-                </a:extLst>
-              </p14:cNvPr>
-              <p14:cNvContentPartPr/>
-              <p14:nvPr/>
-            </p14:nvContentPartPr>
-            <p14:xfrm>
-              <a:off x="899016" y="1006020"/>
-              <a:ext cx="741150" cy="392580"/>
-            </p14:xfrm>
-          </p:contentPart>
-        </mc:Choice>
-        <mc:Fallback xmlns="">
-          <p:pic>
-            <p:nvPicPr>
-              <p:cNvPr id="11" name="Entrada de lápiz 10">
-                <a:extLst>
-                  <a:ext uri="{FF2B5EF4-FFF2-40B4-BE49-F238E27FC236}">
-                    <a16:creationId xmlns:a16="http://schemas.microsoft.com/office/drawing/2014/main" id="{4800A652-AAE0-23EE-310A-7E926F1D8E9B}"/>
-                  </a:ext>
-                </a:extLst>
-              </p:cNvPr>
-              <p:cNvPicPr/>
-              <p:nvPr/>
-            </p:nvPicPr>
-            <p:blipFill>
-              <a:blip r:embed="rId3"/>
-              <a:stretch>
-                <a:fillRect/>
-              </a:stretch>
-            </p:blipFill>
-            <p:spPr>
-              <a:xfrm>
-                <a:off x="888223" y="995215"/>
-                <a:ext cx="762377" cy="413830"/>
-              </a:xfrm>
-              <a:prstGeom prst="rect">
-                <a:avLst/>
-              </a:prstGeom>
-            </p:spPr>
-          </p:pic>
-        </mc:Fallback>
-      </mc:AlternateContent>
-      <p:grpSp>
-        <p:nvGrpSpPr>
-          <p:cNvPr id="7" name="Grupo 6">
+      <p:pic>
+        <p:nvPicPr>
+          <p:cNvPr id="6" name="Imagen 5" descr="File:Eastern Grey Squirrel in St James's Park, London - Nov 2006 edit.jpg">
             <a:extLst>
               <a:ext uri="{FF2B5EF4-FFF2-40B4-BE49-F238E27FC236}">
-                <a16:creationId xmlns:a16="http://schemas.microsoft.com/office/drawing/2014/main" id="{C714DEDA-411B-52E6-855E-C73401AD047E}"/>
+                <a16:creationId xmlns:a16="http://schemas.microsoft.com/office/drawing/2014/main" id="{46C941D7-07D9-B28D-7D11-7330D642D34A}"/>
               </a:ext>
             </a:extLst>
           </p:cNvPr>
-          <p:cNvGrpSpPr/>
+          <p:cNvPicPr>
+            <a:picLocks noChangeAspect="1"/>
+          </p:cNvPicPr>
           <p:nvPr/>
-        </p:nvGrpSpPr>
-        <p:grpSpPr>
+        </p:nvPicPr>
+        <p:blipFill>
+          <a:blip r:embed="rId3"/>
+          <a:stretch>
+            <a:fillRect/>
+          </a:stretch>
+        </p:blipFill>
+        <p:spPr>
           <a:xfrm>
-            <a:off x="1656858" y="897638"/>
-            <a:ext cx="191970" cy="425790"/>
-            <a:chOff x="2209144" y="1196851"/>
-            <a:chExt cx="255960" cy="567720"/>
+            <a:off x="3115025" y="445025"/>
+            <a:ext cx="5372269" cy="4141124"/>
           </a:xfrm>
-        </p:grpSpPr>
-        <mc:AlternateContent xmlns:mc="http://schemas.openxmlformats.org/markup-compatibility/2006" xmlns:p14="http://schemas.microsoft.com/office/powerpoint/2010/main">
-          <mc:Choice Requires="p14">
-            <p:contentPart p14:bwMode="auto" r:id="rId4">
-              <p14:nvContentPartPr>
-                <p14:cNvPr id="4" name="Entrada de lápiz 3">
-                  <a:extLst>
-                    <a:ext uri="{FF2B5EF4-FFF2-40B4-BE49-F238E27FC236}">
-                      <a16:creationId xmlns:a16="http://schemas.microsoft.com/office/drawing/2014/main" id="{D0D1907E-D117-8C6B-4236-58076008D8A4}"/>
-                    </a:ext>
-                  </a:extLst>
-                </p14:cNvPr>
-                <p14:cNvContentPartPr/>
-                <p14:nvPr/>
-              </p14:nvContentPartPr>
-              <p14:xfrm>
-                <a:off x="2209144" y="1461811"/>
-                <a:ext cx="184680" cy="201240"/>
-              </p14:xfrm>
-            </p:contentPart>
-          </mc:Choice>
-          <mc:Fallback xmlns="">
-            <p:pic>
-              <p:nvPicPr>
-                <p:cNvPr id="4" name="Entrada de lápiz 3">
-                  <a:extLst>
-                    <a:ext uri="{FF2B5EF4-FFF2-40B4-BE49-F238E27FC236}">
-                      <a16:creationId xmlns:a16="http://schemas.microsoft.com/office/drawing/2014/main" id="{D0D1907E-D117-8C6B-4236-58076008D8A4}"/>
-                    </a:ext>
-                  </a:extLst>
-                </p:cNvPr>
-                <p:cNvPicPr/>
-                <p:nvPr/>
-              </p:nvPicPr>
-              <p:blipFill>
-                <a:blip r:embed="rId5"/>
-                <a:stretch>
-                  <a:fillRect/>
-                </a:stretch>
-              </p:blipFill>
-              <p:spPr>
-                <a:xfrm>
-                  <a:off x="2197152" y="1450312"/>
-                  <a:ext cx="208185" cy="224718"/>
-                </a:xfrm>
-                <a:prstGeom prst="rect">
-                  <a:avLst/>
-                </a:prstGeom>
-              </p:spPr>
-            </p:pic>
-          </mc:Fallback>
-        </mc:AlternateContent>
-        <mc:AlternateContent xmlns:mc="http://schemas.openxmlformats.org/markup-compatibility/2006" xmlns:p14="http://schemas.microsoft.com/office/powerpoint/2010/main">
-          <mc:Choice Requires="p14">
-            <p:contentPart p14:bwMode="auto" r:id="rId6">
-              <p14:nvContentPartPr>
-                <p14:cNvPr id="5" name="Entrada de lápiz 4">
-                  <a:extLst>
-                    <a:ext uri="{FF2B5EF4-FFF2-40B4-BE49-F238E27FC236}">
-                      <a16:creationId xmlns:a16="http://schemas.microsoft.com/office/drawing/2014/main" id="{2166D13D-8CD1-DE1A-968D-06CC48EB76F9}"/>
-                    </a:ext>
-                  </a:extLst>
-                </p14:cNvPr>
-                <p14:cNvContentPartPr/>
-                <p14:nvPr/>
-              </p14:nvContentPartPr>
-              <p14:xfrm>
-                <a:off x="2443864" y="1196851"/>
-                <a:ext cx="21240" cy="567720"/>
-              </p14:xfrm>
-            </p:contentPart>
-          </mc:Choice>
-          <mc:Fallback xmlns="">
-            <p:pic>
-              <p:nvPicPr>
-                <p:cNvPr id="5" name="Entrada de lápiz 4">
-                  <a:extLst>
-                    <a:ext uri="{FF2B5EF4-FFF2-40B4-BE49-F238E27FC236}">
-                      <a16:creationId xmlns:a16="http://schemas.microsoft.com/office/drawing/2014/main" id="{2166D13D-8CD1-DE1A-968D-06CC48EB76F9}"/>
-                    </a:ext>
-                  </a:extLst>
-                </p:cNvPr>
-                <p:cNvPicPr/>
-                <p:nvPr/>
-              </p:nvPicPr>
-              <p:blipFill>
-                <a:blip r:embed="rId7"/>
-                <a:stretch>
-                  <a:fillRect/>
-                </a:stretch>
-              </p:blipFill>
-              <p:spPr>
-                <a:xfrm>
-                  <a:off x="2432064" y="1185333"/>
-                  <a:ext cx="44368" cy="591235"/>
-                </a:xfrm>
-                <a:prstGeom prst="rect">
-                  <a:avLst/>
-                </a:prstGeom>
-              </p:spPr>
-            </p:pic>
-          </mc:Fallback>
-        </mc:AlternateContent>
-      </p:grpSp>
+          <a:prstGeom prst="rect">
+            <a:avLst/>
+          </a:prstGeom>
+        </p:spPr>
+      </p:pic>
     </p:spTree>
     <p:extLst>
       <p:ext uri="{BB962C8B-B14F-4D97-AF65-F5344CB8AC3E}">
@@ -15941,61 +16650,108 @@
           <a:bodyPr/>
           <a:lstStyle/>
           <a:p>
-            <a:endParaRPr lang="es-PR"/>
+            <a:pPr marL="114300" indent="0">
+              <a:buNone/>
+            </a:pPr>
+            <a:r>
+              <a:rPr lang="es-PR" dirty="0">
+                <a:solidFill>
+                  <a:schemeClr val="tx1"/>
+                </a:solidFill>
+              </a:rPr>
+              <a:t>American crows </a:t>
+            </a:r>
+          </a:p>
+          <a:p>
+            <a:pPr marL="114300" indent="0">
+              <a:buNone/>
+            </a:pPr>
+            <a:r>
+              <a:rPr lang="es-US" i="1" dirty="0">
+                <a:solidFill>
+                  <a:schemeClr val="tx1"/>
+                </a:solidFill>
+              </a:rPr>
+              <a:t>Corvus </a:t>
+            </a:r>
+            <a:r>
+              <a:rPr lang="es-US" i="1" dirty="0" err="1">
+                <a:solidFill>
+                  <a:schemeClr val="tx1"/>
+                </a:solidFill>
+              </a:rPr>
+              <a:t>brachyrhynchos</a:t>
+            </a:r>
+            <a:r>
+              <a:rPr lang="es-US" i="1" dirty="0">
+                <a:solidFill>
+                  <a:schemeClr val="tx1"/>
+                </a:solidFill>
+              </a:rPr>
+              <a:t> </a:t>
+            </a:r>
+          </a:p>
+          <a:p>
+            <a:pPr marL="114300" indent="0">
+              <a:buNone/>
+            </a:pPr>
+            <a:r>
+              <a:rPr lang="es-PR" dirty="0">
+                <a:solidFill>
+                  <a:schemeClr val="tx1"/>
+                </a:solidFill>
+              </a:rPr>
+              <a:t>Wild</a:t>
+            </a:r>
+          </a:p>
+          <a:p>
+            <a:pPr marL="114300" indent="0">
+              <a:buNone/>
+            </a:pPr>
+            <a:r>
+              <a:rPr lang="es-PR" dirty="0">
+                <a:solidFill>
+                  <a:schemeClr val="tx1"/>
+                </a:solidFill>
+              </a:rPr>
+              <a:t>WA</a:t>
+            </a:r>
+          </a:p>
+          <a:p>
+            <a:endParaRPr lang="es-PR" dirty="0"/>
           </a:p>
         </p:txBody>
       </p:sp>
-      <mc:AlternateContent xmlns:mc="http://schemas.openxmlformats.org/markup-compatibility/2006" xmlns:p14="http://schemas.microsoft.com/office/powerpoint/2010/main">
-        <mc:Choice Requires="p14">
-          <p:contentPart p14:bwMode="auto" r:id="rId2">
-            <p14:nvContentPartPr>
-              <p14:cNvPr id="6" name="Entrada de lápiz 5">
-                <a:extLst>
-                  <a:ext uri="{FF2B5EF4-FFF2-40B4-BE49-F238E27FC236}">
-                    <a16:creationId xmlns:a16="http://schemas.microsoft.com/office/drawing/2014/main" id="{BB50EAE9-447D-3851-8E38-CAFE3B4F016B}"/>
-                  </a:ext>
-                </a:extLst>
-              </p14:cNvPr>
-              <p14:cNvContentPartPr/>
-              <p14:nvPr/>
-            </p14:nvContentPartPr>
-            <p14:xfrm>
-              <a:off x="1096122" y="1035720"/>
-              <a:ext cx="710100" cy="237870"/>
-            </p14:xfrm>
-          </p:contentPart>
-        </mc:Choice>
-        <mc:Fallback xmlns="">
-          <p:pic>
-            <p:nvPicPr>
-              <p:cNvPr id="6" name="Entrada de lápiz 5">
-                <a:extLst>
-                  <a:ext uri="{FF2B5EF4-FFF2-40B4-BE49-F238E27FC236}">
-                    <a16:creationId xmlns:a16="http://schemas.microsoft.com/office/drawing/2014/main" id="{BB50EAE9-447D-3851-8E38-CAFE3B4F016B}"/>
-                  </a:ext>
-                </a:extLst>
-              </p:cNvPr>
-              <p:cNvPicPr/>
-              <p:nvPr/>
-            </p:nvPicPr>
-            <p:blipFill>
-              <a:blip r:embed="rId3"/>
-              <a:stretch>
-                <a:fillRect/>
-              </a:stretch>
-            </p:blipFill>
-            <p:spPr>
-              <a:xfrm>
-                <a:off x="1085330" y="1024940"/>
-                <a:ext cx="731324" cy="259070"/>
-              </a:xfrm>
-              <a:prstGeom prst="rect">
-                <a:avLst/>
-              </a:prstGeom>
-            </p:spPr>
-          </p:pic>
-        </mc:Fallback>
-      </mc:AlternateContent>
+      <p:pic>
+        <p:nvPicPr>
+          <p:cNvPr id="4" name="Imagen 3" descr="File:2014-04-29 01 Northwestern crow (Corvus brachyrhynchos caurinus).jpg">
+            <a:extLst>
+              <a:ext uri="{FF2B5EF4-FFF2-40B4-BE49-F238E27FC236}">
+                <a16:creationId xmlns:a16="http://schemas.microsoft.com/office/drawing/2014/main" id="{E03DA2B1-124D-C02D-4D2B-7372BD160864}"/>
+              </a:ext>
+            </a:extLst>
+          </p:cNvPr>
+          <p:cNvPicPr>
+            <a:picLocks noChangeAspect="1"/>
+          </p:cNvPicPr>
+          <p:nvPr/>
+        </p:nvPicPr>
+        <p:blipFill>
+          <a:blip r:embed="rId3"/>
+          <a:stretch>
+            <a:fillRect/>
+          </a:stretch>
+        </p:blipFill>
+        <p:spPr>
+          <a:xfrm>
+            <a:off x="3217025" y="773263"/>
+            <a:ext cx="5395461" cy="3596974"/>
+          </a:xfrm>
+          <a:prstGeom prst="rect">
+            <a:avLst/>
+          </a:prstGeom>
+        </p:spPr>
+      </p:pic>
     </p:spTree>
     <p:extLst>
       <p:ext uri="{BB962C8B-B14F-4D97-AF65-F5344CB8AC3E}">
@@ -16074,61 +16830,125 @@
           <a:bodyPr/>
           <a:lstStyle/>
           <a:p>
-            <a:endParaRPr lang="es-PR"/>
+            <a:pPr marL="114300" indent="0">
+              <a:buNone/>
+            </a:pPr>
+            <a:r>
+              <a:rPr lang="es-PR" dirty="0">
+                <a:solidFill>
+                  <a:schemeClr val="tx1"/>
+                </a:solidFill>
+              </a:rPr>
+              <a:t>American robin</a:t>
+            </a:r>
+          </a:p>
+          <a:p>
+            <a:pPr marL="114300" indent="0">
+              <a:buNone/>
+            </a:pPr>
+            <a:r>
+              <a:rPr lang="es-US" i="1" dirty="0" err="1">
+                <a:solidFill>
+                  <a:schemeClr val="tx1"/>
+                </a:solidFill>
+              </a:rPr>
+              <a:t>Turdus</a:t>
+            </a:r>
+            <a:r>
+              <a:rPr lang="es-US" i="1" dirty="0">
+                <a:solidFill>
+                  <a:schemeClr val="tx1"/>
+                </a:solidFill>
+              </a:rPr>
+              <a:t> </a:t>
+            </a:r>
+            <a:r>
+              <a:rPr lang="es-US" i="1" dirty="0" err="1">
+                <a:solidFill>
+                  <a:schemeClr val="tx1"/>
+                </a:solidFill>
+              </a:rPr>
+              <a:t>migratorius</a:t>
+            </a:r>
+            <a:endParaRPr lang="es-US" i="1" dirty="0">
+              <a:solidFill>
+                <a:schemeClr val="tx1"/>
+              </a:solidFill>
+            </a:endParaRPr>
+          </a:p>
+          <a:p>
+            <a:pPr marL="114300" indent="0">
+              <a:buNone/>
+            </a:pPr>
+            <a:r>
+              <a:rPr lang="es-US" dirty="0">
+                <a:solidFill>
+                  <a:schemeClr val="tx1"/>
+                </a:solidFill>
+              </a:rPr>
+              <a:t>Wild </a:t>
+            </a:r>
+          </a:p>
+          <a:p>
+            <a:pPr marL="114300" indent="0">
+              <a:buNone/>
+            </a:pPr>
+            <a:r>
+              <a:rPr lang="es-US" dirty="0">
+                <a:solidFill>
+                  <a:schemeClr val="tx1"/>
+                </a:solidFill>
+              </a:rPr>
+              <a:t>WA</a:t>
+            </a:r>
+            <a:endParaRPr lang="es-PR" dirty="0">
+              <a:solidFill>
+                <a:schemeClr val="tx1"/>
+              </a:solidFill>
+            </a:endParaRPr>
+          </a:p>
+          <a:p>
+            <a:pPr marL="114300" indent="0">
+              <a:buNone/>
+            </a:pPr>
+            <a:endParaRPr lang="es-PR" dirty="0">
+              <a:solidFill>
+                <a:schemeClr val="tx1"/>
+              </a:solidFill>
+            </a:endParaRPr>
           </a:p>
         </p:txBody>
       </p:sp>
-      <mc:AlternateContent xmlns:mc="http://schemas.openxmlformats.org/markup-compatibility/2006" xmlns:p14="http://schemas.microsoft.com/office/powerpoint/2010/main">
-        <mc:Choice Requires="p14">
-          <p:contentPart p14:bwMode="auto" r:id="rId2">
-            <p14:nvContentPartPr>
-              <p14:cNvPr id="10" name="Entrada de lápiz 9">
-                <a:extLst>
-                  <a:ext uri="{FF2B5EF4-FFF2-40B4-BE49-F238E27FC236}">
-                    <a16:creationId xmlns:a16="http://schemas.microsoft.com/office/drawing/2014/main" id="{166F047D-1229-D036-D9AF-584545A06526}"/>
-                  </a:ext>
-                </a:extLst>
-              </p14:cNvPr>
-              <p14:cNvContentPartPr/>
-              <p14:nvPr/>
-            </p14:nvContentPartPr>
-            <p14:xfrm>
-              <a:off x="917537" y="921376"/>
-              <a:ext cx="858330" cy="358020"/>
-            </p14:xfrm>
-          </p:contentPart>
-        </mc:Choice>
-        <mc:Fallback xmlns="">
-          <p:pic>
-            <p:nvPicPr>
-              <p:cNvPr id="10" name="Entrada de lápiz 9">
-                <a:extLst>
-                  <a:ext uri="{FF2B5EF4-FFF2-40B4-BE49-F238E27FC236}">
-                    <a16:creationId xmlns:a16="http://schemas.microsoft.com/office/drawing/2014/main" id="{166F047D-1229-D036-D9AF-584545A06526}"/>
-                  </a:ext>
-                </a:extLst>
-              </p:cNvPr>
-              <p:cNvPicPr/>
-              <p:nvPr/>
-            </p:nvPicPr>
-            <p:blipFill>
-              <a:blip r:embed="rId3"/>
-              <a:stretch>
-                <a:fillRect/>
-              </a:stretch>
-            </p:blipFill>
-            <p:spPr>
-              <a:xfrm>
-                <a:off x="906740" y="910592"/>
-                <a:ext cx="879563" cy="379228"/>
-              </a:xfrm>
-              <a:prstGeom prst="rect">
-                <a:avLst/>
-              </a:prstGeom>
-            </p:spPr>
-          </p:pic>
-        </mc:Fallback>
-      </mc:AlternateContent>
+      <p:pic>
+        <p:nvPicPr>
+          <p:cNvPr id="4" name="Imagen 3">
+            <a:extLst>
+              <a:ext uri="{FF2B5EF4-FFF2-40B4-BE49-F238E27FC236}">
+                <a16:creationId xmlns:a16="http://schemas.microsoft.com/office/drawing/2014/main" id="{5C525934-840E-5168-8DA5-1C59780EF462}"/>
+              </a:ext>
+            </a:extLst>
+          </p:cNvPr>
+          <p:cNvPicPr>
+            <a:picLocks noChangeAspect="1"/>
+          </p:cNvPicPr>
+          <p:nvPr/>
+        </p:nvPicPr>
+        <p:blipFill>
+          <a:blip r:embed="rId3"/>
+          <a:stretch>
+            <a:fillRect/>
+          </a:stretch>
+        </p:blipFill>
+        <p:spPr>
+          <a:xfrm>
+            <a:off x="3175462" y="574625"/>
+            <a:ext cx="5358361" cy="4062295"/>
+          </a:xfrm>
+          <a:prstGeom prst="rect">
+            <a:avLst/>
+          </a:prstGeom>
+        </p:spPr>
+      </p:pic>
     </p:spTree>
     <p:extLst>
       <p:ext uri="{BB962C8B-B14F-4D97-AF65-F5344CB8AC3E}">
@@ -16207,112 +17027,113 @@
           <a:bodyPr/>
           <a:lstStyle/>
           <a:p>
-            <a:endParaRPr lang="es-PR"/>
+            <a:pPr marL="114300" indent="0">
+              <a:buNone/>
+            </a:pPr>
+            <a:r>
+              <a:rPr lang="es-PR" dirty="0">
+                <a:solidFill>
+                  <a:schemeClr val="tx1"/>
+                </a:solidFill>
+              </a:rPr>
+              <a:t>Thrush</a:t>
+            </a:r>
+          </a:p>
+          <a:p>
+            <a:pPr marL="114300" indent="0">
+              <a:buNone/>
+            </a:pPr>
+            <a:r>
+              <a:rPr lang="es-US" i="1" dirty="0" err="1">
+                <a:solidFill>
+                  <a:schemeClr val="tx1"/>
+                </a:solidFill>
+              </a:rPr>
+              <a:t>Turdus</a:t>
+            </a:r>
+            <a:r>
+              <a:rPr lang="es-US" i="1" dirty="0">
+                <a:solidFill>
+                  <a:schemeClr val="tx1"/>
+                </a:solidFill>
+              </a:rPr>
+              <a:t> </a:t>
+            </a:r>
+            <a:r>
+              <a:rPr lang="es-US" i="1" dirty="0" err="1">
+                <a:solidFill>
+                  <a:schemeClr val="tx1"/>
+                </a:solidFill>
+              </a:rPr>
+              <a:t>viscivorus</a:t>
+            </a:r>
+            <a:r>
+              <a:rPr lang="es-US" i="1" dirty="0">
+                <a:solidFill>
+                  <a:schemeClr val="tx1"/>
+                </a:solidFill>
+              </a:rPr>
+              <a:t> </a:t>
+            </a:r>
+          </a:p>
+          <a:p>
+            <a:pPr marL="114300" indent="0">
+              <a:buNone/>
+            </a:pPr>
+            <a:r>
+              <a:rPr lang="es-PR" dirty="0">
+                <a:solidFill>
+                  <a:schemeClr val="tx1"/>
+                </a:solidFill>
+              </a:rPr>
+              <a:t>Wild </a:t>
+            </a:r>
+          </a:p>
+          <a:p>
+            <a:pPr marL="114300" indent="0">
+              <a:buNone/>
+            </a:pPr>
+            <a:r>
+              <a:rPr lang="es-PR" dirty="0">
+                <a:solidFill>
+                  <a:schemeClr val="tx1"/>
+                </a:solidFill>
+              </a:rPr>
+              <a:t>WA</a:t>
+            </a:r>
           </a:p>
         </p:txBody>
       </p:sp>
-      <mc:AlternateContent xmlns:mc="http://schemas.openxmlformats.org/markup-compatibility/2006" xmlns:p14="http://schemas.microsoft.com/office/powerpoint/2010/main">
-        <mc:Choice Requires="p14">
-          <p:contentPart p14:bwMode="auto" r:id="rId2">
-            <p14:nvContentPartPr>
-              <p14:cNvPr id="7" name="Entrada de lápiz 6">
-                <a:extLst>
-                  <a:ext uri="{FF2B5EF4-FFF2-40B4-BE49-F238E27FC236}">
-                    <a16:creationId xmlns:a16="http://schemas.microsoft.com/office/drawing/2014/main" id="{DDB88146-246A-CB67-1AC1-7E65EB093404}"/>
-                  </a:ext>
-                </a:extLst>
-              </p14:cNvPr>
-              <p14:cNvContentPartPr/>
-              <p14:nvPr/>
-            </p14:nvContentPartPr>
-            <p14:xfrm>
-              <a:off x="896612" y="948510"/>
-              <a:ext cx="386910" cy="337770"/>
-            </p14:xfrm>
-          </p:contentPart>
-        </mc:Choice>
-        <mc:Fallback xmlns="">
-          <p:pic>
-            <p:nvPicPr>
-              <p:cNvPr id="7" name="Entrada de lápiz 6">
-                <a:extLst>
-                  <a:ext uri="{FF2B5EF4-FFF2-40B4-BE49-F238E27FC236}">
-                    <a16:creationId xmlns:a16="http://schemas.microsoft.com/office/drawing/2014/main" id="{DDB88146-246A-CB67-1AC1-7E65EB093404}"/>
-                  </a:ext>
-                </a:extLst>
-              </p:cNvPr>
-              <p:cNvPicPr/>
-              <p:nvPr/>
-            </p:nvPicPr>
-            <p:blipFill>
-              <a:blip r:embed="rId3"/>
-              <a:stretch>
-                <a:fillRect/>
-              </a:stretch>
-            </p:blipFill>
-            <p:spPr>
-              <a:xfrm>
-                <a:off x="885815" y="937719"/>
-                <a:ext cx="408145" cy="358993"/>
-              </a:xfrm>
-              <a:prstGeom prst="rect">
-                <a:avLst/>
-              </a:prstGeom>
-            </p:spPr>
-          </p:pic>
-        </mc:Fallback>
-      </mc:AlternateContent>
-      <mc:AlternateContent xmlns:mc="http://schemas.openxmlformats.org/markup-compatibility/2006" xmlns:p14="http://schemas.microsoft.com/office/powerpoint/2010/main">
-        <mc:Choice Requires="p14">
-          <p:contentPart p14:bwMode="auto" r:id="rId4">
-            <p14:nvContentPartPr>
-              <p14:cNvPr id="14" name="Entrada de lápiz 13">
-                <a:extLst>
-                  <a:ext uri="{FF2B5EF4-FFF2-40B4-BE49-F238E27FC236}">
-                    <a16:creationId xmlns:a16="http://schemas.microsoft.com/office/drawing/2014/main" id="{D2CADFA3-9A4B-BDCE-6C19-0FECA840E888}"/>
-                  </a:ext>
-                </a:extLst>
-              </p14:cNvPr>
-              <p14:cNvContentPartPr/>
-              <p14:nvPr/>
-            </p14:nvContentPartPr>
-            <p14:xfrm>
-              <a:off x="1291622" y="1012230"/>
-              <a:ext cx="727380" cy="269730"/>
-            </p14:xfrm>
-          </p:contentPart>
-        </mc:Choice>
-        <mc:Fallback xmlns="">
-          <p:pic>
-            <p:nvPicPr>
-              <p:cNvPr id="14" name="Entrada de lápiz 13">
-                <a:extLst>
-                  <a:ext uri="{FF2B5EF4-FFF2-40B4-BE49-F238E27FC236}">
-                    <a16:creationId xmlns:a16="http://schemas.microsoft.com/office/drawing/2014/main" id="{D2CADFA3-9A4B-BDCE-6C19-0FECA840E888}"/>
-                  </a:ext>
-                </a:extLst>
-              </p:cNvPr>
-              <p:cNvPicPr/>
-              <p:nvPr/>
-            </p:nvPicPr>
-            <p:blipFill>
-              <a:blip r:embed="rId5"/>
-              <a:stretch>
-                <a:fillRect/>
-              </a:stretch>
-            </p:blipFill>
-            <p:spPr>
-              <a:xfrm>
-                <a:off x="1280825" y="1001441"/>
-                <a:ext cx="748615" cy="290949"/>
-              </a:xfrm>
-              <a:prstGeom prst="rect">
-                <a:avLst/>
-              </a:prstGeom>
-            </p:spPr>
-          </p:pic>
-        </mc:Fallback>
-      </mc:AlternateContent>
+      <p:pic>
+        <p:nvPicPr>
+          <p:cNvPr id="4" name="Imagen 3" descr="File:Turdus viscivorus Brych y coed.jpg">
+            <a:extLst>
+              <a:ext uri="{FF2B5EF4-FFF2-40B4-BE49-F238E27FC236}">
+                <a16:creationId xmlns:a16="http://schemas.microsoft.com/office/drawing/2014/main" id="{EA7E6FC6-0EA3-8E34-C77E-61CD002FCBE8}"/>
+              </a:ext>
+            </a:extLst>
+          </p:cNvPr>
+          <p:cNvPicPr>
+            <a:picLocks noChangeAspect="1"/>
+          </p:cNvPicPr>
+          <p:nvPr/>
+        </p:nvPicPr>
+        <p:blipFill>
+          <a:blip r:embed="rId3"/>
+          <a:stretch>
+            <a:fillRect/>
+          </a:stretch>
+        </p:blipFill>
+        <p:spPr>
+          <a:xfrm>
+            <a:off x="3161093" y="642158"/>
+            <a:ext cx="4529116" cy="3859184"/>
+          </a:xfrm>
+          <a:prstGeom prst="rect">
+            <a:avLst/>
+          </a:prstGeom>
+        </p:spPr>
+      </p:pic>
     </p:spTree>
     <p:extLst>
       <p:ext uri="{BB962C8B-B14F-4D97-AF65-F5344CB8AC3E}">
@@ -16391,61 +17212,105 @@
           <a:bodyPr/>
           <a:lstStyle/>
           <a:p>
-            <a:endParaRPr lang="es-PR"/>
+            <a:pPr marL="114300" indent="0">
+              <a:buNone/>
+            </a:pPr>
+            <a:r>
+              <a:rPr lang="es-PR" dirty="0">
+                <a:solidFill>
+                  <a:schemeClr val="tx1"/>
+                </a:solidFill>
+              </a:rPr>
+              <a:t>Woodpecker</a:t>
+            </a:r>
+          </a:p>
+          <a:p>
+            <a:pPr marL="114300" indent="0">
+              <a:buNone/>
+            </a:pPr>
+            <a:r>
+              <a:rPr lang="es-PR" dirty="0">
+                <a:solidFill>
+                  <a:schemeClr val="tx1"/>
+                </a:solidFill>
+              </a:rPr>
+              <a:t>Picidae fam.</a:t>
+            </a:r>
+          </a:p>
+          <a:p>
+            <a:pPr marL="114300" indent="0">
+              <a:buNone/>
+            </a:pPr>
+            <a:r>
+              <a:rPr lang="es-PR" dirty="0">
+                <a:solidFill>
+                  <a:schemeClr val="tx1"/>
+                </a:solidFill>
+              </a:rPr>
+              <a:t>Wild</a:t>
+            </a:r>
+          </a:p>
+          <a:p>
+            <a:pPr marL="114300" indent="0">
+              <a:buNone/>
+            </a:pPr>
+            <a:r>
+              <a:rPr lang="es-PR" dirty="0">
+                <a:solidFill>
+                  <a:schemeClr val="tx1"/>
+                </a:solidFill>
+              </a:rPr>
+              <a:t>WA</a:t>
+            </a:r>
+          </a:p>
+          <a:p>
+            <a:pPr marL="114300" indent="0">
+              <a:buNone/>
+            </a:pPr>
+            <a:endParaRPr lang="es-PR" dirty="0">
+              <a:solidFill>
+                <a:schemeClr val="tx1"/>
+              </a:solidFill>
+            </a:endParaRPr>
+          </a:p>
+          <a:p>
+            <a:pPr marL="114300" indent="0">
+              <a:buNone/>
+            </a:pPr>
+            <a:endParaRPr lang="es-PR" dirty="0"/>
           </a:p>
         </p:txBody>
       </p:sp>
-      <mc:AlternateContent xmlns:mc="http://schemas.openxmlformats.org/markup-compatibility/2006" xmlns:p14="http://schemas.microsoft.com/office/powerpoint/2010/main">
-        <mc:Choice Requires="p14">
-          <p:contentPart p14:bwMode="auto" r:id="rId2">
-            <p14:nvContentPartPr>
-              <p14:cNvPr id="14" name="Entrada de lápiz 13">
-                <a:extLst>
-                  <a:ext uri="{FF2B5EF4-FFF2-40B4-BE49-F238E27FC236}">
-                    <a16:creationId xmlns:a16="http://schemas.microsoft.com/office/drawing/2014/main" id="{8B8BDDD1-D030-14F9-8938-E70D5A97E6F8}"/>
-                  </a:ext>
-                </a:extLst>
-              </p14:cNvPr>
-              <p14:cNvContentPartPr/>
-              <p14:nvPr/>
-            </p14:nvContentPartPr>
-            <p14:xfrm>
-              <a:off x="1021217" y="980506"/>
-              <a:ext cx="1848690" cy="400410"/>
-            </p14:xfrm>
-          </p:contentPart>
-        </mc:Choice>
-        <mc:Fallback xmlns="">
-          <p:pic>
-            <p:nvPicPr>
-              <p:cNvPr id="14" name="Entrada de lápiz 13">
-                <a:extLst>
-                  <a:ext uri="{FF2B5EF4-FFF2-40B4-BE49-F238E27FC236}">
-                    <a16:creationId xmlns:a16="http://schemas.microsoft.com/office/drawing/2014/main" id="{8B8BDDD1-D030-14F9-8938-E70D5A97E6F8}"/>
-                  </a:ext>
-                </a:extLst>
-              </p:cNvPr>
-              <p:cNvPicPr/>
-              <p:nvPr/>
-            </p:nvPicPr>
-            <p:blipFill>
-              <a:blip r:embed="rId3"/>
-              <a:stretch>
-                <a:fillRect/>
-              </a:stretch>
-            </p:blipFill>
-            <p:spPr>
-              <a:xfrm>
-                <a:off x="1010419" y="969713"/>
-                <a:ext cx="1869927" cy="421636"/>
-              </a:xfrm>
-              <a:prstGeom prst="rect">
-                <a:avLst/>
-              </a:prstGeom>
-            </p:spPr>
-          </p:pic>
-        </mc:Fallback>
-      </mc:AlternateContent>
+      <p:pic>
+        <p:nvPicPr>
+          <p:cNvPr id="6" name="Imagen 5" descr="File:Acorn woodpecker holding a nut in its beak-0225.jpg">
+            <a:extLst>
+              <a:ext uri="{FF2B5EF4-FFF2-40B4-BE49-F238E27FC236}">
+                <a16:creationId xmlns:a16="http://schemas.microsoft.com/office/drawing/2014/main" id="{08919D99-6D40-74F0-797C-9C99AE10DC46}"/>
+              </a:ext>
+            </a:extLst>
+          </p:cNvPr>
+          <p:cNvPicPr>
+            <a:picLocks noChangeAspect="1"/>
+          </p:cNvPicPr>
+          <p:nvPr/>
+        </p:nvPicPr>
+        <p:blipFill>
+          <a:blip r:embed="rId3"/>
+          <a:stretch>
+            <a:fillRect/>
+          </a:stretch>
+        </p:blipFill>
+        <p:spPr>
+          <a:xfrm>
+            <a:off x="3607723" y="383944"/>
+            <a:ext cx="4375612" cy="4375612"/>
+          </a:xfrm>
+          <a:prstGeom prst="rect">
+            <a:avLst/>
+          </a:prstGeom>
+        </p:spPr>
+      </p:pic>
     </p:spTree>
     <p:extLst>
       <p:ext uri="{BB962C8B-B14F-4D97-AF65-F5344CB8AC3E}">
@@ -16524,112 +17389,117 @@
           <a:bodyPr/>
           <a:lstStyle/>
           <a:p>
-            <a:endParaRPr lang="es-PR"/>
+            <a:pPr marL="114300" indent="0">
+              <a:buNone/>
+            </a:pPr>
+            <a:r>
+              <a:rPr lang="es-PR" dirty="0">
+                <a:solidFill>
+                  <a:schemeClr val="tx1"/>
+                </a:solidFill>
+              </a:rPr>
+              <a:t>Great blue heron</a:t>
+            </a:r>
+          </a:p>
+          <a:p>
+            <a:pPr marL="114300" indent="0">
+              <a:buNone/>
+            </a:pPr>
+            <a:r>
+              <a:rPr lang="es-US" i="1" dirty="0">
+                <a:solidFill>
+                  <a:schemeClr val="tx1"/>
+                </a:solidFill>
+              </a:rPr>
+              <a:t>Ardea </a:t>
+            </a:r>
+            <a:r>
+              <a:rPr lang="es-US" i="1" dirty="0" err="1">
+                <a:solidFill>
+                  <a:schemeClr val="tx1"/>
+                </a:solidFill>
+              </a:rPr>
+              <a:t>herodias</a:t>
+            </a:r>
+            <a:endParaRPr lang="es-US" i="1" dirty="0">
+              <a:solidFill>
+                <a:schemeClr val="tx1"/>
+              </a:solidFill>
+            </a:endParaRPr>
+          </a:p>
+          <a:p>
+            <a:pPr marL="114300" indent="0">
+              <a:buNone/>
+            </a:pPr>
+            <a:r>
+              <a:rPr lang="es-US" dirty="0">
+                <a:solidFill>
+                  <a:schemeClr val="tx1"/>
+                </a:solidFill>
+              </a:rPr>
+              <a:t>Wild</a:t>
+            </a:r>
+          </a:p>
+          <a:p>
+            <a:pPr marL="114300" indent="0">
+              <a:buNone/>
+            </a:pPr>
+            <a:r>
+              <a:rPr lang="es-US" dirty="0">
+                <a:solidFill>
+                  <a:schemeClr val="tx1"/>
+                </a:solidFill>
+              </a:rPr>
+              <a:t>WA</a:t>
+            </a:r>
+            <a:endParaRPr lang="es-PR" dirty="0">
+              <a:solidFill>
+                <a:schemeClr val="tx1"/>
+              </a:solidFill>
+            </a:endParaRPr>
+          </a:p>
+          <a:p>
+            <a:pPr marL="114300" indent="0">
+              <a:buNone/>
+            </a:pPr>
+            <a:endParaRPr lang="es-PR" dirty="0">
+              <a:solidFill>
+                <a:schemeClr val="tx1"/>
+              </a:solidFill>
+            </a:endParaRPr>
           </a:p>
         </p:txBody>
       </p:sp>
-      <mc:AlternateContent xmlns:mc="http://schemas.openxmlformats.org/markup-compatibility/2006" xmlns:p14="http://schemas.microsoft.com/office/powerpoint/2010/main">
-        <mc:Choice Requires="p14">
-          <p:contentPart p14:bwMode="auto" r:id="rId2">
-            <p14:nvContentPartPr>
-              <p14:cNvPr id="15" name="Entrada de lápiz 14">
-                <a:extLst>
-                  <a:ext uri="{FF2B5EF4-FFF2-40B4-BE49-F238E27FC236}">
-                    <a16:creationId xmlns:a16="http://schemas.microsoft.com/office/drawing/2014/main" id="{205C2A23-DE50-9100-BF68-158D619416F7}"/>
-                  </a:ext>
-                </a:extLst>
-              </p14:cNvPr>
-              <p14:cNvContentPartPr/>
-              <p14:nvPr/>
-            </p14:nvContentPartPr>
-            <p14:xfrm>
-              <a:off x="1647198" y="961740"/>
-              <a:ext cx="1053000" cy="277560"/>
-            </p14:xfrm>
-          </p:contentPart>
-        </mc:Choice>
-        <mc:Fallback xmlns="">
-          <p:pic>
-            <p:nvPicPr>
-              <p:cNvPr id="15" name="Entrada de lápiz 14">
-                <a:extLst>
-                  <a:ext uri="{FF2B5EF4-FFF2-40B4-BE49-F238E27FC236}">
-                    <a16:creationId xmlns:a16="http://schemas.microsoft.com/office/drawing/2014/main" id="{205C2A23-DE50-9100-BF68-158D619416F7}"/>
-                  </a:ext>
-                </a:extLst>
-              </p:cNvPr>
-              <p:cNvPicPr/>
-              <p:nvPr/>
-            </p:nvPicPr>
-            <p:blipFill>
-              <a:blip r:embed="rId3"/>
-              <a:stretch>
-                <a:fillRect/>
-              </a:stretch>
-            </p:blipFill>
-            <p:spPr>
-              <a:xfrm>
-                <a:off x="1636398" y="950940"/>
-                <a:ext cx="1074240" cy="298800"/>
-              </a:xfrm>
-              <a:prstGeom prst="rect">
-                <a:avLst/>
-              </a:prstGeom>
-            </p:spPr>
-          </p:pic>
-        </mc:Fallback>
-      </mc:AlternateContent>
-      <mc:AlternateContent xmlns:mc="http://schemas.openxmlformats.org/markup-compatibility/2006" xmlns:p14="http://schemas.microsoft.com/office/powerpoint/2010/main">
-        <mc:Choice Requires="p14">
-          <p:contentPart p14:bwMode="auto" r:id="rId4">
-            <p14:nvContentPartPr>
-              <p14:cNvPr id="16" name="Entrada de lápiz 15">
-                <a:extLst>
-                  <a:ext uri="{FF2B5EF4-FFF2-40B4-BE49-F238E27FC236}">
-                    <a16:creationId xmlns:a16="http://schemas.microsoft.com/office/drawing/2014/main" id="{D08FDD27-DF1E-F96D-1262-B90544922F1A}"/>
-                  </a:ext>
-                </a:extLst>
-              </p14:cNvPr>
-              <p14:cNvContentPartPr/>
-              <p14:nvPr/>
-            </p14:nvContentPartPr>
-            <p14:xfrm>
-              <a:off x="919548" y="1017900"/>
-              <a:ext cx="549450" cy="377190"/>
-            </p14:xfrm>
-          </p:contentPart>
-        </mc:Choice>
-        <mc:Fallback xmlns="">
-          <p:pic>
-            <p:nvPicPr>
-              <p:cNvPr id="16" name="Entrada de lápiz 15">
-                <a:extLst>
-                  <a:ext uri="{FF2B5EF4-FFF2-40B4-BE49-F238E27FC236}">
-                    <a16:creationId xmlns:a16="http://schemas.microsoft.com/office/drawing/2014/main" id="{D08FDD27-DF1E-F96D-1262-B90544922F1A}"/>
-                  </a:ext>
-                </a:extLst>
-              </p:cNvPr>
-              <p:cNvPicPr/>
-              <p:nvPr/>
-            </p:nvPicPr>
-            <p:blipFill>
-              <a:blip r:embed="rId5"/>
-              <a:stretch>
-                <a:fillRect/>
-              </a:stretch>
-            </p:blipFill>
-            <p:spPr>
-              <a:xfrm>
-                <a:off x="908753" y="1007092"/>
-                <a:ext cx="570680" cy="398445"/>
-              </a:xfrm>
-              <a:prstGeom prst="rect">
-                <a:avLst/>
-              </a:prstGeom>
-            </p:spPr>
-          </p:pic>
-        </mc:Fallback>
-      </mc:AlternateContent>
+      <p:pic>
+        <p:nvPicPr>
+          <p:cNvPr id="4" name="Imagen 3" descr="File:Great blue heron in GWC (16570).jpg">
+            <a:extLst>
+              <a:ext uri="{FF2B5EF4-FFF2-40B4-BE49-F238E27FC236}">
+                <a16:creationId xmlns:a16="http://schemas.microsoft.com/office/drawing/2014/main" id="{6F960663-F10E-ECE0-7A44-554BCC1E5612}"/>
+              </a:ext>
+            </a:extLst>
+          </p:cNvPr>
+          <p:cNvPicPr>
+            <a:picLocks noChangeAspect="1"/>
+          </p:cNvPicPr>
+          <p:nvPr/>
+        </p:nvPicPr>
+        <p:blipFill>
+          <a:blip r:embed="rId3"/>
+          <a:stretch>
+            <a:fillRect/>
+          </a:stretch>
+        </p:blipFill>
+        <p:spPr>
+          <a:xfrm>
+            <a:off x="3535410" y="287312"/>
+            <a:ext cx="3379345" cy="4568875"/>
+          </a:xfrm>
+          <a:prstGeom prst="rect">
+            <a:avLst/>
+          </a:prstGeom>
+        </p:spPr>
+      </p:pic>
     </p:spTree>
     <p:extLst>
       <p:ext uri="{BB962C8B-B14F-4D97-AF65-F5344CB8AC3E}">

</xml_diff>